<commit_message>
Clarify heartbeat communication improvement
</commit_message>
<xml_diff>
--- a/docs/Wait_Less_Software_Section.pptx
+++ b/docs/Wait_Less_Software_Section.pptx
@@ -2,20 +2,20 @@
 <file path=ppt/presentation.xml><?xml version="1.0" encoding="utf-8"?>
 <p:presentation xmlns:p="http://schemas.openxmlformats.org/presentationml/2006/main">
   <p:sldMasterIdLst>
-    <p:sldMasterId xmlns:r="http://schemas.openxmlformats.org/officeDocument/2006/relationships" id="2147483648" r:id="R903fa09b289b42a3"/>
+    <p:sldMasterId xmlns:r="http://schemas.openxmlformats.org/officeDocument/2006/relationships" id="2147483648" r:id="R18f19e27237f41d9"/>
   </p:sldMasterIdLst>
   <p:notesMasterIdLst>
-    <p:notesMasterId xmlns:r="http://schemas.openxmlformats.org/officeDocument/2006/relationships" r:id="R2f69bf9632b242bb"/>
+    <p:notesMasterId xmlns:r="http://schemas.openxmlformats.org/officeDocument/2006/relationships" r:id="R6e25b6c210eb4545"/>
   </p:notesMasterIdLst>
   <p:sldIdLst>
-    <p:sldId xmlns:r="http://schemas.openxmlformats.org/officeDocument/2006/relationships" id="256" r:id="R7a2c8a9fd79b4f58"/>
-    <p:sldId xmlns:r="http://schemas.openxmlformats.org/officeDocument/2006/relationships" id="257" r:id="R3b42d928113b4c4e"/>
-    <p:sldId xmlns:r="http://schemas.openxmlformats.org/officeDocument/2006/relationships" id="258" r:id="Rdec1c92f6c5448c5"/>
-    <p:sldId xmlns:r="http://schemas.openxmlformats.org/officeDocument/2006/relationships" id="259" r:id="Rdc13c74c5e634bfb"/>
-    <p:sldId xmlns:r="http://schemas.openxmlformats.org/officeDocument/2006/relationships" id="260" r:id="Rfba631281e624437"/>
-    <p:sldId xmlns:r="http://schemas.openxmlformats.org/officeDocument/2006/relationships" id="261" r:id="R8423aee80b98476f"/>
-    <p:sldId xmlns:r="http://schemas.openxmlformats.org/officeDocument/2006/relationships" id="262" r:id="Rfcbda9a2690d445e"/>
-    <p:sldId xmlns:r="http://schemas.openxmlformats.org/officeDocument/2006/relationships" id="263" r:id="R06bc6bb082d84344"/>
+    <p:sldId xmlns:r="http://schemas.openxmlformats.org/officeDocument/2006/relationships" id="256" r:id="R740324943ed2445f"/>
+    <p:sldId xmlns:r="http://schemas.openxmlformats.org/officeDocument/2006/relationships" id="257" r:id="Rd452b60a0eb24373"/>
+    <p:sldId xmlns:r="http://schemas.openxmlformats.org/officeDocument/2006/relationships" id="258" r:id="Ra318ce6065a84660"/>
+    <p:sldId xmlns:r="http://schemas.openxmlformats.org/officeDocument/2006/relationships" id="259" r:id="Rb1da4185239d454f"/>
+    <p:sldId xmlns:r="http://schemas.openxmlformats.org/officeDocument/2006/relationships" id="260" r:id="R8dcaffcd2bb64aeb"/>
+    <p:sldId xmlns:r="http://schemas.openxmlformats.org/officeDocument/2006/relationships" id="261" r:id="R0c49fc651693455f"/>
+    <p:sldId xmlns:r="http://schemas.openxmlformats.org/officeDocument/2006/relationships" id="262" r:id="R4b639ba7eace482d"/>
+    <p:sldId xmlns:r="http://schemas.openxmlformats.org/officeDocument/2006/relationships" id="263" r:id="Ra99bf7f90ae04cf5"/>
   </p:sldIdLst>
   <p:sldSz cx="12192000" cy="6858000"/>
   <p:notesSz cx="6858000" cy="9144000"/>
@@ -1024,7 +1024,7 @@
   </p:cSld>
   <p:clrMap bg1="lt1" tx1="dk1" bg2="lt2" tx2="dk2" accent1="accent1" accent2="accent2" accent3="accent3" accent4="accent4" accent5="accent5" accent6="accent6" hlink="hlink" folHlink="folHlink"/>
   <p:sldLayoutIdLst>
-    <p:sldLayoutId xmlns:r="http://schemas.openxmlformats.org/officeDocument/2006/relationships" id="2147483649" r:id="R8bd75353aed2446b"/>
+    <p:sldLayoutId xmlns:r="http://schemas.openxmlformats.org/officeDocument/2006/relationships" id="2147483649" r:id="Rc8797d685b834e0a"/>
   </p:sldLayoutIdLst>
   <p:txStyles>
     <p:titleStyle>
@@ -1323,7 +1323,7 @@
           <p:cNvPr id="1" name="">
             <a:extLst xmlns:a="http://schemas.openxmlformats.org/drawingml/2006/main">
               <a:ext uri="{FF2B5EF4-FFF2-40B4-BE49-F238E27FC236}">
-                <a16:creationId xmlns:a16="http://schemas.microsoft.com/office/drawing/2014/main" id="{DE7B91E7-AA27-4BCE-A7CD-621641B4E39C}"/>
+                <a16:creationId xmlns:a16="http://schemas.microsoft.com/office/drawing/2014/main" id="{C68D62E3-5F71-4251-8F2B-BB1E71392882}"/>
               </a:ext>
             </a:extLst>
           </p:cNvPr>
@@ -1358,7 +1358,7 @@
           <p:cNvPr id="2" name="">
             <a:extLst xmlns:a="http://schemas.openxmlformats.org/drawingml/2006/main">
               <a:ext uri="{FF2B5EF4-FFF2-40B4-BE49-F238E27FC236}">
-                <a16:creationId xmlns:a16="http://schemas.microsoft.com/office/drawing/2014/main" id="{80A5993F-8441-4CC3-BD02-76F2618705B6}"/>
+                <a16:creationId xmlns:a16="http://schemas.microsoft.com/office/drawing/2014/main" id="{15E96E55-7DFE-4C24-B3B1-346EC4668409}"/>
               </a:ext>
             </a:extLst>
           </p:cNvPr>
@@ -1393,7 +1393,7 @@
           <p:cNvPr id="3" name="">
             <a:extLst xmlns:a="http://schemas.openxmlformats.org/drawingml/2006/main">
               <a:ext uri="{FF2B5EF4-FFF2-40B4-BE49-F238E27FC236}">
-                <a16:creationId xmlns:a16="http://schemas.microsoft.com/office/drawing/2014/main" id="{136472DD-3B8D-4B23-9CB0-EF7FDCC7EDB5}"/>
+                <a16:creationId xmlns:a16="http://schemas.microsoft.com/office/drawing/2014/main" id="{4A4C6EA1-1FE2-4DC9-88D3-821C267A1BE4}"/>
               </a:ext>
             </a:extLst>
           </p:cNvPr>
@@ -1428,7 +1428,7 @@
           <p:cNvPr id="4" name="">
             <a:extLst xmlns:a="http://schemas.openxmlformats.org/drawingml/2006/main">
               <a:ext uri="{FF2B5EF4-FFF2-40B4-BE49-F238E27FC236}">
-                <a16:creationId xmlns:a16="http://schemas.microsoft.com/office/drawing/2014/main" id="{C3FB4E51-8A20-41EB-87F3-A62E0CCDD6BB}"/>
+                <a16:creationId xmlns:a16="http://schemas.microsoft.com/office/drawing/2014/main" id="{6C61FAD8-7240-4A3E-982B-351E2A82AFB6}"/>
               </a:ext>
             </a:extLst>
           </p:cNvPr>
@@ -1492,7 +1492,7 @@
           <p:cNvPr id="5" name="">
             <a:extLst xmlns:a="http://schemas.openxmlformats.org/drawingml/2006/main">
               <a:ext uri="{FF2B5EF4-FFF2-40B4-BE49-F238E27FC236}">
-                <a16:creationId xmlns:a16="http://schemas.microsoft.com/office/drawing/2014/main" id="{24087F4B-65BC-49A2-8E80-D44A79719F9B}"/>
+                <a16:creationId xmlns:a16="http://schemas.microsoft.com/office/drawing/2014/main" id="{9B007589-CC12-4546-80BC-FAFCD745084E}"/>
               </a:ext>
             </a:extLst>
           </p:cNvPr>
@@ -1527,7 +1527,7 @@
           <p:cNvPr id="6" name="">
             <a:extLst xmlns:a="http://schemas.openxmlformats.org/drawingml/2006/main">
               <a:ext uri="{FF2B5EF4-FFF2-40B4-BE49-F238E27FC236}">
-                <a16:creationId xmlns:a16="http://schemas.microsoft.com/office/drawing/2014/main" id="{D3E49700-7914-48E3-8D88-838365DAF058}"/>
+                <a16:creationId xmlns:a16="http://schemas.microsoft.com/office/drawing/2014/main" id="{26DAA955-72C4-45B3-97A6-9F5ECAB130A4}"/>
               </a:ext>
             </a:extLst>
           </p:cNvPr>
@@ -1562,7 +1562,7 @@
           <p:cNvPr id="7" name="">
             <a:extLst xmlns:a="http://schemas.openxmlformats.org/drawingml/2006/main">
               <a:ext uri="{FF2B5EF4-FFF2-40B4-BE49-F238E27FC236}">
-                <a16:creationId xmlns:a16="http://schemas.microsoft.com/office/drawing/2014/main" id="{67FF6A57-9EEB-42C4-B2BB-7C57634A78D3}"/>
+                <a16:creationId xmlns:a16="http://schemas.microsoft.com/office/drawing/2014/main" id="{BD1CEB3E-29A1-4656-AB06-24A4EBEE6380}"/>
               </a:ext>
             </a:extLst>
           </p:cNvPr>
@@ -1597,7 +1597,7 @@
           <p:cNvPr id="8" name="">
             <a:extLst xmlns:a="http://schemas.openxmlformats.org/drawingml/2006/main">
               <a:ext uri="{FF2B5EF4-FFF2-40B4-BE49-F238E27FC236}">
-                <a16:creationId xmlns:a16="http://schemas.microsoft.com/office/drawing/2014/main" id="{16710B9C-020F-4FC9-958E-C6CBFEBBBF24}"/>
+                <a16:creationId xmlns:a16="http://schemas.microsoft.com/office/drawing/2014/main" id="{E80CD19B-9CFF-4766-94BA-FA49A11FB8E2}"/>
               </a:ext>
             </a:extLst>
           </p:cNvPr>
@@ -1661,7 +1661,7 @@
           <p:cNvPr id="9" name="">
             <a:extLst xmlns:a="http://schemas.openxmlformats.org/drawingml/2006/main">
               <a:ext uri="{FF2B5EF4-FFF2-40B4-BE49-F238E27FC236}">
-                <a16:creationId xmlns:a16="http://schemas.microsoft.com/office/drawing/2014/main" id="{5ADCCC68-B9A8-49AC-A623-F9C62A98FCB4}"/>
+                <a16:creationId xmlns:a16="http://schemas.microsoft.com/office/drawing/2014/main" id="{25814B34-568D-4908-86C8-5040182171B9}"/>
               </a:ext>
             </a:extLst>
           </p:cNvPr>
@@ -1725,7 +1725,7 @@
           <p:cNvPr id="10" name="">
             <a:extLst xmlns:a="http://schemas.openxmlformats.org/drawingml/2006/main">
               <a:ext uri="{FF2B5EF4-FFF2-40B4-BE49-F238E27FC236}">
-                <a16:creationId xmlns:a16="http://schemas.microsoft.com/office/drawing/2014/main" id="{B80C155E-292E-46FF-8F6B-D38AC094F204}"/>
+                <a16:creationId xmlns:a16="http://schemas.microsoft.com/office/drawing/2014/main" id="{E4DC3864-E385-4729-B396-9D2C9F9C1DE2}"/>
               </a:ext>
             </a:extLst>
           </p:cNvPr>
@@ -1789,7 +1789,7 @@
           <p:cNvPr id="11" name="">
             <a:extLst xmlns:a="http://schemas.openxmlformats.org/drawingml/2006/main">
               <a:ext uri="{FF2B5EF4-FFF2-40B4-BE49-F238E27FC236}">
-                <a16:creationId xmlns:a16="http://schemas.microsoft.com/office/drawing/2014/main" id="{CA266E85-33E6-4A26-82B1-C2F1BE964D13}"/>
+                <a16:creationId xmlns:a16="http://schemas.microsoft.com/office/drawing/2014/main" id="{0328C7D5-2C08-4A05-8835-53D66EAAC2F7}"/>
               </a:ext>
             </a:extLst>
           </p:cNvPr>
@@ -1853,7 +1853,7 @@
           <p:cNvPr id="12" name="">
             <a:extLst xmlns:a="http://schemas.openxmlformats.org/drawingml/2006/main">
               <a:ext uri="{FF2B5EF4-FFF2-40B4-BE49-F238E27FC236}">
-                <a16:creationId xmlns:a16="http://schemas.microsoft.com/office/drawing/2014/main" id="{A5381B18-15F4-44E9-8392-7E0BC04C93B0}"/>
+                <a16:creationId xmlns:a16="http://schemas.microsoft.com/office/drawing/2014/main" id="{8AF10A90-15D2-41F5-A219-4F2C92EC7917}"/>
               </a:ext>
             </a:extLst>
           </p:cNvPr>
@@ -1886,7 +1886,7 @@
           <p:cNvPr id="13" name="">
             <a:extLst xmlns:a="http://schemas.openxmlformats.org/drawingml/2006/main">
               <a:ext uri="{FF2B5EF4-FFF2-40B4-BE49-F238E27FC236}">
-                <a16:creationId xmlns:a16="http://schemas.microsoft.com/office/drawing/2014/main" id="{5949A971-DF22-4BF5-BD2F-C17CBE2709EF}"/>
+                <a16:creationId xmlns:a16="http://schemas.microsoft.com/office/drawing/2014/main" id="{1353C855-1B38-4676-A6EC-43DB9F1A7D13}"/>
               </a:ext>
             </a:extLst>
           </p:cNvPr>
@@ -1950,7 +1950,7 @@
           <p:cNvPr id="14" name="">
             <a:extLst xmlns:a="http://schemas.openxmlformats.org/drawingml/2006/main">
               <a:ext uri="{FF2B5EF4-FFF2-40B4-BE49-F238E27FC236}">
-                <a16:creationId xmlns:a16="http://schemas.microsoft.com/office/drawing/2014/main" id="{3CAB79B9-D239-45AB-B2C5-AB8CE57B28A5}"/>
+                <a16:creationId xmlns:a16="http://schemas.microsoft.com/office/drawing/2014/main" id="{33501DFF-AA4C-4B37-8263-23EA0ECA1105}"/>
               </a:ext>
             </a:extLst>
           </p:cNvPr>
@@ -2037,7 +2037,7 @@
           <p:cNvPr id="15" name="">
             <a:extLst xmlns:a="http://schemas.openxmlformats.org/drawingml/2006/main">
               <a:ext uri="{FF2B5EF4-FFF2-40B4-BE49-F238E27FC236}">
-                <a16:creationId xmlns:a16="http://schemas.microsoft.com/office/drawing/2014/main" id="{ABE996EF-11E8-41D6-96C6-C030A0817935}"/>
+                <a16:creationId xmlns:a16="http://schemas.microsoft.com/office/drawing/2014/main" id="{DF5FB112-5CBB-4F07-BF13-E55315DAB448}"/>
               </a:ext>
             </a:extLst>
           </p:cNvPr>
@@ -2101,7 +2101,7 @@
           <p:cNvPr id="16" name="">
             <a:extLst xmlns:a="http://schemas.openxmlformats.org/drawingml/2006/main">
               <a:ext uri="{FF2B5EF4-FFF2-40B4-BE49-F238E27FC236}">
-                <a16:creationId xmlns:a16="http://schemas.microsoft.com/office/drawing/2014/main" id="{2091FCBE-4CAB-4D2F-9DB7-E6312EFD8448}"/>
+                <a16:creationId xmlns:a16="http://schemas.microsoft.com/office/drawing/2014/main" id="{EBE4A8DF-6099-449C-B459-0F668E5828F3}"/>
               </a:ext>
             </a:extLst>
           </p:cNvPr>
@@ -2134,7 +2134,7 @@
           <p:cNvPr id="17" name="">
             <a:extLst xmlns:a="http://schemas.openxmlformats.org/drawingml/2006/main">
               <a:ext uri="{FF2B5EF4-FFF2-40B4-BE49-F238E27FC236}">
-                <a16:creationId xmlns:a16="http://schemas.microsoft.com/office/drawing/2014/main" id="{C368D319-F6F7-436F-84F7-FCB626D333B3}"/>
+                <a16:creationId xmlns:a16="http://schemas.microsoft.com/office/drawing/2014/main" id="{630B90D1-AA72-4576-A4B4-4999E0E8EB96}"/>
               </a:ext>
             </a:extLst>
           </p:cNvPr>
@@ -2198,7 +2198,7 @@
           <p:cNvPr id="18" name="">
             <a:extLst xmlns:a="http://schemas.openxmlformats.org/drawingml/2006/main">
               <a:ext uri="{FF2B5EF4-FFF2-40B4-BE49-F238E27FC236}">
-                <a16:creationId xmlns:a16="http://schemas.microsoft.com/office/drawing/2014/main" id="{E7730702-1146-4900-8AF9-2FC64B0F02E4}"/>
+                <a16:creationId xmlns:a16="http://schemas.microsoft.com/office/drawing/2014/main" id="{12FCDBF2-5B9B-4222-B815-54317F11D6E4}"/>
               </a:ext>
             </a:extLst>
           </p:cNvPr>
@@ -2285,7 +2285,7 @@
           <p:cNvPr id="19" name="">
             <a:extLst xmlns:a="http://schemas.openxmlformats.org/drawingml/2006/main">
               <a:ext uri="{FF2B5EF4-FFF2-40B4-BE49-F238E27FC236}">
-                <a16:creationId xmlns:a16="http://schemas.microsoft.com/office/drawing/2014/main" id="{444A2E83-8D9F-4073-AB9D-98A799EA3CE4}"/>
+                <a16:creationId xmlns:a16="http://schemas.microsoft.com/office/drawing/2014/main" id="{C68D703F-73B0-46EC-B6C6-191CDA1FB013}"/>
               </a:ext>
             </a:extLst>
           </p:cNvPr>
@@ -2349,7 +2349,7 @@
           <p:cNvPr id="20" name="">
             <a:extLst xmlns:a="http://schemas.openxmlformats.org/drawingml/2006/main">
               <a:ext uri="{FF2B5EF4-FFF2-40B4-BE49-F238E27FC236}">
-                <a16:creationId xmlns:a16="http://schemas.microsoft.com/office/drawing/2014/main" id="{A4782212-4B15-4C0A-97F6-C2F2DF66972B}"/>
+                <a16:creationId xmlns:a16="http://schemas.microsoft.com/office/drawing/2014/main" id="{9E738D12-3597-4B0E-81C5-1A4920A42E55}"/>
               </a:ext>
             </a:extLst>
           </p:cNvPr>
@@ -2382,7 +2382,7 @@
           <p:cNvPr id="21" name="">
             <a:extLst xmlns:a="http://schemas.openxmlformats.org/drawingml/2006/main">
               <a:ext uri="{FF2B5EF4-FFF2-40B4-BE49-F238E27FC236}">
-                <a16:creationId xmlns:a16="http://schemas.microsoft.com/office/drawing/2014/main" id="{020F29BE-239F-4B2A-8205-B2550D4C1D5A}"/>
+                <a16:creationId xmlns:a16="http://schemas.microsoft.com/office/drawing/2014/main" id="{097D15AD-FA89-479C-9A95-5C413548CD2B}"/>
               </a:ext>
             </a:extLst>
           </p:cNvPr>
@@ -2446,7 +2446,7 @@
           <p:cNvPr id="22" name="">
             <a:extLst xmlns:a="http://schemas.openxmlformats.org/drawingml/2006/main">
               <a:ext uri="{FF2B5EF4-FFF2-40B4-BE49-F238E27FC236}">
-                <a16:creationId xmlns:a16="http://schemas.microsoft.com/office/drawing/2014/main" id="{C37D18D8-4211-43F6-848C-12BEBA0B4B7D}"/>
+                <a16:creationId xmlns:a16="http://schemas.microsoft.com/office/drawing/2014/main" id="{121D664A-31C8-45D3-A9E6-CA71216A25C4}"/>
               </a:ext>
             </a:extLst>
           </p:cNvPr>
@@ -2533,7 +2533,7 @@
           <p:cNvPr id="23" name="">
             <a:extLst xmlns:a="http://schemas.openxmlformats.org/drawingml/2006/main">
               <a:ext uri="{FF2B5EF4-FFF2-40B4-BE49-F238E27FC236}">
-                <a16:creationId xmlns:a16="http://schemas.microsoft.com/office/drawing/2014/main" id="{7D46DDD7-9D75-44F1-9475-C969AD369AB6}"/>
+                <a16:creationId xmlns:a16="http://schemas.microsoft.com/office/drawing/2014/main" id="{DDB39B14-7FB9-42F6-8103-EC28E48C7031}"/>
               </a:ext>
             </a:extLst>
           </p:cNvPr>
@@ -2597,7 +2597,7 @@
           <p:cNvPr id="24" name="">
             <a:extLst xmlns:a="http://schemas.openxmlformats.org/drawingml/2006/main">
               <a:ext uri="{FF2B5EF4-FFF2-40B4-BE49-F238E27FC236}">
-                <a16:creationId xmlns:a16="http://schemas.microsoft.com/office/drawing/2014/main" id="{91416B3D-9F63-46D8-8174-4145661D255B}"/>
+                <a16:creationId xmlns:a16="http://schemas.microsoft.com/office/drawing/2014/main" id="{1D7DAE8E-C69D-4A5E-AA38-7123219DA8A7}"/>
               </a:ext>
             </a:extLst>
           </p:cNvPr>
@@ -2630,7 +2630,7 @@
           <p:cNvPr id="25" name="">
             <a:extLst xmlns:a="http://schemas.openxmlformats.org/drawingml/2006/main">
               <a:ext uri="{FF2B5EF4-FFF2-40B4-BE49-F238E27FC236}">
-                <a16:creationId xmlns:a16="http://schemas.microsoft.com/office/drawing/2014/main" id="{07BFAC1E-440A-4567-BDA7-6ECBF892E53B}"/>
+                <a16:creationId xmlns:a16="http://schemas.microsoft.com/office/drawing/2014/main" id="{969AD8FD-6EB4-4818-BF2B-C839976D35FF}"/>
               </a:ext>
             </a:extLst>
           </p:cNvPr>
@@ -2694,7 +2694,7 @@
           <p:cNvPr id="26" name="">
             <a:extLst xmlns:a="http://schemas.openxmlformats.org/drawingml/2006/main">
               <a:ext uri="{FF2B5EF4-FFF2-40B4-BE49-F238E27FC236}">
-                <a16:creationId xmlns:a16="http://schemas.microsoft.com/office/drawing/2014/main" id="{119AD964-4996-4CBB-A066-1753A244121D}"/>
+                <a16:creationId xmlns:a16="http://schemas.microsoft.com/office/drawing/2014/main" id="{784DD375-F9D2-4E45-B20C-0DC25285B5AD}"/>
               </a:ext>
             </a:extLst>
           </p:cNvPr>
@@ -2781,7 +2781,7 @@
           <p:cNvPr id="27" name="">
             <a:extLst xmlns:a="http://schemas.openxmlformats.org/drawingml/2006/main">
               <a:ext uri="{FF2B5EF4-FFF2-40B4-BE49-F238E27FC236}">
-                <a16:creationId xmlns:a16="http://schemas.microsoft.com/office/drawing/2014/main" id="{E210D8F7-3EB9-4137-BF14-636B6CA6ADC3}"/>
+                <a16:creationId xmlns:a16="http://schemas.microsoft.com/office/drawing/2014/main" id="{6EE0F576-67CC-40E1-9AAE-06251B9C67D8}"/>
               </a:ext>
             </a:extLst>
           </p:cNvPr>
@@ -2845,7 +2845,7 @@
           <p:cNvPr id="28" name="">
             <a:extLst xmlns:a="http://schemas.openxmlformats.org/drawingml/2006/main">
               <a:ext uri="{FF2B5EF4-FFF2-40B4-BE49-F238E27FC236}">
-                <a16:creationId xmlns:a16="http://schemas.microsoft.com/office/drawing/2014/main" id="{65796BC2-DA25-4B5C-9BCE-2207BC2C39FF}"/>
+                <a16:creationId xmlns:a16="http://schemas.microsoft.com/office/drawing/2014/main" id="{232F93EF-7264-4A92-A8D1-F3D7476AF2F3}"/>
               </a:ext>
             </a:extLst>
           </p:cNvPr>
@@ -2878,7 +2878,7 @@
           <p:cNvPr id="29" name="">
             <a:extLst xmlns:a="http://schemas.openxmlformats.org/drawingml/2006/main">
               <a:ext uri="{FF2B5EF4-FFF2-40B4-BE49-F238E27FC236}">
-                <a16:creationId xmlns:a16="http://schemas.microsoft.com/office/drawing/2014/main" id="{6F7A20D9-E5D3-4936-A622-82BE6043F0E1}"/>
+                <a16:creationId xmlns:a16="http://schemas.microsoft.com/office/drawing/2014/main" id="{1DA40956-8E85-4C05-8050-94FE41D8E2E0}"/>
               </a:ext>
             </a:extLst>
           </p:cNvPr>
@@ -2942,7 +2942,7 @@
           <p:cNvPr id="30" name="">
             <a:extLst xmlns:a="http://schemas.openxmlformats.org/drawingml/2006/main">
               <a:ext uri="{FF2B5EF4-FFF2-40B4-BE49-F238E27FC236}">
-                <a16:creationId xmlns:a16="http://schemas.microsoft.com/office/drawing/2014/main" id="{1146F9A9-7D1F-4097-9883-9A74CE1EE639}"/>
+                <a16:creationId xmlns:a16="http://schemas.microsoft.com/office/drawing/2014/main" id="{9ACBA6C5-FD73-4785-856A-9693B2E129FC}"/>
               </a:ext>
             </a:extLst>
           </p:cNvPr>
@@ -3029,7 +3029,7 @@
           <p:cNvPr id="31" name="">
             <a:extLst xmlns:a="http://schemas.openxmlformats.org/drawingml/2006/main">
               <a:ext uri="{FF2B5EF4-FFF2-40B4-BE49-F238E27FC236}">
-                <a16:creationId xmlns:a16="http://schemas.microsoft.com/office/drawing/2014/main" id="{E6F9C24E-2584-4AF0-A9F2-0CEC111C08FE}"/>
+                <a16:creationId xmlns:a16="http://schemas.microsoft.com/office/drawing/2014/main" id="{FAC45961-2CB9-4A44-8307-DCD4A532C8B3}"/>
               </a:ext>
             </a:extLst>
           </p:cNvPr>
@@ -3093,7 +3093,7 @@
           <p:cNvPr id="32" name="">
             <a:extLst xmlns:a="http://schemas.openxmlformats.org/drawingml/2006/main">
               <a:ext uri="{FF2B5EF4-FFF2-40B4-BE49-F238E27FC236}">
-                <a16:creationId xmlns:a16="http://schemas.microsoft.com/office/drawing/2014/main" id="{B9218DF2-6360-420D-A33E-BDA6BFC9B2DE}"/>
+                <a16:creationId xmlns:a16="http://schemas.microsoft.com/office/drawing/2014/main" id="{631C0238-CA39-4051-8838-393F7E59F1C7}"/>
               </a:ext>
             </a:extLst>
           </p:cNvPr>
@@ -3126,7 +3126,7 @@
           <p:cNvPr id="33" name="">
             <a:extLst xmlns:a="http://schemas.openxmlformats.org/drawingml/2006/main">
               <a:ext uri="{FF2B5EF4-FFF2-40B4-BE49-F238E27FC236}">
-                <a16:creationId xmlns:a16="http://schemas.microsoft.com/office/drawing/2014/main" id="{A63F216E-940F-4895-8864-6DC8AF7E55B7}"/>
+                <a16:creationId xmlns:a16="http://schemas.microsoft.com/office/drawing/2014/main" id="{46ABF685-D6D7-4040-9514-CE279B281E61}"/>
               </a:ext>
             </a:extLst>
           </p:cNvPr>
@@ -3190,7 +3190,7 @@
           <p:cNvPr id="34" name="">
             <a:extLst xmlns:a="http://schemas.openxmlformats.org/drawingml/2006/main">
               <a:ext uri="{FF2B5EF4-FFF2-40B4-BE49-F238E27FC236}">
-                <a16:creationId xmlns:a16="http://schemas.microsoft.com/office/drawing/2014/main" id="{A618C53A-3BD5-412F-B524-A8318BF3314A}"/>
+                <a16:creationId xmlns:a16="http://schemas.microsoft.com/office/drawing/2014/main" id="{C5707D4D-780B-4149-A255-D1678583AC10}"/>
               </a:ext>
             </a:extLst>
           </p:cNvPr>
@@ -3277,7 +3277,7 @@
           <p:cNvPr id="35" name="">
             <a:extLst xmlns:a="http://schemas.openxmlformats.org/drawingml/2006/main">
               <a:ext uri="{FF2B5EF4-FFF2-40B4-BE49-F238E27FC236}">
-                <a16:creationId xmlns:a16="http://schemas.microsoft.com/office/drawing/2014/main" id="{00CE007A-98C2-410C-9E4E-F86E0F011BF5}"/>
+                <a16:creationId xmlns:a16="http://schemas.microsoft.com/office/drawing/2014/main" id="{2471F171-EB43-4155-81CF-44F176779D7E}"/>
               </a:ext>
             </a:extLst>
           </p:cNvPr>
@@ -3310,7 +3310,7 @@
           <p:cNvPr id="36" name="">
             <a:extLst xmlns:a="http://schemas.openxmlformats.org/drawingml/2006/main">
               <a:ext uri="{FF2B5EF4-FFF2-40B4-BE49-F238E27FC236}">
-                <a16:creationId xmlns:a16="http://schemas.microsoft.com/office/drawing/2014/main" id="{8E35CB7D-7029-4D88-A89C-A008B1B29F8E}"/>
+                <a16:creationId xmlns:a16="http://schemas.microsoft.com/office/drawing/2014/main" id="{44EEFC7F-814D-4452-8660-C0629532A540}"/>
               </a:ext>
             </a:extLst>
           </p:cNvPr>
@@ -3374,7 +3374,7 @@
           <p:cNvPr id="37" name="">
             <a:extLst xmlns:a="http://schemas.openxmlformats.org/drawingml/2006/main">
               <a:ext uri="{FF2B5EF4-FFF2-40B4-BE49-F238E27FC236}">
-                <a16:creationId xmlns:a16="http://schemas.microsoft.com/office/drawing/2014/main" id="{14837466-1C9F-4718-A729-3F033D80EC94}"/>
+                <a16:creationId xmlns:a16="http://schemas.microsoft.com/office/drawing/2014/main" id="{F3DB36FB-0522-421F-9C09-449546092A2B}"/>
               </a:ext>
             </a:extLst>
           </p:cNvPr>
@@ -3553,7 +3553,7 @@
           <p:cNvPr id="38" name="">
             <a:extLst xmlns:a="http://schemas.openxmlformats.org/drawingml/2006/main">
               <a:ext uri="{FF2B5EF4-FFF2-40B4-BE49-F238E27FC236}">
-                <a16:creationId xmlns:a16="http://schemas.microsoft.com/office/drawing/2014/main" id="{30E964C3-DEFD-4EE0-8948-DAB456D6BAF1}"/>
+                <a16:creationId xmlns:a16="http://schemas.microsoft.com/office/drawing/2014/main" id="{83703725-C524-48D0-AFCC-6E7DE4549D41}"/>
               </a:ext>
             </a:extLst>
           </p:cNvPr>
@@ -3586,7 +3586,7 @@
           <p:cNvPr id="39" name="">
             <a:extLst xmlns:a="http://schemas.openxmlformats.org/drawingml/2006/main">
               <a:ext uri="{FF2B5EF4-FFF2-40B4-BE49-F238E27FC236}">
-                <a16:creationId xmlns:a16="http://schemas.microsoft.com/office/drawing/2014/main" id="{5BB6303B-CB2E-46BA-920F-31EFA341349F}"/>
+                <a16:creationId xmlns:a16="http://schemas.microsoft.com/office/drawing/2014/main" id="{60BB82A9-DA05-4531-B8B4-7860D72AF528}"/>
               </a:ext>
             </a:extLst>
           </p:cNvPr>
@@ -3650,7 +3650,7 @@
           <p:cNvPr id="40" name="">
             <a:extLst xmlns:a="http://schemas.openxmlformats.org/drawingml/2006/main">
               <a:ext uri="{FF2B5EF4-FFF2-40B4-BE49-F238E27FC236}">
-                <a16:creationId xmlns:a16="http://schemas.microsoft.com/office/drawing/2014/main" id="{1E0E7D1D-C287-4D48-B5E5-4E1B0C9DDC82}"/>
+                <a16:creationId xmlns:a16="http://schemas.microsoft.com/office/drawing/2014/main" id="{7B9AE6CA-55E2-4719-9AD0-0E1BE4F00FF1}"/>
               </a:ext>
             </a:extLst>
           </p:cNvPr>
@@ -3806,7 +3806,7 @@
           <p:cNvPr id="41" name="">
             <a:extLst xmlns:a="http://schemas.openxmlformats.org/drawingml/2006/main">
               <a:ext uri="{FF2B5EF4-FFF2-40B4-BE49-F238E27FC236}">
-                <a16:creationId xmlns:a16="http://schemas.microsoft.com/office/drawing/2014/main" id="{8580E13D-4272-4E93-B78C-C9FF6DD570C5}"/>
+                <a16:creationId xmlns:a16="http://schemas.microsoft.com/office/drawing/2014/main" id="{39349A59-7A65-429A-88CF-FF2EE67599E0}"/>
               </a:ext>
             </a:extLst>
           </p:cNvPr>
@@ -3868,7 +3868,7 @@
     </p:spTree>
     <p:extLst>
       <p:ext uri="{BB962C8B-B14F-4D97-AF65-F5344CB8AC3E}">
-        <p14:creationId xmlns:p14="http://schemas.microsoft.com/office/powerpoint/2010/main" val="784572932"/>
+        <p14:creationId xmlns:p14="http://schemas.microsoft.com/office/powerpoint/2010/main" val="602425714"/>
       </p:ext>
     </p:extLst>
   </p:cSld>
@@ -3892,7 +3892,7 @@
           <p:cNvPr id="1" name="">
             <a:extLst xmlns:a="http://schemas.openxmlformats.org/drawingml/2006/main">
               <a:ext uri="{FF2B5EF4-FFF2-40B4-BE49-F238E27FC236}">
-                <a16:creationId xmlns:a16="http://schemas.microsoft.com/office/drawing/2014/main" id="{8A1B862F-EEA3-4330-B2A5-E19F9EC984DD}"/>
+                <a16:creationId xmlns:a16="http://schemas.microsoft.com/office/drawing/2014/main" id="{7DCE08F0-7EED-40DF-A97F-C6E55C652F0C}"/>
               </a:ext>
             </a:extLst>
           </p:cNvPr>
@@ -3927,7 +3927,7 @@
           <p:cNvPr id="2" name="">
             <a:extLst xmlns:a="http://schemas.openxmlformats.org/drawingml/2006/main">
               <a:ext uri="{FF2B5EF4-FFF2-40B4-BE49-F238E27FC236}">
-                <a16:creationId xmlns:a16="http://schemas.microsoft.com/office/drawing/2014/main" id="{27604A9E-F094-4DDF-B93E-7E7455656B91}"/>
+                <a16:creationId xmlns:a16="http://schemas.microsoft.com/office/drawing/2014/main" id="{D2714DC0-2D69-45EA-A7A3-BC41CF17F7F7}"/>
               </a:ext>
             </a:extLst>
           </p:cNvPr>
@@ -3962,7 +3962,7 @@
           <p:cNvPr id="3" name="">
             <a:extLst xmlns:a="http://schemas.openxmlformats.org/drawingml/2006/main">
               <a:ext uri="{FF2B5EF4-FFF2-40B4-BE49-F238E27FC236}">
-                <a16:creationId xmlns:a16="http://schemas.microsoft.com/office/drawing/2014/main" id="{295C4F20-E94E-4419-8D5D-99B12494BDBF}"/>
+                <a16:creationId xmlns:a16="http://schemas.microsoft.com/office/drawing/2014/main" id="{F9D6D5CA-C4FA-444F-990F-84816DB2CBB8}"/>
               </a:ext>
             </a:extLst>
           </p:cNvPr>
@@ -3997,7 +3997,7 @@
           <p:cNvPr id="4" name="">
             <a:extLst xmlns:a="http://schemas.openxmlformats.org/drawingml/2006/main">
               <a:ext uri="{FF2B5EF4-FFF2-40B4-BE49-F238E27FC236}">
-                <a16:creationId xmlns:a16="http://schemas.microsoft.com/office/drawing/2014/main" id="{7CB23A23-3132-48F3-BE88-EB8DC079A62D}"/>
+                <a16:creationId xmlns:a16="http://schemas.microsoft.com/office/drawing/2014/main" id="{14F614FC-9E43-4694-8AEB-D2E8F7D3C771}"/>
               </a:ext>
             </a:extLst>
           </p:cNvPr>
@@ -4061,7 +4061,7 @@
           <p:cNvPr id="5" name="">
             <a:extLst xmlns:a="http://schemas.openxmlformats.org/drawingml/2006/main">
               <a:ext uri="{FF2B5EF4-FFF2-40B4-BE49-F238E27FC236}">
-                <a16:creationId xmlns:a16="http://schemas.microsoft.com/office/drawing/2014/main" id="{99F85C52-0699-42FE-9219-A84213ADBC3A}"/>
+                <a16:creationId xmlns:a16="http://schemas.microsoft.com/office/drawing/2014/main" id="{A4F4B805-7D03-4C2A-8EBE-D2FF8C5328D5}"/>
               </a:ext>
             </a:extLst>
           </p:cNvPr>
@@ -4096,7 +4096,7 @@
           <p:cNvPr id="6" name="">
             <a:extLst xmlns:a="http://schemas.openxmlformats.org/drawingml/2006/main">
               <a:ext uri="{FF2B5EF4-FFF2-40B4-BE49-F238E27FC236}">
-                <a16:creationId xmlns:a16="http://schemas.microsoft.com/office/drawing/2014/main" id="{A319C9DE-FC31-4320-B26B-331661945C97}"/>
+                <a16:creationId xmlns:a16="http://schemas.microsoft.com/office/drawing/2014/main" id="{68BD9765-FD54-42A1-8183-7060A871B7E4}"/>
               </a:ext>
             </a:extLst>
           </p:cNvPr>
@@ -4131,7 +4131,7 @@
           <p:cNvPr id="7" name="">
             <a:extLst xmlns:a="http://schemas.openxmlformats.org/drawingml/2006/main">
               <a:ext uri="{FF2B5EF4-FFF2-40B4-BE49-F238E27FC236}">
-                <a16:creationId xmlns:a16="http://schemas.microsoft.com/office/drawing/2014/main" id="{98CCCF88-1283-48EC-A8C1-6704288CA102}"/>
+                <a16:creationId xmlns:a16="http://schemas.microsoft.com/office/drawing/2014/main" id="{92B2FFFA-75E2-43F0-A5C8-F95103CCC7CC}"/>
               </a:ext>
             </a:extLst>
           </p:cNvPr>
@@ -4166,7 +4166,7 @@
           <p:cNvPr id="8" name="">
             <a:extLst xmlns:a="http://schemas.openxmlformats.org/drawingml/2006/main">
               <a:ext uri="{FF2B5EF4-FFF2-40B4-BE49-F238E27FC236}">
-                <a16:creationId xmlns:a16="http://schemas.microsoft.com/office/drawing/2014/main" id="{A3F71316-463A-4BB9-A2C8-1890AC03642E}"/>
+                <a16:creationId xmlns:a16="http://schemas.microsoft.com/office/drawing/2014/main" id="{C0F027D8-421E-480C-A3AE-97C8C61737AD}"/>
               </a:ext>
             </a:extLst>
           </p:cNvPr>
@@ -4230,7 +4230,7 @@
           <p:cNvPr id="9" name="">
             <a:extLst xmlns:a="http://schemas.openxmlformats.org/drawingml/2006/main">
               <a:ext uri="{FF2B5EF4-FFF2-40B4-BE49-F238E27FC236}">
-                <a16:creationId xmlns:a16="http://schemas.microsoft.com/office/drawing/2014/main" id="{DF0A2C32-B1DF-4E0A-9246-1956482B9287}"/>
+                <a16:creationId xmlns:a16="http://schemas.microsoft.com/office/drawing/2014/main" id="{18291E10-E765-41EA-B5C6-7AF661F81EA1}"/>
               </a:ext>
             </a:extLst>
           </p:cNvPr>
@@ -4294,7 +4294,7 @@
           <p:cNvPr id="10" name="">
             <a:extLst xmlns:a="http://schemas.openxmlformats.org/drawingml/2006/main">
               <a:ext uri="{FF2B5EF4-FFF2-40B4-BE49-F238E27FC236}">
-                <a16:creationId xmlns:a16="http://schemas.microsoft.com/office/drawing/2014/main" id="{E464F5F4-7035-4AD2-998A-43EA9B1DF74E}"/>
+                <a16:creationId xmlns:a16="http://schemas.microsoft.com/office/drawing/2014/main" id="{6D4B927E-54D0-4EDC-AE49-B13C93D4EF93}"/>
               </a:ext>
             </a:extLst>
           </p:cNvPr>
@@ -4358,7 +4358,7 @@
           <p:cNvPr id="11" name="">
             <a:extLst xmlns:a="http://schemas.openxmlformats.org/drawingml/2006/main">
               <a:ext uri="{FF2B5EF4-FFF2-40B4-BE49-F238E27FC236}">
-                <a16:creationId xmlns:a16="http://schemas.microsoft.com/office/drawing/2014/main" id="{61F60FD1-80E7-44F7-B762-FD1195C0C864}"/>
+                <a16:creationId xmlns:a16="http://schemas.microsoft.com/office/drawing/2014/main" id="{84B689BB-1CB4-4815-9A2A-0FA3EBD338B9}"/>
               </a:ext>
             </a:extLst>
           </p:cNvPr>
@@ -4422,7 +4422,7 @@
           <p:cNvPr id="12" name="">
             <a:extLst xmlns:a="http://schemas.openxmlformats.org/drawingml/2006/main">
               <a:ext uri="{FF2B5EF4-FFF2-40B4-BE49-F238E27FC236}">
-                <a16:creationId xmlns:a16="http://schemas.microsoft.com/office/drawing/2014/main" id="{1472718A-0FE7-47A9-84A3-2E0E601D4EB2}"/>
+                <a16:creationId xmlns:a16="http://schemas.microsoft.com/office/drawing/2014/main" id="{8557F53D-F88E-4B4D-A3C5-A66C09A1ADD7}"/>
               </a:ext>
             </a:extLst>
           </p:cNvPr>
@@ -4455,7 +4455,7 @@
           <p:cNvPr id="13" name="">
             <a:extLst xmlns:a="http://schemas.openxmlformats.org/drawingml/2006/main">
               <a:ext uri="{FF2B5EF4-FFF2-40B4-BE49-F238E27FC236}">
-                <a16:creationId xmlns:a16="http://schemas.microsoft.com/office/drawing/2014/main" id="{85C48AE8-256C-4215-82D3-FD17416224AF}"/>
+                <a16:creationId xmlns:a16="http://schemas.microsoft.com/office/drawing/2014/main" id="{B3E63335-BD0C-4CA8-BD7F-BF62C740A5E5}"/>
               </a:ext>
             </a:extLst>
           </p:cNvPr>
@@ -4519,7 +4519,7 @@
           <p:cNvPr id="14" name="">
             <a:extLst xmlns:a="http://schemas.openxmlformats.org/drawingml/2006/main">
               <a:ext uri="{FF2B5EF4-FFF2-40B4-BE49-F238E27FC236}">
-                <a16:creationId xmlns:a16="http://schemas.microsoft.com/office/drawing/2014/main" id="{A1F8FB3E-1B2A-439E-AB7F-549A72782CF4}"/>
+                <a16:creationId xmlns:a16="http://schemas.microsoft.com/office/drawing/2014/main" id="{006F5EB7-04AE-4F69-B9C5-FC6AC4C96835}"/>
               </a:ext>
             </a:extLst>
           </p:cNvPr>
@@ -4675,7 +4675,7 @@
           <p:cNvPr id="15" name="">
             <a:extLst xmlns:a="http://schemas.openxmlformats.org/drawingml/2006/main">
               <a:ext uri="{FF2B5EF4-FFF2-40B4-BE49-F238E27FC236}">
-                <a16:creationId xmlns:a16="http://schemas.microsoft.com/office/drawing/2014/main" id="{EEC08511-F701-49C6-BC9D-A679D0196ED6}"/>
+                <a16:creationId xmlns:a16="http://schemas.microsoft.com/office/drawing/2014/main" id="{42EF7CA1-7F3A-4F01-A547-416ADBB728F4}"/>
               </a:ext>
             </a:extLst>
           </p:cNvPr>
@@ -4708,7 +4708,7 @@
           <p:cNvPr id="16" name="">
             <a:extLst xmlns:a="http://schemas.openxmlformats.org/drawingml/2006/main">
               <a:ext uri="{FF2B5EF4-FFF2-40B4-BE49-F238E27FC236}">
-                <a16:creationId xmlns:a16="http://schemas.microsoft.com/office/drawing/2014/main" id="{23978FB0-70C2-4FE3-AD54-1AA9318C0A51}"/>
+                <a16:creationId xmlns:a16="http://schemas.microsoft.com/office/drawing/2014/main" id="{1F4A420A-7097-42D2-98E9-27B8953FC9F9}"/>
               </a:ext>
             </a:extLst>
           </p:cNvPr>
@@ -4772,7 +4772,7 @@
           <p:cNvPr id="17" name="">
             <a:extLst xmlns:a="http://schemas.openxmlformats.org/drawingml/2006/main">
               <a:ext uri="{FF2B5EF4-FFF2-40B4-BE49-F238E27FC236}">
-                <a16:creationId xmlns:a16="http://schemas.microsoft.com/office/drawing/2014/main" id="{885BC13F-D6E3-4603-A5D7-477A572254B8}"/>
+                <a16:creationId xmlns:a16="http://schemas.microsoft.com/office/drawing/2014/main" id="{09B728BF-912D-4966-B68E-6B686B94B983}"/>
               </a:ext>
             </a:extLst>
           </p:cNvPr>
@@ -4928,7 +4928,7 @@
           <p:cNvPr id="18" name="">
             <a:extLst xmlns:a="http://schemas.openxmlformats.org/drawingml/2006/main">
               <a:ext uri="{FF2B5EF4-FFF2-40B4-BE49-F238E27FC236}">
-                <a16:creationId xmlns:a16="http://schemas.microsoft.com/office/drawing/2014/main" id="{2B43DB43-BD40-496C-93FF-F4FBCCC23ACD}"/>
+                <a16:creationId xmlns:a16="http://schemas.microsoft.com/office/drawing/2014/main" id="{F6E32560-7246-4BB2-8A33-705A104819DA}"/>
               </a:ext>
             </a:extLst>
           </p:cNvPr>
@@ -4961,7 +4961,7 @@
           <p:cNvPr id="19" name="">
             <a:extLst xmlns:a="http://schemas.openxmlformats.org/drawingml/2006/main">
               <a:ext uri="{FF2B5EF4-FFF2-40B4-BE49-F238E27FC236}">
-                <a16:creationId xmlns:a16="http://schemas.microsoft.com/office/drawing/2014/main" id="{222EAC1E-2F3F-4071-9B6F-F716BF79FABC}"/>
+                <a16:creationId xmlns:a16="http://schemas.microsoft.com/office/drawing/2014/main" id="{DFCEBBFC-39AC-4414-B6DD-2F20C27D9D2D}"/>
               </a:ext>
             </a:extLst>
           </p:cNvPr>
@@ -5025,7 +5025,7 @@
           <p:cNvPr id="20" name="">
             <a:extLst xmlns:a="http://schemas.openxmlformats.org/drawingml/2006/main">
               <a:ext uri="{FF2B5EF4-FFF2-40B4-BE49-F238E27FC236}">
-                <a16:creationId xmlns:a16="http://schemas.microsoft.com/office/drawing/2014/main" id="{2F5085FC-F91A-47DF-8BF0-04DDB753897B}"/>
+                <a16:creationId xmlns:a16="http://schemas.microsoft.com/office/drawing/2014/main" id="{96285CCF-724A-44FC-80C6-83462D3B17EB}"/>
               </a:ext>
             </a:extLst>
           </p:cNvPr>
@@ -5237,7 +5237,7 @@
           <p:cNvPr id="21" name="">
             <a:extLst xmlns:a="http://schemas.openxmlformats.org/drawingml/2006/main">
               <a:ext uri="{FF2B5EF4-FFF2-40B4-BE49-F238E27FC236}">
-                <a16:creationId xmlns:a16="http://schemas.microsoft.com/office/drawing/2014/main" id="{122307E2-438A-4E62-8C35-C60E0016E9D5}"/>
+                <a16:creationId xmlns:a16="http://schemas.microsoft.com/office/drawing/2014/main" id="{8BEE41B8-4D2A-4F84-A0B2-7351378C0401}"/>
               </a:ext>
             </a:extLst>
           </p:cNvPr>
@@ -5270,7 +5270,7 @@
           <p:cNvPr id="22" name="">
             <a:extLst xmlns:a="http://schemas.openxmlformats.org/drawingml/2006/main">
               <a:ext uri="{FF2B5EF4-FFF2-40B4-BE49-F238E27FC236}">
-                <a16:creationId xmlns:a16="http://schemas.microsoft.com/office/drawing/2014/main" id="{641D8293-293B-4B28-8D77-38AC188BB0BA}"/>
+                <a16:creationId xmlns:a16="http://schemas.microsoft.com/office/drawing/2014/main" id="{1EBE9083-AE26-45EC-BFC2-864B21AB8AC0}"/>
               </a:ext>
             </a:extLst>
           </p:cNvPr>
@@ -5334,7 +5334,7 @@
           <p:cNvPr id="23" name="">
             <a:extLst xmlns:a="http://schemas.openxmlformats.org/drawingml/2006/main">
               <a:ext uri="{FF2B5EF4-FFF2-40B4-BE49-F238E27FC236}">
-                <a16:creationId xmlns:a16="http://schemas.microsoft.com/office/drawing/2014/main" id="{B44881FA-C9EC-46B2-8AC8-BDEB7A6B69CE}"/>
+                <a16:creationId xmlns:a16="http://schemas.microsoft.com/office/drawing/2014/main" id="{37D4D85D-1C99-4D70-AE71-2C22E4A9FACA}"/>
               </a:ext>
             </a:extLst>
           </p:cNvPr>
@@ -5569,7 +5569,7 @@
           <p:cNvPr id="24" name="">
             <a:extLst xmlns:a="http://schemas.openxmlformats.org/drawingml/2006/main">
               <a:ext uri="{FF2B5EF4-FFF2-40B4-BE49-F238E27FC236}">
-                <a16:creationId xmlns:a16="http://schemas.microsoft.com/office/drawing/2014/main" id="{15B6F255-95F1-483C-A314-B6C1BA3E28C5}"/>
+                <a16:creationId xmlns:a16="http://schemas.microsoft.com/office/drawing/2014/main" id="{27F4CC1B-5BED-4310-BE77-6817ECE0DD9B}"/>
               </a:ext>
             </a:extLst>
           </p:cNvPr>
@@ -5602,7 +5602,7 @@
           <p:cNvPr id="25" name="">
             <a:extLst xmlns:a="http://schemas.openxmlformats.org/drawingml/2006/main">
               <a:ext uri="{FF2B5EF4-FFF2-40B4-BE49-F238E27FC236}">
-                <a16:creationId xmlns:a16="http://schemas.microsoft.com/office/drawing/2014/main" id="{D4F0BD10-8CE6-4308-AD30-17F0F5AB9DF5}"/>
+                <a16:creationId xmlns:a16="http://schemas.microsoft.com/office/drawing/2014/main" id="{62FFC93B-E3B5-493F-A2CA-FAA823B88F19}"/>
               </a:ext>
             </a:extLst>
           </p:cNvPr>
@@ -5666,7 +5666,7 @@
           <p:cNvPr id="26" name="">
             <a:extLst xmlns:a="http://schemas.openxmlformats.org/drawingml/2006/main">
               <a:ext uri="{FF2B5EF4-FFF2-40B4-BE49-F238E27FC236}">
-                <a16:creationId xmlns:a16="http://schemas.microsoft.com/office/drawing/2014/main" id="{B18D774A-A5F1-4122-A7B7-7ED3F9E9BB1D}"/>
+                <a16:creationId xmlns:a16="http://schemas.microsoft.com/office/drawing/2014/main" id="{CCCFCBDF-625E-4FF6-AFC5-6B1F4C6B65D0}"/>
               </a:ext>
             </a:extLst>
           </p:cNvPr>
@@ -5730,7 +5730,7 @@
           <p:cNvPr id="27" name="">
             <a:extLst xmlns:a="http://schemas.openxmlformats.org/drawingml/2006/main">
               <a:ext uri="{FF2B5EF4-FFF2-40B4-BE49-F238E27FC236}">
-                <a16:creationId xmlns:a16="http://schemas.microsoft.com/office/drawing/2014/main" id="{0C7ABC51-AF66-4885-8D8A-53E2EBD4FB11}"/>
+                <a16:creationId xmlns:a16="http://schemas.microsoft.com/office/drawing/2014/main" id="{63D0BDB7-6DDA-452D-9955-EC6E94762E70}"/>
               </a:ext>
             </a:extLst>
           </p:cNvPr>
@@ -5763,7 +5763,7 @@
           <p:cNvPr id="28" name="">
             <a:extLst xmlns:a="http://schemas.openxmlformats.org/drawingml/2006/main">
               <a:ext uri="{FF2B5EF4-FFF2-40B4-BE49-F238E27FC236}">
-                <a16:creationId xmlns:a16="http://schemas.microsoft.com/office/drawing/2014/main" id="{D0437977-78C7-491A-9B6B-3406F2C812B0}"/>
+                <a16:creationId xmlns:a16="http://schemas.microsoft.com/office/drawing/2014/main" id="{82B58EEB-50A9-4609-A936-2069A125F1C2}"/>
               </a:ext>
             </a:extLst>
           </p:cNvPr>
@@ -5827,7 +5827,7 @@
           <p:cNvPr id="29" name="">
             <a:extLst xmlns:a="http://schemas.openxmlformats.org/drawingml/2006/main">
               <a:ext uri="{FF2B5EF4-FFF2-40B4-BE49-F238E27FC236}">
-                <a16:creationId xmlns:a16="http://schemas.microsoft.com/office/drawing/2014/main" id="{A017FC0E-8C82-4862-A462-7E9F184161CD}"/>
+                <a16:creationId xmlns:a16="http://schemas.microsoft.com/office/drawing/2014/main" id="{3D1FBEE5-C5D3-4E1D-A53F-07EB96BC1140}"/>
               </a:ext>
             </a:extLst>
           </p:cNvPr>
@@ -5891,7 +5891,7 @@
           <p:cNvPr id="30" name="">
             <a:extLst xmlns:a="http://schemas.openxmlformats.org/drawingml/2006/main">
               <a:ext uri="{FF2B5EF4-FFF2-40B4-BE49-F238E27FC236}">
-                <a16:creationId xmlns:a16="http://schemas.microsoft.com/office/drawing/2014/main" id="{3636F687-53DE-4E6A-BF2D-4FFD97445148}"/>
+                <a16:creationId xmlns:a16="http://schemas.microsoft.com/office/drawing/2014/main" id="{4EC1C3C7-B70D-4AE4-BF66-B5CA466E372C}"/>
               </a:ext>
             </a:extLst>
           </p:cNvPr>
@@ -5924,7 +5924,7 @@
           <p:cNvPr id="31" name="">
             <a:extLst xmlns:a="http://schemas.openxmlformats.org/drawingml/2006/main">
               <a:ext uri="{FF2B5EF4-FFF2-40B4-BE49-F238E27FC236}">
-                <a16:creationId xmlns:a16="http://schemas.microsoft.com/office/drawing/2014/main" id="{BC86DDA3-2573-4949-8820-EBAA566D0F1E}"/>
+                <a16:creationId xmlns:a16="http://schemas.microsoft.com/office/drawing/2014/main" id="{6E52E50B-9E49-430B-B9B9-6EB9729BFA68}"/>
               </a:ext>
             </a:extLst>
           </p:cNvPr>
@@ -5988,7 +5988,7 @@
           <p:cNvPr id="32" name="">
             <a:extLst xmlns:a="http://schemas.openxmlformats.org/drawingml/2006/main">
               <a:ext uri="{FF2B5EF4-FFF2-40B4-BE49-F238E27FC236}">
-                <a16:creationId xmlns:a16="http://schemas.microsoft.com/office/drawing/2014/main" id="{DEA7139F-982E-49D4-95F4-9097EE4A4898}"/>
+                <a16:creationId xmlns:a16="http://schemas.microsoft.com/office/drawing/2014/main" id="{C3216671-5063-462A-8558-A8C594E6E9D1}"/>
               </a:ext>
             </a:extLst>
           </p:cNvPr>
@@ -6052,7 +6052,7 @@
           <p:cNvPr id="33" name="">
             <a:extLst xmlns:a="http://schemas.openxmlformats.org/drawingml/2006/main">
               <a:ext uri="{FF2B5EF4-FFF2-40B4-BE49-F238E27FC236}">
-                <a16:creationId xmlns:a16="http://schemas.microsoft.com/office/drawing/2014/main" id="{A64EBF91-F97B-4A4F-A0EF-5105407C5874}"/>
+                <a16:creationId xmlns:a16="http://schemas.microsoft.com/office/drawing/2014/main" id="{0A2F072C-5C76-49C9-AE0F-7E7EEAD66853}"/>
               </a:ext>
             </a:extLst>
           </p:cNvPr>
@@ -6085,7 +6085,7 @@
           <p:cNvPr id="34" name="">
             <a:extLst xmlns:a="http://schemas.openxmlformats.org/drawingml/2006/main">
               <a:ext uri="{FF2B5EF4-FFF2-40B4-BE49-F238E27FC236}">
-                <a16:creationId xmlns:a16="http://schemas.microsoft.com/office/drawing/2014/main" id="{16C9F2F0-6B9F-452E-AD1B-09645FC1AC80}"/>
+                <a16:creationId xmlns:a16="http://schemas.microsoft.com/office/drawing/2014/main" id="{A43BC01F-733E-4340-B482-9F35A0DDE12D}"/>
               </a:ext>
             </a:extLst>
           </p:cNvPr>
@@ -6149,7 +6149,7 @@
           <p:cNvPr id="35" name="">
             <a:extLst xmlns:a="http://schemas.openxmlformats.org/drawingml/2006/main">
               <a:ext uri="{FF2B5EF4-FFF2-40B4-BE49-F238E27FC236}">
-                <a16:creationId xmlns:a16="http://schemas.microsoft.com/office/drawing/2014/main" id="{6CB68CA5-0C79-43E9-AF16-FB0B78D681F8}"/>
+                <a16:creationId xmlns:a16="http://schemas.microsoft.com/office/drawing/2014/main" id="{F5B99B6B-8241-4DB0-887C-E0154DD5EE31}"/>
               </a:ext>
             </a:extLst>
           </p:cNvPr>
@@ -6213,7 +6213,7 @@
           <p:cNvPr id="36" name="">
             <a:extLst xmlns:a="http://schemas.openxmlformats.org/drawingml/2006/main">
               <a:ext uri="{FF2B5EF4-FFF2-40B4-BE49-F238E27FC236}">
-                <a16:creationId xmlns:a16="http://schemas.microsoft.com/office/drawing/2014/main" id="{BB7BF046-C3E3-46B6-B856-A5A0723D316F}"/>
+                <a16:creationId xmlns:a16="http://schemas.microsoft.com/office/drawing/2014/main" id="{D166D30B-9B6B-48DA-9EF0-E0E0DC490495}"/>
               </a:ext>
             </a:extLst>
           </p:cNvPr>
@@ -6246,7 +6246,7 @@
           <p:cNvPr id="37" name="">
             <a:extLst xmlns:a="http://schemas.openxmlformats.org/drawingml/2006/main">
               <a:ext uri="{FF2B5EF4-FFF2-40B4-BE49-F238E27FC236}">
-                <a16:creationId xmlns:a16="http://schemas.microsoft.com/office/drawing/2014/main" id="{8E0B6019-9C41-4B81-84A1-C4165D82B196}"/>
+                <a16:creationId xmlns:a16="http://schemas.microsoft.com/office/drawing/2014/main" id="{786A29D5-4947-495A-9135-8147F439F487}"/>
               </a:ext>
             </a:extLst>
           </p:cNvPr>
@@ -6310,7 +6310,7 @@
           <p:cNvPr id="38" name="">
             <a:extLst xmlns:a="http://schemas.openxmlformats.org/drawingml/2006/main">
               <a:ext uri="{FF2B5EF4-FFF2-40B4-BE49-F238E27FC236}">
-                <a16:creationId xmlns:a16="http://schemas.microsoft.com/office/drawing/2014/main" id="{648BFEBC-1A66-43D3-B1C0-02B585BBDE60}"/>
+                <a16:creationId xmlns:a16="http://schemas.microsoft.com/office/drawing/2014/main" id="{1A0B6772-8DFC-431A-AD45-44C062D6CFCA}"/>
               </a:ext>
             </a:extLst>
           </p:cNvPr>
@@ -6441,7 +6441,7 @@
     </p:spTree>
     <p:extLst>
       <p:ext uri="{BB962C8B-B14F-4D97-AF65-F5344CB8AC3E}">
-        <p14:creationId xmlns:p14="http://schemas.microsoft.com/office/powerpoint/2010/main" val="211332629"/>
+        <p14:creationId xmlns:p14="http://schemas.microsoft.com/office/powerpoint/2010/main" val="1331442612"/>
       </p:ext>
     </p:extLst>
   </p:cSld>
@@ -6465,7 +6465,7 @@
           <p:cNvPr id="1" name="">
             <a:extLst xmlns:a="http://schemas.openxmlformats.org/drawingml/2006/main">
               <a:ext uri="{FF2B5EF4-FFF2-40B4-BE49-F238E27FC236}">
-                <a16:creationId xmlns:a16="http://schemas.microsoft.com/office/drawing/2014/main" id="{81C9A8EB-36B4-4DBA-9A49-142546953E0B}"/>
+                <a16:creationId xmlns:a16="http://schemas.microsoft.com/office/drawing/2014/main" id="{A5AE75D5-20E7-4456-9C09-AD18833A207A}"/>
               </a:ext>
             </a:extLst>
           </p:cNvPr>
@@ -6500,7 +6500,7 @@
           <p:cNvPr id="2" name="">
             <a:extLst xmlns:a="http://schemas.openxmlformats.org/drawingml/2006/main">
               <a:ext uri="{FF2B5EF4-FFF2-40B4-BE49-F238E27FC236}">
-                <a16:creationId xmlns:a16="http://schemas.microsoft.com/office/drawing/2014/main" id="{E0E6B325-EBFC-47CA-90E6-A604AE0AF5F6}"/>
+                <a16:creationId xmlns:a16="http://schemas.microsoft.com/office/drawing/2014/main" id="{6491C884-F329-4255-A52C-D1EA0BAE0D80}"/>
               </a:ext>
             </a:extLst>
           </p:cNvPr>
@@ -6535,7 +6535,7 @@
           <p:cNvPr id="3" name="">
             <a:extLst xmlns:a="http://schemas.openxmlformats.org/drawingml/2006/main">
               <a:ext uri="{FF2B5EF4-FFF2-40B4-BE49-F238E27FC236}">
-                <a16:creationId xmlns:a16="http://schemas.microsoft.com/office/drawing/2014/main" id="{2A236148-53BF-466A-A42D-C46160F6E032}"/>
+                <a16:creationId xmlns:a16="http://schemas.microsoft.com/office/drawing/2014/main" id="{162A2CF9-5354-4B13-BD06-206A2ED58988}"/>
               </a:ext>
             </a:extLst>
           </p:cNvPr>
@@ -6570,7 +6570,7 @@
           <p:cNvPr id="4" name="">
             <a:extLst xmlns:a="http://schemas.openxmlformats.org/drawingml/2006/main">
               <a:ext uri="{FF2B5EF4-FFF2-40B4-BE49-F238E27FC236}">
-                <a16:creationId xmlns:a16="http://schemas.microsoft.com/office/drawing/2014/main" id="{21381922-7804-4888-8E0D-814524CDF52A}"/>
+                <a16:creationId xmlns:a16="http://schemas.microsoft.com/office/drawing/2014/main" id="{6B1E11B4-7133-4D1D-8DF2-E36383D3FF6C}"/>
               </a:ext>
             </a:extLst>
           </p:cNvPr>
@@ -6634,7 +6634,7 @@
           <p:cNvPr id="5" name="">
             <a:extLst xmlns:a="http://schemas.openxmlformats.org/drawingml/2006/main">
               <a:ext uri="{FF2B5EF4-FFF2-40B4-BE49-F238E27FC236}">
-                <a16:creationId xmlns:a16="http://schemas.microsoft.com/office/drawing/2014/main" id="{D31431C3-2A16-4680-B88E-021D9E5FC0E8}"/>
+                <a16:creationId xmlns:a16="http://schemas.microsoft.com/office/drawing/2014/main" id="{F68C080C-BDF2-425A-84E3-0B02D4AE7166}"/>
               </a:ext>
             </a:extLst>
           </p:cNvPr>
@@ -6669,7 +6669,7 @@
           <p:cNvPr id="6" name="">
             <a:extLst xmlns:a="http://schemas.openxmlformats.org/drawingml/2006/main">
               <a:ext uri="{FF2B5EF4-FFF2-40B4-BE49-F238E27FC236}">
-                <a16:creationId xmlns:a16="http://schemas.microsoft.com/office/drawing/2014/main" id="{B087DF1C-BB50-4E1C-84BD-F76C8732C889}"/>
+                <a16:creationId xmlns:a16="http://schemas.microsoft.com/office/drawing/2014/main" id="{88567390-7AE3-4C08-9FC2-B38D4DA5AC4D}"/>
               </a:ext>
             </a:extLst>
           </p:cNvPr>
@@ -6704,7 +6704,7 @@
           <p:cNvPr id="7" name="">
             <a:extLst xmlns:a="http://schemas.openxmlformats.org/drawingml/2006/main">
               <a:ext uri="{FF2B5EF4-FFF2-40B4-BE49-F238E27FC236}">
-                <a16:creationId xmlns:a16="http://schemas.microsoft.com/office/drawing/2014/main" id="{3817120B-5916-4B4A-9BC7-B3A6F2466C4F}"/>
+                <a16:creationId xmlns:a16="http://schemas.microsoft.com/office/drawing/2014/main" id="{CCB2FD8D-D6BB-4AA0-8D26-C0640632852A}"/>
               </a:ext>
             </a:extLst>
           </p:cNvPr>
@@ -6739,7 +6739,7 @@
           <p:cNvPr id="8" name="">
             <a:extLst xmlns:a="http://schemas.openxmlformats.org/drawingml/2006/main">
               <a:ext uri="{FF2B5EF4-FFF2-40B4-BE49-F238E27FC236}">
-                <a16:creationId xmlns:a16="http://schemas.microsoft.com/office/drawing/2014/main" id="{4DE656D1-CB25-47E9-8B42-B4B3D6A8DCAB}"/>
+                <a16:creationId xmlns:a16="http://schemas.microsoft.com/office/drawing/2014/main" id="{8F8C1CF7-EFD6-48A0-8BD2-ED7A63211DF8}"/>
               </a:ext>
             </a:extLst>
           </p:cNvPr>
@@ -6803,7 +6803,7 @@
           <p:cNvPr id="9" name="">
             <a:extLst xmlns:a="http://schemas.openxmlformats.org/drawingml/2006/main">
               <a:ext uri="{FF2B5EF4-FFF2-40B4-BE49-F238E27FC236}">
-                <a16:creationId xmlns:a16="http://schemas.microsoft.com/office/drawing/2014/main" id="{694EB20D-34AD-4099-BE32-8DD5EB239216}"/>
+                <a16:creationId xmlns:a16="http://schemas.microsoft.com/office/drawing/2014/main" id="{91CD7728-D142-4B69-A575-9BD39E8CBA00}"/>
               </a:ext>
             </a:extLst>
           </p:cNvPr>
@@ -6867,7 +6867,7 @@
           <p:cNvPr id="10" name="">
             <a:extLst xmlns:a="http://schemas.openxmlformats.org/drawingml/2006/main">
               <a:ext uri="{FF2B5EF4-FFF2-40B4-BE49-F238E27FC236}">
-                <a16:creationId xmlns:a16="http://schemas.microsoft.com/office/drawing/2014/main" id="{93DBA525-189D-44B8-A7A7-CEE79BAEEE74}"/>
+                <a16:creationId xmlns:a16="http://schemas.microsoft.com/office/drawing/2014/main" id="{D2F2B16B-CFFA-45E4-97FB-970AC5396051}"/>
               </a:ext>
             </a:extLst>
           </p:cNvPr>
@@ -6931,7 +6931,7 @@
           <p:cNvPr id="11" name="">
             <a:extLst xmlns:a="http://schemas.openxmlformats.org/drawingml/2006/main">
               <a:ext uri="{FF2B5EF4-FFF2-40B4-BE49-F238E27FC236}">
-                <a16:creationId xmlns:a16="http://schemas.microsoft.com/office/drawing/2014/main" id="{9FAB62C4-3CAA-44F1-B76A-85288372A9A9}"/>
+                <a16:creationId xmlns:a16="http://schemas.microsoft.com/office/drawing/2014/main" id="{DD53E090-493E-44A8-AAE4-9CDFCC6C95C8}"/>
               </a:ext>
             </a:extLst>
           </p:cNvPr>
@@ -6995,7 +6995,7 @@
           <p:cNvPr id="12" name="">
             <a:extLst xmlns:a="http://schemas.openxmlformats.org/drawingml/2006/main">
               <a:ext uri="{FF2B5EF4-FFF2-40B4-BE49-F238E27FC236}">
-                <a16:creationId xmlns:a16="http://schemas.microsoft.com/office/drawing/2014/main" id="{8B8BF19E-F1F7-41EC-8739-14A6824B85F7}"/>
+                <a16:creationId xmlns:a16="http://schemas.microsoft.com/office/drawing/2014/main" id="{4EF47402-9393-4757-82C4-1105CF78E948}"/>
               </a:ext>
             </a:extLst>
           </p:cNvPr>
@@ -7028,7 +7028,7 @@
           <p:cNvPr id="13" name="">
             <a:extLst xmlns:a="http://schemas.openxmlformats.org/drawingml/2006/main">
               <a:ext uri="{FF2B5EF4-FFF2-40B4-BE49-F238E27FC236}">
-                <a16:creationId xmlns:a16="http://schemas.microsoft.com/office/drawing/2014/main" id="{5DEAD55F-C240-4773-85C0-2277BFD4CEF4}"/>
+                <a16:creationId xmlns:a16="http://schemas.microsoft.com/office/drawing/2014/main" id="{21402928-2B10-4983-890A-0E057D5DD8C3}"/>
               </a:ext>
             </a:extLst>
           </p:cNvPr>
@@ -7092,7 +7092,7 @@
           <p:cNvPr id="14" name="">
             <a:extLst xmlns:a="http://schemas.openxmlformats.org/drawingml/2006/main">
               <a:ext uri="{FF2B5EF4-FFF2-40B4-BE49-F238E27FC236}">
-                <a16:creationId xmlns:a16="http://schemas.microsoft.com/office/drawing/2014/main" id="{84AF4E66-1089-4538-AD8F-56F805EAB563}"/>
+                <a16:creationId xmlns:a16="http://schemas.microsoft.com/office/drawing/2014/main" id="{69E630D0-E971-475B-8342-4BDE20A91E54}"/>
               </a:ext>
             </a:extLst>
           </p:cNvPr>
@@ -7179,7 +7179,7 @@
           <p:cNvPr id="15" name="">
             <a:extLst xmlns:a="http://schemas.openxmlformats.org/drawingml/2006/main">
               <a:ext uri="{FF2B5EF4-FFF2-40B4-BE49-F238E27FC236}">
-                <a16:creationId xmlns:a16="http://schemas.microsoft.com/office/drawing/2014/main" id="{7B535578-0DE2-497A-A6BF-2371C99FD41B}"/>
+                <a16:creationId xmlns:a16="http://schemas.microsoft.com/office/drawing/2014/main" id="{F5360AAB-18B4-41AA-9FDF-4C06E46D7914}"/>
               </a:ext>
             </a:extLst>
           </p:cNvPr>
@@ -7212,7 +7212,7 @@
           <p:cNvPr id="16" name="">
             <a:extLst xmlns:a="http://schemas.openxmlformats.org/drawingml/2006/main">
               <a:ext uri="{FF2B5EF4-FFF2-40B4-BE49-F238E27FC236}">
-                <a16:creationId xmlns:a16="http://schemas.microsoft.com/office/drawing/2014/main" id="{5376AF63-B71C-4198-8622-C9786DEECC40}"/>
+                <a16:creationId xmlns:a16="http://schemas.microsoft.com/office/drawing/2014/main" id="{6C65A2A1-7E81-4A07-B79E-EBF6910806C1}"/>
               </a:ext>
             </a:extLst>
           </p:cNvPr>
@@ -7276,7 +7276,7 @@
           <p:cNvPr id="17" name="">
             <a:extLst xmlns:a="http://schemas.openxmlformats.org/drawingml/2006/main">
               <a:ext uri="{FF2B5EF4-FFF2-40B4-BE49-F238E27FC236}">
-                <a16:creationId xmlns:a16="http://schemas.microsoft.com/office/drawing/2014/main" id="{91AE21A9-B18B-4241-8DAD-4B7CADBABC81}"/>
+                <a16:creationId xmlns:a16="http://schemas.microsoft.com/office/drawing/2014/main" id="{A0F87340-9895-47E9-A0A5-771015E96CFD}"/>
               </a:ext>
             </a:extLst>
           </p:cNvPr>
@@ -7363,7 +7363,7 @@
           <p:cNvPr id="18" name="">
             <a:extLst xmlns:a="http://schemas.openxmlformats.org/drawingml/2006/main">
               <a:ext uri="{FF2B5EF4-FFF2-40B4-BE49-F238E27FC236}">
-                <a16:creationId xmlns:a16="http://schemas.microsoft.com/office/drawing/2014/main" id="{73D82789-0986-42F6-8416-03ABF3E7E814}"/>
+                <a16:creationId xmlns:a16="http://schemas.microsoft.com/office/drawing/2014/main" id="{4219CEAF-296F-42E1-8D46-4ADE163D287A}"/>
               </a:ext>
             </a:extLst>
           </p:cNvPr>
@@ -7396,7 +7396,7 @@
           <p:cNvPr id="19" name="">
             <a:extLst xmlns:a="http://schemas.openxmlformats.org/drawingml/2006/main">
               <a:ext uri="{FF2B5EF4-FFF2-40B4-BE49-F238E27FC236}">
-                <a16:creationId xmlns:a16="http://schemas.microsoft.com/office/drawing/2014/main" id="{106775FE-DA8E-4E98-8B1E-EA4A096F05CE}"/>
+                <a16:creationId xmlns:a16="http://schemas.microsoft.com/office/drawing/2014/main" id="{2FB72A3A-553C-4238-924C-C819BF408F8F}"/>
               </a:ext>
             </a:extLst>
           </p:cNvPr>
@@ -7460,7 +7460,7 @@
           <p:cNvPr id="20" name="">
             <a:extLst xmlns:a="http://schemas.openxmlformats.org/drawingml/2006/main">
               <a:ext uri="{FF2B5EF4-FFF2-40B4-BE49-F238E27FC236}">
-                <a16:creationId xmlns:a16="http://schemas.microsoft.com/office/drawing/2014/main" id="{9B8609DA-612A-48B6-9563-5ABBCDCB4850}"/>
+                <a16:creationId xmlns:a16="http://schemas.microsoft.com/office/drawing/2014/main" id="{86FDCE47-9AF7-420B-AE12-DA1249C841A9}"/>
               </a:ext>
             </a:extLst>
           </p:cNvPr>
@@ -7547,7 +7547,7 @@
           <p:cNvPr id="21" name="">
             <a:extLst xmlns:a="http://schemas.openxmlformats.org/drawingml/2006/main">
               <a:ext uri="{FF2B5EF4-FFF2-40B4-BE49-F238E27FC236}">
-                <a16:creationId xmlns:a16="http://schemas.microsoft.com/office/drawing/2014/main" id="{28FF6B2E-3C89-4C05-AA80-C07D5F1A0F96}"/>
+                <a16:creationId xmlns:a16="http://schemas.microsoft.com/office/drawing/2014/main" id="{DFC9AFF1-B14D-4923-BC13-01B882B3E584}"/>
               </a:ext>
             </a:extLst>
           </p:cNvPr>
@@ -7580,7 +7580,7 @@
           <p:cNvPr id="22" name="">
             <a:extLst xmlns:a="http://schemas.openxmlformats.org/drawingml/2006/main">
               <a:ext uri="{FF2B5EF4-FFF2-40B4-BE49-F238E27FC236}">
-                <a16:creationId xmlns:a16="http://schemas.microsoft.com/office/drawing/2014/main" id="{0AA167DD-F02A-46DE-B33E-35B382721E32}"/>
+                <a16:creationId xmlns:a16="http://schemas.microsoft.com/office/drawing/2014/main" id="{4D12AC22-3A0E-4410-99DF-492976BC67F3}"/>
               </a:ext>
             </a:extLst>
           </p:cNvPr>
@@ -7644,7 +7644,7 @@
           <p:cNvPr id="23" name="">
             <a:extLst xmlns:a="http://schemas.openxmlformats.org/drawingml/2006/main">
               <a:ext uri="{FF2B5EF4-FFF2-40B4-BE49-F238E27FC236}">
-                <a16:creationId xmlns:a16="http://schemas.microsoft.com/office/drawing/2014/main" id="{CF2DE0C6-D1AC-45EB-B045-E4B51381934D}"/>
+                <a16:creationId xmlns:a16="http://schemas.microsoft.com/office/drawing/2014/main" id="{68FB6141-C661-41B3-924E-B621B6A8225A}"/>
               </a:ext>
             </a:extLst>
           </p:cNvPr>
@@ -7731,7 +7731,7 @@
           <p:cNvPr id="24" name="">
             <a:extLst xmlns:a="http://schemas.openxmlformats.org/drawingml/2006/main">
               <a:ext uri="{FF2B5EF4-FFF2-40B4-BE49-F238E27FC236}">
-                <a16:creationId xmlns:a16="http://schemas.microsoft.com/office/drawing/2014/main" id="{DC2E952A-346E-41E0-9FD0-2693C9A9ED5B}"/>
+                <a16:creationId xmlns:a16="http://schemas.microsoft.com/office/drawing/2014/main" id="{2A1AADA4-FA8E-4757-AC9F-960E515193CE}"/>
               </a:ext>
             </a:extLst>
           </p:cNvPr>
@@ -7764,7 +7764,7 @@
           <p:cNvPr id="25" name="">
             <a:extLst xmlns:a="http://schemas.openxmlformats.org/drawingml/2006/main">
               <a:ext uri="{FF2B5EF4-FFF2-40B4-BE49-F238E27FC236}">
-                <a16:creationId xmlns:a16="http://schemas.microsoft.com/office/drawing/2014/main" id="{5E40C382-DE83-4EAF-87AA-B44501213593}"/>
+                <a16:creationId xmlns:a16="http://schemas.microsoft.com/office/drawing/2014/main" id="{2DD0BAF8-941B-40D6-AEE7-27E7CCAAA85D}"/>
               </a:ext>
             </a:extLst>
           </p:cNvPr>
@@ -7828,7 +7828,7 @@
           <p:cNvPr id="26" name="">
             <a:extLst xmlns:a="http://schemas.openxmlformats.org/drawingml/2006/main">
               <a:ext uri="{FF2B5EF4-FFF2-40B4-BE49-F238E27FC236}">
-                <a16:creationId xmlns:a16="http://schemas.microsoft.com/office/drawing/2014/main" id="{C2F30F0C-E117-44B9-89AF-FF6051653159}"/>
+                <a16:creationId xmlns:a16="http://schemas.microsoft.com/office/drawing/2014/main" id="{B0D9F6D8-13D2-44E2-BA74-9A15968199C6}"/>
               </a:ext>
             </a:extLst>
           </p:cNvPr>
@@ -7915,7 +7915,7 @@
           <p:cNvPr id="27" name="">
             <a:extLst xmlns:a="http://schemas.openxmlformats.org/drawingml/2006/main">
               <a:ext uri="{FF2B5EF4-FFF2-40B4-BE49-F238E27FC236}">
-                <a16:creationId xmlns:a16="http://schemas.microsoft.com/office/drawing/2014/main" id="{A6F644B9-F5A4-4A65-87DE-88BBEB6B8C5D}"/>
+                <a16:creationId xmlns:a16="http://schemas.microsoft.com/office/drawing/2014/main" id="{165B608F-000B-4DA9-A09F-C0957129E605}"/>
               </a:ext>
             </a:extLst>
           </p:cNvPr>
@@ -7948,7 +7948,7 @@
           <p:cNvPr id="28" name="">
             <a:extLst xmlns:a="http://schemas.openxmlformats.org/drawingml/2006/main">
               <a:ext uri="{FF2B5EF4-FFF2-40B4-BE49-F238E27FC236}">
-                <a16:creationId xmlns:a16="http://schemas.microsoft.com/office/drawing/2014/main" id="{5106AB3C-F005-49FB-BA14-D5B960996E8B}"/>
+                <a16:creationId xmlns:a16="http://schemas.microsoft.com/office/drawing/2014/main" id="{A87EF0DD-C393-424B-BE04-41E5398628EE}"/>
               </a:ext>
             </a:extLst>
           </p:cNvPr>
@@ -8012,7 +8012,7 @@
           <p:cNvPr id="29" name="">
             <a:extLst xmlns:a="http://schemas.openxmlformats.org/drawingml/2006/main">
               <a:ext uri="{FF2B5EF4-FFF2-40B4-BE49-F238E27FC236}">
-                <a16:creationId xmlns:a16="http://schemas.microsoft.com/office/drawing/2014/main" id="{D02E8889-A02E-43D4-86F0-006843C9D5F6}"/>
+                <a16:creationId xmlns:a16="http://schemas.microsoft.com/office/drawing/2014/main" id="{4DEE3C5B-70F1-4AA0-82D4-B57703872F09}"/>
               </a:ext>
             </a:extLst>
           </p:cNvPr>
@@ -8099,7 +8099,7 @@
           <p:cNvPr id="30" name="">
             <a:extLst xmlns:a="http://schemas.openxmlformats.org/drawingml/2006/main">
               <a:ext uri="{FF2B5EF4-FFF2-40B4-BE49-F238E27FC236}">
-                <a16:creationId xmlns:a16="http://schemas.microsoft.com/office/drawing/2014/main" id="{67686B1E-2E3D-416C-9DE1-3F78D7B4A7EB}"/>
+                <a16:creationId xmlns:a16="http://schemas.microsoft.com/office/drawing/2014/main" id="{B607D3D4-49F3-4D43-8F65-57E58B497DED}"/>
               </a:ext>
             </a:extLst>
           </p:cNvPr>
@@ -8132,7 +8132,7 @@
           <p:cNvPr id="31" name="">
             <a:extLst xmlns:a="http://schemas.openxmlformats.org/drawingml/2006/main">
               <a:ext uri="{FF2B5EF4-FFF2-40B4-BE49-F238E27FC236}">
-                <a16:creationId xmlns:a16="http://schemas.microsoft.com/office/drawing/2014/main" id="{25D360AD-D650-4E42-891D-CD47722C79A2}"/>
+                <a16:creationId xmlns:a16="http://schemas.microsoft.com/office/drawing/2014/main" id="{26D273B3-B49D-4C73-9F86-AE4458274CA5}"/>
               </a:ext>
             </a:extLst>
           </p:cNvPr>
@@ -8196,7 +8196,7 @@
           <p:cNvPr id="32" name="">
             <a:extLst xmlns:a="http://schemas.openxmlformats.org/drawingml/2006/main">
               <a:ext uri="{FF2B5EF4-FFF2-40B4-BE49-F238E27FC236}">
-                <a16:creationId xmlns:a16="http://schemas.microsoft.com/office/drawing/2014/main" id="{8D084FE0-DD60-48DE-BAAF-A0C65D248188}"/>
+                <a16:creationId xmlns:a16="http://schemas.microsoft.com/office/drawing/2014/main" id="{3D20B157-6373-4F42-8BE4-86441F3C4BE4}"/>
               </a:ext>
             </a:extLst>
           </p:cNvPr>
@@ -8306,7 +8306,7 @@
           <p:cNvPr id="33" name="">
             <a:extLst xmlns:a="http://schemas.openxmlformats.org/drawingml/2006/main">
               <a:ext uri="{FF2B5EF4-FFF2-40B4-BE49-F238E27FC236}">
-                <a16:creationId xmlns:a16="http://schemas.microsoft.com/office/drawing/2014/main" id="{7DCE9142-91EC-44BD-8389-02B113D2BEB7}"/>
+                <a16:creationId xmlns:a16="http://schemas.microsoft.com/office/drawing/2014/main" id="{1F13F730-AC6E-46D9-8D60-FE92796C3358}"/>
               </a:ext>
             </a:extLst>
           </p:cNvPr>
@@ -8339,7 +8339,7 @@
           <p:cNvPr id="34" name="">
             <a:extLst xmlns:a="http://schemas.openxmlformats.org/drawingml/2006/main">
               <a:ext uri="{FF2B5EF4-FFF2-40B4-BE49-F238E27FC236}">
-                <a16:creationId xmlns:a16="http://schemas.microsoft.com/office/drawing/2014/main" id="{3D025AAC-3D7A-421C-BE76-594D8FD471AE}"/>
+                <a16:creationId xmlns:a16="http://schemas.microsoft.com/office/drawing/2014/main" id="{EE262DA2-B470-4173-8D73-A1AD09619509}"/>
               </a:ext>
             </a:extLst>
           </p:cNvPr>
@@ -8403,7 +8403,7 @@
           <p:cNvPr id="35" name="">
             <a:extLst xmlns:a="http://schemas.openxmlformats.org/drawingml/2006/main">
               <a:ext uri="{FF2B5EF4-FFF2-40B4-BE49-F238E27FC236}">
-                <a16:creationId xmlns:a16="http://schemas.microsoft.com/office/drawing/2014/main" id="{C5FA9B46-18F5-4FF3-83A6-55C3107BF705}"/>
+                <a16:creationId xmlns:a16="http://schemas.microsoft.com/office/drawing/2014/main" id="{D842C678-C450-469B-A5A3-8DD34ECBA20F}"/>
               </a:ext>
             </a:extLst>
           </p:cNvPr>
@@ -8564,7 +8564,7 @@
           <p:cNvPr id="36" name="">
             <a:extLst xmlns:a="http://schemas.openxmlformats.org/drawingml/2006/main">
               <a:ext uri="{FF2B5EF4-FFF2-40B4-BE49-F238E27FC236}">
-                <a16:creationId xmlns:a16="http://schemas.microsoft.com/office/drawing/2014/main" id="{429B85EB-F13F-4CCF-A18F-94B5C2060682}"/>
+                <a16:creationId xmlns:a16="http://schemas.microsoft.com/office/drawing/2014/main" id="{5A31D69A-2E8D-4080-85BE-6DAB1292104B}"/>
               </a:ext>
             </a:extLst>
           </p:cNvPr>
@@ -8626,7 +8626,7 @@
     </p:spTree>
     <p:extLst>
       <p:ext uri="{BB962C8B-B14F-4D97-AF65-F5344CB8AC3E}">
-        <p14:creationId xmlns:p14="http://schemas.microsoft.com/office/powerpoint/2010/main" val="1762727829"/>
+        <p14:creationId xmlns:p14="http://schemas.microsoft.com/office/powerpoint/2010/main" val="379715571"/>
       </p:ext>
     </p:extLst>
   </p:cSld>
@@ -8650,7 +8650,7 @@
           <p:cNvPr id="1" name="">
             <a:extLst xmlns:a="http://schemas.openxmlformats.org/drawingml/2006/main">
               <a:ext uri="{FF2B5EF4-FFF2-40B4-BE49-F238E27FC236}">
-                <a16:creationId xmlns:a16="http://schemas.microsoft.com/office/drawing/2014/main" id="{A8B41167-1BD2-407A-9B1C-F8E81AD9C4E3}"/>
+                <a16:creationId xmlns:a16="http://schemas.microsoft.com/office/drawing/2014/main" id="{52D1A1A5-9408-4EB4-B902-6FD5C81A636A}"/>
               </a:ext>
             </a:extLst>
           </p:cNvPr>
@@ -8685,7 +8685,7 @@
           <p:cNvPr id="2" name="">
             <a:extLst xmlns:a="http://schemas.openxmlformats.org/drawingml/2006/main">
               <a:ext uri="{FF2B5EF4-FFF2-40B4-BE49-F238E27FC236}">
-                <a16:creationId xmlns:a16="http://schemas.microsoft.com/office/drawing/2014/main" id="{7FD08DAE-B3E0-4BD7-B9C8-6679D8E57194}"/>
+                <a16:creationId xmlns:a16="http://schemas.microsoft.com/office/drawing/2014/main" id="{B4F93533-679C-48D0-A7E6-427C20E69292}"/>
               </a:ext>
             </a:extLst>
           </p:cNvPr>
@@ -8720,7 +8720,7 @@
           <p:cNvPr id="3" name="">
             <a:extLst xmlns:a="http://schemas.openxmlformats.org/drawingml/2006/main">
               <a:ext uri="{FF2B5EF4-FFF2-40B4-BE49-F238E27FC236}">
-                <a16:creationId xmlns:a16="http://schemas.microsoft.com/office/drawing/2014/main" id="{CF9439AB-8151-4B72-A2E7-70948B376D67}"/>
+                <a16:creationId xmlns:a16="http://schemas.microsoft.com/office/drawing/2014/main" id="{6862049D-31FE-4D7C-BD30-01ADF4E8E344}"/>
               </a:ext>
             </a:extLst>
           </p:cNvPr>
@@ -8755,7 +8755,7 @@
           <p:cNvPr id="4" name="">
             <a:extLst xmlns:a="http://schemas.openxmlformats.org/drawingml/2006/main">
               <a:ext uri="{FF2B5EF4-FFF2-40B4-BE49-F238E27FC236}">
-                <a16:creationId xmlns:a16="http://schemas.microsoft.com/office/drawing/2014/main" id="{945A928B-B83D-4903-8534-26FFCA2E7121}"/>
+                <a16:creationId xmlns:a16="http://schemas.microsoft.com/office/drawing/2014/main" id="{97EF98F8-33A6-416E-9B3F-A3D4B9D78949}"/>
               </a:ext>
             </a:extLst>
           </p:cNvPr>
@@ -8819,7 +8819,7 @@
           <p:cNvPr id="5" name="">
             <a:extLst xmlns:a="http://schemas.openxmlformats.org/drawingml/2006/main">
               <a:ext uri="{FF2B5EF4-FFF2-40B4-BE49-F238E27FC236}">
-                <a16:creationId xmlns:a16="http://schemas.microsoft.com/office/drawing/2014/main" id="{CDED313D-376C-4EEA-805C-1721F55C24F7}"/>
+                <a16:creationId xmlns:a16="http://schemas.microsoft.com/office/drawing/2014/main" id="{0E6091EA-3A01-4902-B519-35044F5C348E}"/>
               </a:ext>
             </a:extLst>
           </p:cNvPr>
@@ -8854,7 +8854,7 @@
           <p:cNvPr id="6" name="">
             <a:extLst xmlns:a="http://schemas.openxmlformats.org/drawingml/2006/main">
               <a:ext uri="{FF2B5EF4-FFF2-40B4-BE49-F238E27FC236}">
-                <a16:creationId xmlns:a16="http://schemas.microsoft.com/office/drawing/2014/main" id="{34FEB2AE-ABBB-4F76-9AA2-6533C35B0159}"/>
+                <a16:creationId xmlns:a16="http://schemas.microsoft.com/office/drawing/2014/main" id="{C9498905-B885-4B1D-BB64-72A62D024EB1}"/>
               </a:ext>
             </a:extLst>
           </p:cNvPr>
@@ -8889,7 +8889,7 @@
           <p:cNvPr id="7" name="">
             <a:extLst xmlns:a="http://schemas.openxmlformats.org/drawingml/2006/main">
               <a:ext uri="{FF2B5EF4-FFF2-40B4-BE49-F238E27FC236}">
-                <a16:creationId xmlns:a16="http://schemas.microsoft.com/office/drawing/2014/main" id="{24D281FC-7E86-4A65-B843-2D80A3CC22A1}"/>
+                <a16:creationId xmlns:a16="http://schemas.microsoft.com/office/drawing/2014/main" id="{497F8630-F224-4860-AA81-2F5F7E306D3B}"/>
               </a:ext>
             </a:extLst>
           </p:cNvPr>
@@ -8924,7 +8924,7 @@
           <p:cNvPr id="8" name="">
             <a:extLst xmlns:a="http://schemas.openxmlformats.org/drawingml/2006/main">
               <a:ext uri="{FF2B5EF4-FFF2-40B4-BE49-F238E27FC236}">
-                <a16:creationId xmlns:a16="http://schemas.microsoft.com/office/drawing/2014/main" id="{8C369379-C55A-4C8C-A77B-4C48473D9B89}"/>
+                <a16:creationId xmlns:a16="http://schemas.microsoft.com/office/drawing/2014/main" id="{499D794E-DD80-4B43-8C24-9D4992201C60}"/>
               </a:ext>
             </a:extLst>
           </p:cNvPr>
@@ -8988,7 +8988,7 @@
           <p:cNvPr id="9" name="">
             <a:extLst xmlns:a="http://schemas.openxmlformats.org/drawingml/2006/main">
               <a:ext uri="{FF2B5EF4-FFF2-40B4-BE49-F238E27FC236}">
-                <a16:creationId xmlns:a16="http://schemas.microsoft.com/office/drawing/2014/main" id="{1A806617-F348-484B-855A-B0470850D432}"/>
+                <a16:creationId xmlns:a16="http://schemas.microsoft.com/office/drawing/2014/main" id="{7657CAA1-C434-415D-BCFE-4AA65537B39D}"/>
               </a:ext>
             </a:extLst>
           </p:cNvPr>
@@ -9052,7 +9052,7 @@
           <p:cNvPr id="10" name="">
             <a:extLst xmlns:a="http://schemas.openxmlformats.org/drawingml/2006/main">
               <a:ext uri="{FF2B5EF4-FFF2-40B4-BE49-F238E27FC236}">
-                <a16:creationId xmlns:a16="http://schemas.microsoft.com/office/drawing/2014/main" id="{A31C268E-AF45-4812-8DD4-9C71568A874D}"/>
+                <a16:creationId xmlns:a16="http://schemas.microsoft.com/office/drawing/2014/main" id="{214FDC41-1652-4E76-99BC-2C77DDD49D1E}"/>
               </a:ext>
             </a:extLst>
           </p:cNvPr>
@@ -9116,7 +9116,7 @@
           <p:cNvPr id="11" name="">
             <a:extLst xmlns:a="http://schemas.openxmlformats.org/drawingml/2006/main">
               <a:ext uri="{FF2B5EF4-FFF2-40B4-BE49-F238E27FC236}">
-                <a16:creationId xmlns:a16="http://schemas.microsoft.com/office/drawing/2014/main" id="{1F6120EA-7E83-480A-9FF1-59D6C12F4218}"/>
+                <a16:creationId xmlns:a16="http://schemas.microsoft.com/office/drawing/2014/main" id="{B6F9B2C2-08AC-4649-9A59-9FC023284640}"/>
               </a:ext>
             </a:extLst>
           </p:cNvPr>
@@ -9180,7 +9180,7 @@
           <p:cNvPr id="12" name="">
             <a:extLst xmlns:a="http://schemas.openxmlformats.org/drawingml/2006/main">
               <a:ext uri="{FF2B5EF4-FFF2-40B4-BE49-F238E27FC236}">
-                <a16:creationId xmlns:a16="http://schemas.microsoft.com/office/drawing/2014/main" id="{EFE3D0F0-5DBA-4392-9C7E-73EDE6814897}"/>
+                <a16:creationId xmlns:a16="http://schemas.microsoft.com/office/drawing/2014/main" id="{F04CEE46-75C8-4052-9C47-604F459BE2A3}"/>
               </a:ext>
             </a:extLst>
           </p:cNvPr>
@@ -9213,7 +9213,7 @@
           <p:cNvPr id="13" name="">
             <a:extLst xmlns:a="http://schemas.openxmlformats.org/drawingml/2006/main">
               <a:ext uri="{FF2B5EF4-FFF2-40B4-BE49-F238E27FC236}">
-                <a16:creationId xmlns:a16="http://schemas.microsoft.com/office/drawing/2014/main" id="{6203B986-E5A0-4A11-B8F3-DA1EBC460343}"/>
+                <a16:creationId xmlns:a16="http://schemas.microsoft.com/office/drawing/2014/main" id="{067EF87E-2E9C-475B-98C6-6691D01DED39}"/>
               </a:ext>
             </a:extLst>
           </p:cNvPr>
@@ -9277,7 +9277,7 @@
           <p:cNvPr id="14" name="">
             <a:extLst xmlns:a="http://schemas.openxmlformats.org/drawingml/2006/main">
               <a:ext uri="{FF2B5EF4-FFF2-40B4-BE49-F238E27FC236}">
-                <a16:creationId xmlns:a16="http://schemas.microsoft.com/office/drawing/2014/main" id="{0F870BC7-5798-4DB8-BBD7-8FA1D21F4E5C}"/>
+                <a16:creationId xmlns:a16="http://schemas.microsoft.com/office/drawing/2014/main" id="{F104A81B-7338-41ED-BE11-BC634EF35B4C}"/>
               </a:ext>
             </a:extLst>
           </p:cNvPr>
@@ -9341,7 +9341,7 @@
           <p:cNvPr id="15" name="">
             <a:extLst xmlns:a="http://schemas.openxmlformats.org/drawingml/2006/main">
               <a:ext uri="{FF2B5EF4-FFF2-40B4-BE49-F238E27FC236}">
-                <a16:creationId xmlns:a16="http://schemas.microsoft.com/office/drawing/2014/main" id="{ADE43C04-944C-4ED9-9555-9A43B5D8AB28}"/>
+                <a16:creationId xmlns:a16="http://schemas.microsoft.com/office/drawing/2014/main" id="{B8E1FFC3-9592-4C32-BC5E-AA8B0B6C65E3}"/>
               </a:ext>
             </a:extLst>
           </p:cNvPr>
@@ -9405,7 +9405,7 @@
           <p:cNvPr id="16" name="">
             <a:extLst xmlns:a="http://schemas.openxmlformats.org/drawingml/2006/main">
               <a:ext uri="{FF2B5EF4-FFF2-40B4-BE49-F238E27FC236}">
-                <a16:creationId xmlns:a16="http://schemas.microsoft.com/office/drawing/2014/main" id="{A50168AD-AB11-45B2-897B-D3C3704230C7}"/>
+                <a16:creationId xmlns:a16="http://schemas.microsoft.com/office/drawing/2014/main" id="{83BD7DB5-39BB-4D82-BBC4-E88367B91A49}"/>
               </a:ext>
             </a:extLst>
           </p:cNvPr>
@@ -9438,7 +9438,7 @@
           <p:cNvPr id="17" name="">
             <a:extLst xmlns:a="http://schemas.openxmlformats.org/drawingml/2006/main">
               <a:ext uri="{FF2B5EF4-FFF2-40B4-BE49-F238E27FC236}">
-                <a16:creationId xmlns:a16="http://schemas.microsoft.com/office/drawing/2014/main" id="{721367FF-8B9F-4214-86E6-C7959D36BE7D}"/>
+                <a16:creationId xmlns:a16="http://schemas.microsoft.com/office/drawing/2014/main" id="{7BE9A856-F163-4395-82C1-3CB55DFCA372}"/>
               </a:ext>
             </a:extLst>
           </p:cNvPr>
@@ -9502,7 +9502,7 @@
           <p:cNvPr id="18" name="">
             <a:extLst xmlns:a="http://schemas.openxmlformats.org/drawingml/2006/main">
               <a:ext uri="{FF2B5EF4-FFF2-40B4-BE49-F238E27FC236}">
-                <a16:creationId xmlns:a16="http://schemas.microsoft.com/office/drawing/2014/main" id="{ED3F6C80-28A8-47A0-88A2-573488EBDCC1}"/>
+                <a16:creationId xmlns:a16="http://schemas.microsoft.com/office/drawing/2014/main" id="{2CF8A47E-4384-4D69-8AAA-62021CF8E8F8}"/>
               </a:ext>
             </a:extLst>
           </p:cNvPr>
@@ -9635,7 +9635,7 @@
           <p:cNvPr id="19" name="">
             <a:extLst xmlns:a="http://schemas.openxmlformats.org/drawingml/2006/main">
               <a:ext uri="{FF2B5EF4-FFF2-40B4-BE49-F238E27FC236}">
-                <a16:creationId xmlns:a16="http://schemas.microsoft.com/office/drawing/2014/main" id="{FEECFC6E-8B36-440B-83E2-A012F3E36544}"/>
+                <a16:creationId xmlns:a16="http://schemas.microsoft.com/office/drawing/2014/main" id="{3D4264D1-1EC5-4DC0-8E92-C853B20E901B}"/>
               </a:ext>
             </a:extLst>
           </p:cNvPr>
@@ -9668,7 +9668,7 @@
           <p:cNvPr id="20" name="">
             <a:extLst xmlns:a="http://schemas.openxmlformats.org/drawingml/2006/main">
               <a:ext uri="{FF2B5EF4-FFF2-40B4-BE49-F238E27FC236}">
-                <a16:creationId xmlns:a16="http://schemas.microsoft.com/office/drawing/2014/main" id="{CDA3CC55-A7BC-442E-BA1B-27D23EC6F3C5}"/>
+                <a16:creationId xmlns:a16="http://schemas.microsoft.com/office/drawing/2014/main" id="{A9455D6C-6C23-4D5C-9771-389E0732C4E8}"/>
               </a:ext>
             </a:extLst>
           </p:cNvPr>
@@ -9732,7 +9732,7 @@
           <p:cNvPr id="21" name="">
             <a:extLst xmlns:a="http://schemas.openxmlformats.org/drawingml/2006/main">
               <a:ext uri="{FF2B5EF4-FFF2-40B4-BE49-F238E27FC236}">
-                <a16:creationId xmlns:a16="http://schemas.microsoft.com/office/drawing/2014/main" id="{A6401F1D-FAF9-4BCA-B921-7D9E3E077805}"/>
+                <a16:creationId xmlns:a16="http://schemas.microsoft.com/office/drawing/2014/main" id="{ABBB0A15-5A13-4E0D-89B8-F5F19F470B27}"/>
               </a:ext>
             </a:extLst>
           </p:cNvPr>
@@ -10008,7 +10008,7 @@
           <p:cNvPr id="22" name="">
             <a:extLst xmlns:a="http://schemas.openxmlformats.org/drawingml/2006/main">
               <a:ext uri="{FF2B5EF4-FFF2-40B4-BE49-F238E27FC236}">
-                <a16:creationId xmlns:a16="http://schemas.microsoft.com/office/drawing/2014/main" id="{CC5AB1E2-E366-442E-9288-9144BF30E330}"/>
+                <a16:creationId xmlns:a16="http://schemas.microsoft.com/office/drawing/2014/main" id="{6CF02B60-2E2A-41F8-96F8-68D618857A30}"/>
               </a:ext>
             </a:extLst>
           </p:cNvPr>
@@ -10041,7 +10041,7 @@
           <p:cNvPr id="23" name="">
             <a:extLst xmlns:a="http://schemas.openxmlformats.org/drawingml/2006/main">
               <a:ext uri="{FF2B5EF4-FFF2-40B4-BE49-F238E27FC236}">
-                <a16:creationId xmlns:a16="http://schemas.microsoft.com/office/drawing/2014/main" id="{7714B77D-E46D-4D33-BBD8-A6A0F1A578FD}"/>
+                <a16:creationId xmlns:a16="http://schemas.microsoft.com/office/drawing/2014/main" id="{2ACC051D-8B7D-4F98-AD18-7C51C708A97B}"/>
               </a:ext>
             </a:extLst>
           </p:cNvPr>
@@ -10105,7 +10105,7 @@
           <p:cNvPr id="24" name="">
             <a:extLst xmlns:a="http://schemas.openxmlformats.org/drawingml/2006/main">
               <a:ext uri="{FF2B5EF4-FFF2-40B4-BE49-F238E27FC236}">
-                <a16:creationId xmlns:a16="http://schemas.microsoft.com/office/drawing/2014/main" id="{43C4BF0C-E573-4B0A-9E2D-66BC03D01012}"/>
+                <a16:creationId xmlns:a16="http://schemas.microsoft.com/office/drawing/2014/main" id="{A8BE8200-D1EF-4F55-AA9B-F1EF4D6C1A7A}"/>
               </a:ext>
             </a:extLst>
           </p:cNvPr>
@@ -10284,7 +10284,7 @@
           <p:cNvPr id="25" name="">
             <a:extLst xmlns:a="http://schemas.openxmlformats.org/drawingml/2006/main">
               <a:ext uri="{FF2B5EF4-FFF2-40B4-BE49-F238E27FC236}">
-                <a16:creationId xmlns:a16="http://schemas.microsoft.com/office/drawing/2014/main" id="{B21BC499-6558-4679-9140-16D70220BF6D}"/>
+                <a16:creationId xmlns:a16="http://schemas.microsoft.com/office/drawing/2014/main" id="{918DE7D8-346B-4678-9ED8-0523D53D047D}"/>
               </a:ext>
             </a:extLst>
           </p:cNvPr>
@@ -10346,7 +10346,7 @@
     </p:spTree>
     <p:extLst>
       <p:ext uri="{BB962C8B-B14F-4D97-AF65-F5344CB8AC3E}">
-        <p14:creationId xmlns:p14="http://schemas.microsoft.com/office/powerpoint/2010/main" val="429805559"/>
+        <p14:creationId xmlns:p14="http://schemas.microsoft.com/office/powerpoint/2010/main" val="1786460006"/>
       </p:ext>
     </p:extLst>
   </p:cSld>
@@ -10370,7 +10370,7 @@
           <p:cNvPr id="1" name="">
             <a:extLst xmlns:a="http://schemas.openxmlformats.org/drawingml/2006/main">
               <a:ext uri="{FF2B5EF4-FFF2-40B4-BE49-F238E27FC236}">
-                <a16:creationId xmlns:a16="http://schemas.microsoft.com/office/drawing/2014/main" id="{64514198-6132-439D-98B4-7A6BE41A64D1}"/>
+                <a16:creationId xmlns:a16="http://schemas.microsoft.com/office/drawing/2014/main" id="{69DE0595-3C3A-4743-9B76-EB825356166C}"/>
               </a:ext>
             </a:extLst>
           </p:cNvPr>
@@ -10405,7 +10405,7 @@
           <p:cNvPr id="2" name="">
             <a:extLst xmlns:a="http://schemas.openxmlformats.org/drawingml/2006/main">
               <a:ext uri="{FF2B5EF4-FFF2-40B4-BE49-F238E27FC236}">
-                <a16:creationId xmlns:a16="http://schemas.microsoft.com/office/drawing/2014/main" id="{E5E89738-8079-4B02-ADB3-AD93B8766425}"/>
+                <a16:creationId xmlns:a16="http://schemas.microsoft.com/office/drawing/2014/main" id="{38CC1AD3-9B18-44EC-AA42-9C49A0A348BB}"/>
               </a:ext>
             </a:extLst>
           </p:cNvPr>
@@ -10440,7 +10440,7 @@
           <p:cNvPr id="3" name="">
             <a:extLst xmlns:a="http://schemas.openxmlformats.org/drawingml/2006/main">
               <a:ext uri="{FF2B5EF4-FFF2-40B4-BE49-F238E27FC236}">
-                <a16:creationId xmlns:a16="http://schemas.microsoft.com/office/drawing/2014/main" id="{5CB958A7-EB9B-48BA-BCF6-6676C8782DBF}"/>
+                <a16:creationId xmlns:a16="http://schemas.microsoft.com/office/drawing/2014/main" id="{4845AFE4-9724-46DC-8190-3025260E8EE4}"/>
               </a:ext>
             </a:extLst>
           </p:cNvPr>
@@ -10475,7 +10475,7 @@
           <p:cNvPr id="4" name="">
             <a:extLst xmlns:a="http://schemas.openxmlformats.org/drawingml/2006/main">
               <a:ext uri="{FF2B5EF4-FFF2-40B4-BE49-F238E27FC236}">
-                <a16:creationId xmlns:a16="http://schemas.microsoft.com/office/drawing/2014/main" id="{45C25CB1-6A6A-4888-89A2-ABCE4656A7BE}"/>
+                <a16:creationId xmlns:a16="http://schemas.microsoft.com/office/drawing/2014/main" id="{65AB7E37-4B9B-4853-A124-EEF1A78A06BC}"/>
               </a:ext>
             </a:extLst>
           </p:cNvPr>
@@ -10539,7 +10539,7 @@
           <p:cNvPr id="5" name="">
             <a:extLst xmlns:a="http://schemas.openxmlformats.org/drawingml/2006/main">
               <a:ext uri="{FF2B5EF4-FFF2-40B4-BE49-F238E27FC236}">
-                <a16:creationId xmlns:a16="http://schemas.microsoft.com/office/drawing/2014/main" id="{840A336C-5032-49FC-90D8-FC3A94908EB5}"/>
+                <a16:creationId xmlns:a16="http://schemas.microsoft.com/office/drawing/2014/main" id="{49724607-202E-4AE6-A9D2-C316169A0ED8}"/>
               </a:ext>
             </a:extLst>
           </p:cNvPr>
@@ -10574,7 +10574,7 @@
           <p:cNvPr id="6" name="">
             <a:extLst xmlns:a="http://schemas.openxmlformats.org/drawingml/2006/main">
               <a:ext uri="{FF2B5EF4-FFF2-40B4-BE49-F238E27FC236}">
-                <a16:creationId xmlns:a16="http://schemas.microsoft.com/office/drawing/2014/main" id="{07E23F1A-6A6A-456F-A829-A2206EB03223}"/>
+                <a16:creationId xmlns:a16="http://schemas.microsoft.com/office/drawing/2014/main" id="{B4E57C7C-20C0-409D-84E9-416995D94547}"/>
               </a:ext>
             </a:extLst>
           </p:cNvPr>
@@ -10609,7 +10609,7 @@
           <p:cNvPr id="7" name="">
             <a:extLst xmlns:a="http://schemas.openxmlformats.org/drawingml/2006/main">
               <a:ext uri="{FF2B5EF4-FFF2-40B4-BE49-F238E27FC236}">
-                <a16:creationId xmlns:a16="http://schemas.microsoft.com/office/drawing/2014/main" id="{CE13CAC2-97C2-4CE5-BB4D-A61EF0C3976D}"/>
+                <a16:creationId xmlns:a16="http://schemas.microsoft.com/office/drawing/2014/main" id="{D94EC750-74DC-48A8-9DD8-DF6B94C021D6}"/>
               </a:ext>
             </a:extLst>
           </p:cNvPr>
@@ -10644,7 +10644,7 @@
           <p:cNvPr id="8" name="">
             <a:extLst xmlns:a="http://schemas.openxmlformats.org/drawingml/2006/main">
               <a:ext uri="{FF2B5EF4-FFF2-40B4-BE49-F238E27FC236}">
-                <a16:creationId xmlns:a16="http://schemas.microsoft.com/office/drawing/2014/main" id="{4ABC65D1-85CB-4C83-9141-2C6C0E0CB19A}"/>
+                <a16:creationId xmlns:a16="http://schemas.microsoft.com/office/drawing/2014/main" id="{52EE08EF-A853-4E0D-8430-DBD47C633267}"/>
               </a:ext>
             </a:extLst>
           </p:cNvPr>
@@ -10708,7 +10708,7 @@
           <p:cNvPr id="9" name="">
             <a:extLst xmlns:a="http://schemas.openxmlformats.org/drawingml/2006/main">
               <a:ext uri="{FF2B5EF4-FFF2-40B4-BE49-F238E27FC236}">
-                <a16:creationId xmlns:a16="http://schemas.microsoft.com/office/drawing/2014/main" id="{E2253EB0-7CB7-48AC-ADCA-81B9A413D179}"/>
+                <a16:creationId xmlns:a16="http://schemas.microsoft.com/office/drawing/2014/main" id="{0EA5C2C4-318A-4B55-BC00-ADCB102984C8}"/>
               </a:ext>
             </a:extLst>
           </p:cNvPr>
@@ -10772,7 +10772,7 @@
           <p:cNvPr id="10" name="">
             <a:extLst xmlns:a="http://schemas.openxmlformats.org/drawingml/2006/main">
               <a:ext uri="{FF2B5EF4-FFF2-40B4-BE49-F238E27FC236}">
-                <a16:creationId xmlns:a16="http://schemas.microsoft.com/office/drawing/2014/main" id="{178637BD-6508-4387-BAAE-E0E343C4DCA6}"/>
+                <a16:creationId xmlns:a16="http://schemas.microsoft.com/office/drawing/2014/main" id="{E709B596-7C01-485F-8C2A-877D39903554}"/>
               </a:ext>
             </a:extLst>
           </p:cNvPr>
@@ -10826,7 +10826,7 @@
                 <a:ea typeface="Georgia"/>
                 <a:cs typeface="Georgia"/>
               </a:rPr>
-              <a:t>Before improving, sending a packet was not enough.</a:t>
+              <a:t>Full packets became heartbeat mode.</a:t>
             </a:r>
           </a:p>
         </p:txBody>
@@ -10836,7 +10836,7 @@
           <p:cNvPr id="11" name="">
             <a:extLst xmlns:a="http://schemas.openxmlformats.org/drawingml/2006/main">
               <a:ext uri="{FF2B5EF4-FFF2-40B4-BE49-F238E27FC236}">
-                <a16:creationId xmlns:a16="http://schemas.microsoft.com/office/drawing/2014/main" id="{145D2007-2466-422C-B93F-B6DB302B36ED}"/>
+                <a16:creationId xmlns:a16="http://schemas.microsoft.com/office/drawing/2014/main" id="{89B5EFC2-2F76-4BD2-AA71-74AAA369A21A}"/>
               </a:ext>
             </a:extLst>
           </p:cNvPr>
@@ -10890,7 +10890,7 @@
                 <a:ea typeface="Aptos"/>
                 <a:cs typeface="Aptos"/>
               </a:rPr>
-              <a:t>The first LoRa version proved connectivity, but the professor's point was reliability: what does the packet mean, and is it fresh?</a:t>
+              <a:t>First we sent complete telemetry periodically; the improvement separates traffic data from node-alive signals.</a:t>
             </a:r>
           </a:p>
         </p:txBody>
@@ -10900,7 +10900,7 @@
           <p:cNvPr id="12" name="">
             <a:extLst xmlns:a="http://schemas.openxmlformats.org/drawingml/2006/main">
               <a:ext uri="{FF2B5EF4-FFF2-40B4-BE49-F238E27FC236}">
-                <a16:creationId xmlns:a16="http://schemas.microsoft.com/office/drawing/2014/main" id="{16608A79-833A-4478-A8DA-839115DCACA3}"/>
+                <a16:creationId xmlns:a16="http://schemas.microsoft.com/office/drawing/2014/main" id="{9D660700-49EB-423B-B9AC-D7085EF98131}"/>
               </a:ext>
             </a:extLst>
           </p:cNvPr>
@@ -10933,7 +10933,7 @@
           <p:cNvPr id="13" name="">
             <a:extLst xmlns:a="http://schemas.openxmlformats.org/drawingml/2006/main">
               <a:ext uri="{FF2B5EF4-FFF2-40B4-BE49-F238E27FC236}">
-                <a16:creationId xmlns:a16="http://schemas.microsoft.com/office/drawing/2014/main" id="{8D9A2216-4F9C-4D4F-91F2-506761E3C44A}"/>
+                <a16:creationId xmlns:a16="http://schemas.microsoft.com/office/drawing/2014/main" id="{4016F9B2-F267-42B9-B3A5-C10EBF7E9BF0}"/>
               </a:ext>
             </a:extLst>
           </p:cNvPr>
@@ -10987,7 +10987,7 @@
                 <a:ea typeface="Aptos"/>
                 <a:cs typeface="Aptos"/>
               </a:rPr>
-              <a:t>Older payload accepted by the decoder</a:t>
+              <a:t>Before: full telemetry every 5 seconds</a:t>
             </a:r>
           </a:p>
         </p:txBody>
@@ -10997,7 +10997,7 @@
           <p:cNvPr id="14" name="">
             <a:extLst xmlns:a="http://schemas.openxmlformats.org/drawingml/2006/main">
               <a:ext uri="{FF2B5EF4-FFF2-40B4-BE49-F238E27FC236}">
-                <a16:creationId xmlns:a16="http://schemas.microsoft.com/office/drawing/2014/main" id="{42C8C87C-5291-4DF3-8E79-E496B52B7481}"/>
+                <a16:creationId xmlns:a16="http://schemas.microsoft.com/office/drawing/2014/main" id="{E08ADA78-3FE7-471F-84F2-CE4E78049FB6}"/>
               </a:ext>
             </a:extLst>
           </p:cNvPr>
@@ -11033,48 +11033,117 @@
           <a:lstStyle xmlns:a="http://schemas.openxmlformats.org/drawingml/2006/main"/>
           <a:p xmlns:a="http://schemas.openxmlformats.org/drawingml/2006/main">
             <a:pPr algn="l">
-              <a:defRPr sz="900" b="0">
-                <a:solidFill>
-                  <a:srgbClr val="172033"/>
-                </a:solidFill>
-                <a:latin typeface="Consolas"/>
-                <a:ea typeface="Consolas"/>
-                <a:cs typeface="Consolas"/>
-              </a:defRPr>
-            </a:pPr>
-            <a:r>
-              <a:rPr sz="900" b="0">
-                <a:solidFill>
-                  <a:srgbClr val="172033"/>
-                </a:solidFill>
-                <a:latin typeface="Consolas"/>
-                <a:ea typeface="Consolas"/>
-                <a:cs typeface="Consolas"/>
-              </a:rPr>
-              <a:t>A,farOccupied,nearOccupied,</a:t>
-            </a:r>
-          </a:p>
-          <a:p xmlns:a="http://schemas.openxmlformats.org/drawingml/2006/main">
-            <a:pPr algn="l">
-              <a:defRPr sz="900" b="0">
-                <a:solidFill>
-                  <a:srgbClr val="172033"/>
-                </a:solidFill>
-                <a:latin typeface="Consolas"/>
-                <a:ea typeface="Consolas"/>
-                <a:cs typeface="Consolas"/>
-              </a:defRPr>
-            </a:pPr>
-            <a:r>
-              <a:rPr sz="900" b="0">
-                <a:solidFill>
-                  <a:srgbClr val="172033"/>
-                </a:solidFill>
-                <a:latin typeface="Consolas"/>
-                <a:ea typeface="Consolas"/>
-                <a:cs typeface="Consolas"/>
-              </a:rPr>
-              <a:t>  incomingCount,passedCount,queue,timestampMs</a:t>
+              <a:defRPr sz="810" b="0">
+                <a:solidFill>
+                  <a:srgbClr val="172033"/>
+                </a:solidFill>
+                <a:latin typeface="Consolas"/>
+                <a:ea typeface="Consolas"/>
+                <a:cs typeface="Consolas"/>
+              </a:defRPr>
+            </a:pPr>
+            <a:r>
+              <a:rPr sz="810" b="0">
+                <a:solidFill>
+                  <a:srgbClr val="172033"/>
+                </a:solidFill>
+                <a:latin typeface="Consolas"/>
+                <a:ea typeface="Consolas"/>
+                <a:cs typeface="Consolas"/>
+              </a:rPr>
+              <a:t>if (nowMs - lastTelemetryMs &gt;= 5000) {</a:t>
+            </a:r>
+          </a:p>
+          <a:p xmlns:a="http://schemas.openxmlformats.org/drawingml/2006/main">
+            <a:pPr algn="l">
+              <a:defRPr sz="810" b="0">
+                <a:solidFill>
+                  <a:srgbClr val="172033"/>
+                </a:solidFill>
+                <a:latin typeface="Consolas"/>
+                <a:ea typeface="Consolas"/>
+                <a:cs typeface="Consolas"/>
+              </a:defRPr>
+            </a:pPr>
+            <a:r>
+              <a:rPr sz="810" b="0">
+                <a:solidFill>
+                  <a:srgbClr val="172033"/>
+                </a:solidFill>
+                <a:latin typeface="Consolas"/>
+                <a:ea typeface="Consolas"/>
+                <a:cs typeface="Consolas"/>
+              </a:rPr>
+              <a:t>  lastTelemetryMs = nowMs;</a:t>
+            </a:r>
+          </a:p>
+          <a:p xmlns:a="http://schemas.openxmlformats.org/drawingml/2006/main">
+            <a:pPr algn="l">
+              <a:defRPr sz="810" b="0">
+                <a:solidFill>
+                  <a:srgbClr val="172033"/>
+                </a:solidFill>
+                <a:latin typeface="Consolas"/>
+                <a:ea typeface="Consolas"/>
+                <a:cs typeface="Consolas"/>
+              </a:defRPr>
+            </a:pPr>
+            <a:r>
+              <a:rPr sz="810" b="0">
+                <a:solidFill>
+                  <a:srgbClr val="172033"/>
+                </a:solidFill>
+                <a:latin typeface="Consolas"/>
+                <a:ea typeface="Consolas"/>
+                <a:cs typeface="Consolas"/>
+              </a:rPr>
+              <a:t>  payload = encodeTelemetry(telemetry);</a:t>
+            </a:r>
+          </a:p>
+          <a:p xmlns:a="http://schemas.openxmlformats.org/drawingml/2006/main">
+            <a:pPr algn="l">
+              <a:defRPr sz="810" b="0">
+                <a:solidFill>
+                  <a:srgbClr val="172033"/>
+                </a:solidFill>
+                <a:latin typeface="Consolas"/>
+                <a:ea typeface="Consolas"/>
+                <a:cs typeface="Consolas"/>
+              </a:defRPr>
+            </a:pPr>
+            <a:r>
+              <a:rPr sz="810" b="0">
+                <a:solidFill>
+                  <a:srgbClr val="172033"/>
+                </a:solidFill>
+                <a:latin typeface="Consolas"/>
+                <a:ea typeface="Consolas"/>
+                <a:cs typeface="Consolas"/>
+              </a:rPr>
+              <a:t>  sendTelemetryOverLoRa(payload);</a:t>
+            </a:r>
+          </a:p>
+          <a:p xmlns:a="http://schemas.openxmlformats.org/drawingml/2006/main">
+            <a:pPr algn="l">
+              <a:defRPr sz="810" b="0">
+                <a:solidFill>
+                  <a:srgbClr val="172033"/>
+                </a:solidFill>
+                <a:latin typeface="Consolas"/>
+                <a:ea typeface="Consolas"/>
+                <a:cs typeface="Consolas"/>
+              </a:defRPr>
+            </a:pPr>
+            <a:r>
+              <a:rPr sz="810" b="0">
+                <a:solidFill>
+                  <a:srgbClr val="172033"/>
+                </a:solidFill>
+                <a:latin typeface="Consolas"/>
+                <a:ea typeface="Consolas"/>
+                <a:cs typeface="Consolas"/>
+              </a:rPr>
+              <a:t>}</a:t>
             </a:r>
           </a:p>
           <a:p xmlns:a="http://schemas.openxmlformats.org/drawingml/2006/main">
@@ -11084,40 +11153,63 @@
           </a:p>
           <a:p xmlns:a="http://schemas.openxmlformats.org/drawingml/2006/main">
             <a:pPr algn="l">
-              <a:defRPr sz="900" b="0">
-                <a:solidFill>
-                  <a:srgbClr val="172033"/>
-                </a:solidFill>
-                <a:latin typeface="Consolas"/>
-                <a:ea typeface="Consolas"/>
-                <a:cs typeface="Consolas"/>
-              </a:defRPr>
-            </a:pPr>
-            <a:r>
-              <a:rPr sz="900" b="0">
-                <a:solidFill>
-                  <a:srgbClr val="172033"/>
-                </a:solidFill>
-                <a:latin typeface="Consolas"/>
-                <a:ea typeface="Consolas"/>
-                <a:cs typeface="Consolas"/>
-              </a:rPr>
-              <a:t>Example:</a:t>
-            </a:r>
-          </a:p>
-          <a:p xmlns:a="http://schemas.openxmlformats.org/drawingml/2006/main">
-            <a:pPr algn="l">
-              <a:defRPr sz="900" b="0">
-                <a:solidFill>
-                  <a:srgbClr val="172033"/>
-                </a:solidFill>
-                <a:latin typeface="Consolas"/>
-                <a:ea typeface="Consolas"/>
-                <a:cs typeface="Consolas"/>
-              </a:defRPr>
-            </a:pPr>
-            <a:r>
-              <a:rPr sz="900" b="0">
+              <a:defRPr sz="810" b="0">
+                <a:solidFill>
+                  <a:srgbClr val="172033"/>
+                </a:solidFill>
+                <a:latin typeface="Consolas"/>
+                <a:ea typeface="Consolas"/>
+                <a:cs typeface="Consolas"/>
+              </a:defRPr>
+            </a:pPr>
+            <a:r>
+              <a:rPr sz="810" b="0">
+                <a:solidFill>
+                  <a:srgbClr val="172033"/>
+                </a:solidFill>
+                <a:latin typeface="Consolas"/>
+                <a:ea typeface="Consolas"/>
+                <a:cs typeface="Consolas"/>
+              </a:rPr>
+              <a:t>Old packet:</a:t>
+            </a:r>
+          </a:p>
+          <a:p xmlns:a="http://schemas.openxmlformats.org/drawingml/2006/main">
+            <a:pPr algn="l">
+              <a:defRPr sz="810" b="0">
+                <a:solidFill>
+                  <a:srgbClr val="172033"/>
+                </a:solidFill>
+                <a:latin typeface="Consolas"/>
+                <a:ea typeface="Consolas"/>
+                <a:cs typeface="Consolas"/>
+              </a:defRPr>
+            </a:pPr>
+            <a:r>
+              <a:rPr sz="810" b="0">
+                <a:solidFill>
+                  <a:srgbClr val="172033"/>
+                </a:solidFill>
+                <a:latin typeface="Consolas"/>
+                <a:ea typeface="Consolas"/>
+                <a:cs typeface="Consolas"/>
+              </a:rPr>
+              <a:t>A,farOcc,nearOcc,incoming,passed,queue,timestamp</a:t>
+            </a:r>
+          </a:p>
+          <a:p xmlns:a="http://schemas.openxmlformats.org/drawingml/2006/main">
+            <a:pPr algn="l">
+              <a:defRPr sz="810" b="0">
+                <a:solidFill>
+                  <a:srgbClr val="172033"/>
+                </a:solidFill>
+                <a:latin typeface="Consolas"/>
+                <a:ea typeface="Consolas"/>
+                <a:cs typeface="Consolas"/>
+              </a:defRPr>
+            </a:pPr>
+            <a:r>
+              <a:rPr sz="810" b="0">
                 <a:solidFill>
                   <a:srgbClr val="172033"/>
                 </a:solidFill>
@@ -11135,7 +11227,7 @@
           <p:cNvPr id="15" name="">
             <a:extLst xmlns:a="http://schemas.openxmlformats.org/drawingml/2006/main">
               <a:ext uri="{FF2B5EF4-FFF2-40B4-BE49-F238E27FC236}">
-                <a16:creationId xmlns:a16="http://schemas.microsoft.com/office/drawing/2014/main" id="{9238129F-2788-4B26-AD5C-E717CD5CEFFC}"/>
+                <a16:creationId xmlns:a16="http://schemas.microsoft.com/office/drawing/2014/main" id="{096AD93A-4356-4575-BBB2-95ABB736DB80}"/>
               </a:ext>
             </a:extLst>
           </p:cNvPr>
@@ -11168,7 +11260,7 @@
           <p:cNvPr id="16" name="">
             <a:extLst xmlns:a="http://schemas.openxmlformats.org/drawingml/2006/main">
               <a:ext uri="{FF2B5EF4-FFF2-40B4-BE49-F238E27FC236}">
-                <a16:creationId xmlns:a16="http://schemas.microsoft.com/office/drawing/2014/main" id="{13A0821F-1D0C-4007-8505-E87A9B8F1B52}"/>
+                <a16:creationId xmlns:a16="http://schemas.microsoft.com/office/drawing/2014/main" id="{0CEE3A65-7127-4481-A33E-607A00BC4BE8}"/>
               </a:ext>
             </a:extLst>
           </p:cNvPr>
@@ -11222,7 +11314,7 @@
                 <a:ea typeface="Aptos"/>
                 <a:cs typeface="Aptos"/>
               </a:rPr>
-              <a:t>NodeMessaging.cpp kept backward compatibility</a:t>
+              <a:t>Problem: silence looked like failure</a:t>
             </a:r>
           </a:p>
         </p:txBody>
@@ -11232,7 +11324,7 @@
           <p:cNvPr id="17" name="">
             <a:extLst xmlns:a="http://schemas.openxmlformats.org/drawingml/2006/main">
               <a:ext uri="{FF2B5EF4-FFF2-40B4-BE49-F238E27FC236}">
-                <a16:creationId xmlns:a16="http://schemas.microsoft.com/office/drawing/2014/main" id="{5A0C03C1-D71D-43C9-A286-5AFAE9155066}"/>
+                <a16:creationId xmlns:a16="http://schemas.microsoft.com/office/drawing/2014/main" id="{820E7A04-DBFF-45A8-B17A-B11D536CC26C}"/>
               </a:ext>
             </a:extLst>
           </p:cNvPr>
@@ -11268,163 +11360,191 @@
           <a:lstStyle xmlns:a="http://schemas.openxmlformats.org/drawingml/2006/main"/>
           <a:p xmlns:a="http://schemas.openxmlformats.org/drawingml/2006/main">
             <a:pPr algn="l">
-              <a:defRPr sz="750" b="0">
-                <a:solidFill>
-                  <a:srgbClr val="172033"/>
-                </a:solidFill>
-                <a:latin typeface="Consolas"/>
-                <a:ea typeface="Consolas"/>
-                <a:cs typeface="Consolas"/>
-              </a:defRPr>
-            </a:pPr>
-            <a:r>
-              <a:rPr sz="750" b="0">
-                <a:solidFill>
-                  <a:srgbClr val="172033"/>
-                </a:solidFill>
-                <a:latin typeface="Consolas"/>
-                <a:ea typeface="Consolas"/>
-                <a:cs typeface="Consolas"/>
-              </a:rPr>
-              <a:t>// Earliest payload without emergency flag or distances</a:t>
-            </a:r>
-          </a:p>
-          <a:p xmlns:a="http://schemas.openxmlformats.org/drawingml/2006/main">
-            <a:pPr algn="l">
-              <a:defRPr sz="750" b="0">
-                <a:solidFill>
-                  <a:srgbClr val="172033"/>
-                </a:solidFill>
-                <a:latin typeface="Consolas"/>
-                <a:ea typeface="Consolas"/>
-                <a:cs typeface="Consolas"/>
-              </a:defRPr>
-            </a:pPr>
-            <a:r>
-              <a:rPr sz="750" b="0">
-                <a:solidFill>
-                  <a:srgbClr val="172033"/>
-                </a:solidFill>
-                <a:latin typeface="Consolas"/>
-                <a:ea typeface="Consolas"/>
-                <a:cs typeface="Consolas"/>
-              </a:rPr>
-              <a:t>matched = sscanf(payload.c_str(),</a:t>
-            </a:r>
-          </a:p>
-          <a:p xmlns:a="http://schemas.openxmlformats.org/drawingml/2006/main">
-            <a:pPr algn="l">
-              <a:defRPr sz="750" b="0">
-                <a:solidFill>
-                  <a:srgbClr val="172033"/>
-                </a:solidFill>
-                <a:latin typeface="Consolas"/>
-                <a:ea typeface="Consolas"/>
-                <a:cs typeface="Consolas"/>
-              </a:defRPr>
-            </a:pPr>
-            <a:r>
-              <a:rPr sz="750" b="0">
-                <a:solidFill>
-                  <a:srgbClr val="172033"/>
-                </a:solidFill>
-                <a:latin typeface="Consolas"/>
-                <a:ea typeface="Consolas"/>
-                <a:cs typeface="Consolas"/>
-              </a:rPr>
-              <a:t>  "%c,%d,%d,%lu,%lu,%lu,%lu",</a:t>
-            </a:r>
-          </a:p>
-          <a:p xmlns:a="http://schemas.openxmlformats.org/drawingml/2006/main">
-            <a:pPr algn="l">
-              <a:defRPr sz="750" b="0">
-                <a:solidFill>
-                  <a:srgbClr val="172033"/>
-                </a:solidFill>
-                <a:latin typeface="Consolas"/>
-                <a:ea typeface="Consolas"/>
-                <a:cs typeface="Consolas"/>
-              </a:defRPr>
-            </a:pPr>
-            <a:r>
-              <a:rPr sz="750" b="0">
-                <a:solidFill>
-                  <a:srgbClr val="172033"/>
-                </a:solidFill>
-                <a:latin typeface="Consolas"/>
-                <a:ea typeface="Consolas"/>
-                <a:cs typeface="Consolas"/>
-              </a:rPr>
-              <a:t>  &amp;sideToken, &amp;farOccupied, &amp;nearOccupied,</a:t>
-            </a:r>
-          </a:p>
-          <a:p xmlns:a="http://schemas.openxmlformats.org/drawingml/2006/main">
-            <a:pPr algn="l">
-              <a:defRPr sz="750" b="0">
-                <a:solidFill>
-                  <a:srgbClr val="172033"/>
-                </a:solidFill>
-                <a:latin typeface="Consolas"/>
-                <a:ea typeface="Consolas"/>
-                <a:cs typeface="Consolas"/>
-              </a:defRPr>
-            </a:pPr>
-            <a:r>
-              <a:rPr sz="750" b="0">
-                <a:solidFill>
-                  <a:srgbClr val="172033"/>
-                </a:solidFill>
-                <a:latin typeface="Consolas"/>
-                <a:ea typeface="Consolas"/>
-                <a:cs typeface="Consolas"/>
-              </a:rPr>
-              <a:t>  &amp;incomingCount, &amp;passedCount,</a:t>
-            </a:r>
-          </a:p>
-          <a:p xmlns:a="http://schemas.openxmlformats.org/drawingml/2006/main">
-            <a:pPr algn="l">
-              <a:defRPr sz="750" b="0">
-                <a:solidFill>
-                  <a:srgbClr val="172033"/>
-                </a:solidFill>
-                <a:latin typeface="Consolas"/>
-                <a:ea typeface="Consolas"/>
-                <a:cs typeface="Consolas"/>
-              </a:defRPr>
-            </a:pPr>
-            <a:r>
-              <a:rPr sz="750" b="0">
-                <a:solidFill>
-                  <a:srgbClr val="172033"/>
-                </a:solidFill>
-                <a:latin typeface="Consolas"/>
-                <a:ea typeface="Consolas"/>
-                <a:cs typeface="Consolas"/>
-              </a:rPr>
-              <a:t>  &amp;estimatedQueue, &amp;timestampMs);</a:t>
-            </a:r>
-          </a:p>
-          <a:p xmlns:a="http://schemas.openxmlformats.org/drawingml/2006/main">
-            <a:pPr algn="l">
-              <a:defRPr sz="750" b="0">
-                <a:solidFill>
-                  <a:srgbClr val="172033"/>
-                </a:solidFill>
-                <a:latin typeface="Consolas"/>
-                <a:ea typeface="Consolas"/>
-                <a:cs typeface="Consolas"/>
-              </a:defRPr>
-            </a:pPr>
-            <a:r>
-              <a:rPr sz="750" b="0">
-                <a:solidFill>
-                  <a:srgbClr val="172033"/>
-                </a:solidFill>
-                <a:latin typeface="Consolas"/>
-                <a:ea typeface="Consolas"/>
-                <a:cs typeface="Consolas"/>
-              </a:rPr>
-              <a:t>emergencyRequested = 0;</a:t>
+              <a:defRPr sz="780" b="0">
+                <a:solidFill>
+                  <a:srgbClr val="172033"/>
+                </a:solidFill>
+                <a:latin typeface="Consolas"/>
+                <a:ea typeface="Consolas"/>
+                <a:cs typeface="Consolas"/>
+              </a:defRPr>
+            </a:pPr>
+            <a:r>
+              <a:rPr sz="780" b="0">
+                <a:solidFill>
+                  <a:srgbClr val="172033"/>
+                </a:solidFill>
+                <a:latin typeface="Consolas"/>
+                <a:ea typeface="Consolas"/>
+                <a:cs typeface="Consolas"/>
+              </a:rPr>
+              <a:t>// If packets stop, Node B cannot know why:</a:t>
+            </a:r>
+          </a:p>
+          <a:p xmlns:a="http://schemas.openxmlformats.org/drawingml/2006/main">
+            <a:pPr algn="l">
+              <a:defRPr sz="780" b="0">
+                <a:solidFill>
+                  <a:srgbClr val="172033"/>
+                </a:solidFill>
+                <a:latin typeface="Consolas"/>
+                <a:ea typeface="Consolas"/>
+                <a:cs typeface="Consolas"/>
+              </a:defRPr>
+            </a:pPr>
+            <a:r>
+              <a:rPr sz="780" b="0">
+                <a:solidFill>
+                  <a:srgbClr val="172033"/>
+                </a:solidFill>
+                <a:latin typeface="Consolas"/>
+                <a:ea typeface="Consolas"/>
+                <a:cs typeface="Consolas"/>
+              </a:rPr>
+              <a:t>// 1) no cars, so Node A is quiet</a:t>
+            </a:r>
+          </a:p>
+          <a:p xmlns:a="http://schemas.openxmlformats.org/drawingml/2006/main">
+            <a:pPr algn="l">
+              <a:defRPr sz="780" b="0">
+                <a:solidFill>
+                  <a:srgbClr val="172033"/>
+                </a:solidFill>
+                <a:latin typeface="Consolas"/>
+                <a:ea typeface="Consolas"/>
+                <a:cs typeface="Consolas"/>
+              </a:defRPr>
+            </a:pPr>
+            <a:r>
+              <a:rPr sz="780" b="0">
+                <a:solidFill>
+                  <a:srgbClr val="172033"/>
+                </a:solidFill>
+                <a:latin typeface="Consolas"/>
+                <a:ea typeface="Consolas"/>
+                <a:cs typeface="Consolas"/>
+              </a:rPr>
+              <a:t>// 2) Node A failed</a:t>
+            </a:r>
+          </a:p>
+          <a:p xmlns:a="http://schemas.openxmlformats.org/drawingml/2006/main">
+            <a:pPr algn="l">
+              <a:defRPr sz="780" b="0">
+                <a:solidFill>
+                  <a:srgbClr val="172033"/>
+                </a:solidFill>
+                <a:latin typeface="Consolas"/>
+                <a:ea typeface="Consolas"/>
+                <a:cs typeface="Consolas"/>
+              </a:defRPr>
+            </a:pPr>
+            <a:r>
+              <a:rPr sz="780" b="0">
+                <a:solidFill>
+                  <a:srgbClr val="172033"/>
+                </a:solidFill>
+                <a:latin typeface="Consolas"/>
+                <a:ea typeface="Consolas"/>
+                <a:cs typeface="Consolas"/>
+              </a:rPr>
+              <a:t>// 3) LoRa link failed</a:t>
+            </a:r>
+          </a:p>
+          <a:p xmlns:a="http://schemas.openxmlformats.org/drawingml/2006/main">
+            <a:r>
+              <a:t/>
+            </a:r>
+          </a:p>
+          <a:p xmlns:a="http://schemas.openxmlformats.org/drawingml/2006/main">
+            <a:pPr algn="l">
+              <a:defRPr sz="780" b="0">
+                <a:solidFill>
+                  <a:srgbClr val="172033"/>
+                </a:solidFill>
+                <a:latin typeface="Consolas"/>
+                <a:ea typeface="Consolas"/>
+                <a:cs typeface="Consolas"/>
+              </a:defRPr>
+            </a:pPr>
+            <a:r>
+              <a:rPr sz="780" b="0">
+                <a:solidFill>
+                  <a:srgbClr val="172033"/>
+                </a:solidFill>
+                <a:latin typeface="Consolas"/>
+                <a:ea typeface="Consolas"/>
+                <a:cs typeface="Consolas"/>
+              </a:rPr>
+              <a:t>if (nowMs - lastRemoteRxMs &gt; timeoutMs) {</a:t>
+            </a:r>
+          </a:p>
+          <a:p xmlns:a="http://schemas.openxmlformats.org/drawingml/2006/main">
+            <a:pPr algn="l">
+              <a:defRPr sz="780" b="0">
+                <a:solidFill>
+                  <a:srgbClr val="172033"/>
+                </a:solidFill>
+                <a:latin typeface="Consolas"/>
+                <a:ea typeface="Consolas"/>
+                <a:cs typeface="Consolas"/>
+              </a:defRPr>
+            </a:pPr>
+            <a:r>
+              <a:rPr sz="780" b="0">
+                <a:solidFill>
+                  <a:srgbClr val="172033"/>
+                </a:solidFill>
+                <a:latin typeface="Consolas"/>
+                <a:ea typeface="Consolas"/>
+                <a:cs typeface="Consolas"/>
+              </a:rPr>
+              <a:t>  lastRemoteSource = "LORA_STALE";</a:t>
+            </a:r>
+          </a:p>
+          <a:p xmlns:a="http://schemas.openxmlformats.org/drawingml/2006/main">
+            <a:pPr algn="l">
+              <a:defRPr sz="780" b="0">
+                <a:solidFill>
+                  <a:srgbClr val="172033"/>
+                </a:solidFill>
+                <a:latin typeface="Consolas"/>
+                <a:ea typeface="Consolas"/>
+                <a:cs typeface="Consolas"/>
+              </a:defRPr>
+            </a:pPr>
+            <a:r>
+              <a:rPr sz="780" b="0">
+                <a:solidFill>
+                  <a:srgbClr val="172033"/>
+                </a:solidFill>
+                <a:latin typeface="Consolas"/>
+                <a:ea typeface="Consolas"/>
+                <a:cs typeface="Consolas"/>
+              </a:rPr>
+              <a:t>  backup = ON;</a:t>
+            </a:r>
+          </a:p>
+          <a:p xmlns:a="http://schemas.openxmlformats.org/drawingml/2006/main">
+            <a:pPr algn="l">
+              <a:defRPr sz="780" b="0">
+                <a:solidFill>
+                  <a:srgbClr val="172033"/>
+                </a:solidFill>
+                <a:latin typeface="Consolas"/>
+                <a:ea typeface="Consolas"/>
+                <a:cs typeface="Consolas"/>
+              </a:defRPr>
+            </a:pPr>
+            <a:r>
+              <a:rPr sz="780" b="0">
+                <a:solidFill>
+                  <a:srgbClr val="172033"/>
+                </a:solidFill>
+                <a:latin typeface="Consolas"/>
+                <a:ea typeface="Consolas"/>
+                <a:cs typeface="Consolas"/>
+              </a:rPr>
+              <a:t>}</a:t>
             </a:r>
           </a:p>
         </p:txBody>
@@ -11434,7 +11554,7 @@
           <p:cNvPr id="18" name="">
             <a:extLst xmlns:a="http://schemas.openxmlformats.org/drawingml/2006/main">
               <a:ext uri="{FF2B5EF4-FFF2-40B4-BE49-F238E27FC236}">
-                <a16:creationId xmlns:a16="http://schemas.microsoft.com/office/drawing/2014/main" id="{76B801DE-8FB7-4661-943D-DA2E3BD52E97}"/>
+                <a16:creationId xmlns:a16="http://schemas.microsoft.com/office/drawing/2014/main" id="{38A1EF7E-3C70-4F29-AA35-0171E1CB6410}"/>
               </a:ext>
             </a:extLst>
           </p:cNvPr>
@@ -11467,7 +11587,7 @@
           <p:cNvPr id="19" name="">
             <a:extLst xmlns:a="http://schemas.openxmlformats.org/drawingml/2006/main">
               <a:ext uri="{FF2B5EF4-FFF2-40B4-BE49-F238E27FC236}">
-                <a16:creationId xmlns:a16="http://schemas.microsoft.com/office/drawing/2014/main" id="{314C458C-E6AE-4C4F-9D00-F70656E98819}"/>
+                <a16:creationId xmlns:a16="http://schemas.microsoft.com/office/drawing/2014/main" id="{EBFF2882-A787-4F16-9736-FF4AFEC34E7A}"/>
               </a:ext>
             </a:extLst>
           </p:cNvPr>
@@ -11531,7 +11651,7 @@
           <p:cNvPr id="20" name="">
             <a:extLst xmlns:a="http://schemas.openxmlformats.org/drawingml/2006/main">
               <a:ext uri="{FF2B5EF4-FFF2-40B4-BE49-F238E27FC236}">
-                <a16:creationId xmlns:a16="http://schemas.microsoft.com/office/drawing/2014/main" id="{B4BB0C30-2646-42BA-9472-6C0E77F253E1}"/>
+                <a16:creationId xmlns:a16="http://schemas.microsoft.com/office/drawing/2014/main" id="{FA4BD8E6-FB6D-4483-B61D-677DC2F86786}"/>
               </a:ext>
             </a:extLst>
           </p:cNvPr>
@@ -11585,7 +11705,7 @@
                 <a:ea typeface="Aptos"/>
                 <a:cs typeface="Aptos"/>
               </a:rPr>
-              <a:t>- no real distance values in the packet</a:t>
+              <a:t>- full packets even when nothing changed</a:t>
             </a:r>
           </a:p>
           <a:p xmlns:a="http://schemas.openxmlformats.org/drawingml/2006/main">
@@ -11608,7 +11728,7 @@
                 <a:ea typeface="Aptos"/>
                 <a:cs typeface="Aptos"/>
               </a:rPr>
-              <a:t>- no emergency field in earliest format</a:t>
+              <a:t>- silence could mean empty road or failure</a:t>
             </a:r>
           </a:p>
           <a:p xmlns:a="http://schemas.openxmlformats.org/drawingml/2006/main">
@@ -11631,7 +11751,7 @@
                 <a:ea typeface="Aptos"/>
                 <a:cs typeface="Aptos"/>
               </a:rPr>
-              <a:t>- no clear stale/fresh state for Node B</a:t>
+              <a:t>- no heartbeat meaning node alive / no traffic</a:t>
             </a:r>
           </a:p>
           <a:p xmlns:a="http://schemas.openxmlformats.org/drawingml/2006/main">
@@ -11654,7 +11774,7 @@
                 <a:ea typeface="Aptos"/>
                 <a:cs typeface="Aptos"/>
               </a:rPr>
-              <a:t>- no way to distinguish no traffic from no node</a:t>
+              <a:t>- no peak-hour low-traffic-message mode</a:t>
             </a:r>
           </a:p>
         </p:txBody>
@@ -11664,7 +11784,7 @@
           <p:cNvPr id="21" name="">
             <a:extLst xmlns:a="http://schemas.openxmlformats.org/drawingml/2006/main">
               <a:ext uri="{FF2B5EF4-FFF2-40B4-BE49-F238E27FC236}">
-                <a16:creationId xmlns:a16="http://schemas.microsoft.com/office/drawing/2014/main" id="{F8ECF823-372A-4059-A511-4C4853D3A8A9}"/>
+                <a16:creationId xmlns:a16="http://schemas.microsoft.com/office/drawing/2014/main" id="{F6DA260A-DA4A-46A4-87D7-BD706905A97F}"/>
               </a:ext>
             </a:extLst>
           </p:cNvPr>
@@ -11697,7 +11817,7 @@
           <p:cNvPr id="22" name="">
             <a:extLst xmlns:a="http://schemas.openxmlformats.org/drawingml/2006/main">
               <a:ext uri="{FF2B5EF4-FFF2-40B4-BE49-F238E27FC236}">
-                <a16:creationId xmlns:a16="http://schemas.microsoft.com/office/drawing/2014/main" id="{6CACE4C3-73F5-4C2C-A445-4C07CBB364E5}"/>
+                <a16:creationId xmlns:a16="http://schemas.microsoft.com/office/drawing/2014/main" id="{0583923D-9482-4288-826E-FE1BFFDC0D91}"/>
               </a:ext>
             </a:extLst>
           </p:cNvPr>
@@ -11761,7 +11881,7 @@
           <p:cNvPr id="23" name="">
             <a:extLst xmlns:a="http://schemas.openxmlformats.org/drawingml/2006/main">
               <a:ext uri="{FF2B5EF4-FFF2-40B4-BE49-F238E27FC236}">
-                <a16:creationId xmlns:a16="http://schemas.microsoft.com/office/drawing/2014/main" id="{83B5FBCB-A060-4E89-8245-EA3EC51D941C}"/>
+                <a16:creationId xmlns:a16="http://schemas.microsoft.com/office/drawing/2014/main" id="{03111AC9-49ED-45D2-9D17-282CF56C7D26}"/>
               </a:ext>
             </a:extLst>
           </p:cNvPr>
@@ -11815,7 +11935,7 @@
                 <a:ea typeface="Aptos"/>
                 <a:cs typeface="Aptos"/>
               </a:rPr>
-              <a:t>- false positives cannot be measured from a packet alone</a:t>
+              <a:t>- LoRa traffic wastes energy when repeated state is unchanged</a:t>
             </a:r>
           </a:p>
           <a:p xmlns:a="http://schemas.openxmlformats.org/drawingml/2006/main">
@@ -11838,7 +11958,7 @@
                 <a:ea typeface="Aptos"/>
                 <a:cs typeface="Aptos"/>
               </a:rPr>
-              <a:t>- old packets can create a phantom queue</a:t>
+              <a:t>- stale detection can conflict with energy saving</a:t>
             </a:r>
           </a:p>
           <a:p xmlns:a="http://schemas.openxmlformats.org/drawingml/2006/main">
@@ -11861,7 +11981,7 @@
                 <a:ea typeface="Aptos"/>
                 <a:cs typeface="Aptos"/>
               </a:rPr>
-              <a:t>- energy saving by silence can look like failure</a:t>
+              <a:t>- backup mode may activate even when the road is simply empty</a:t>
             </a:r>
           </a:p>
           <a:p xmlns:a="http://schemas.openxmlformats.org/drawingml/2006/main">
@@ -11884,7 +12004,7 @@
                 <a:ea typeface="Aptos"/>
                 <a:cs typeface="Aptos"/>
               </a:rPr>
-              <a:t>- logs need enough fields for CSV evaluation</a:t>
+              <a:t>- we need reliability and energy saving together</a:t>
             </a:r>
           </a:p>
         </p:txBody>
@@ -11894,7 +12014,7 @@
           <p:cNvPr id="24" name="">
             <a:extLst xmlns:a="http://schemas.openxmlformats.org/drawingml/2006/main">
               <a:ext uri="{FF2B5EF4-FFF2-40B4-BE49-F238E27FC236}">
-                <a16:creationId xmlns:a16="http://schemas.microsoft.com/office/drawing/2014/main" id="{8F1A1E40-706D-4D03-951D-54E5DEA19F13}"/>
+                <a16:creationId xmlns:a16="http://schemas.microsoft.com/office/drawing/2014/main" id="{A7090EC9-BC29-4AB2-977B-A0A4812670BA}"/>
               </a:ext>
             </a:extLst>
           </p:cNvPr>
@@ -11927,7 +12047,7 @@
           <p:cNvPr id="25" name="">
             <a:extLst xmlns:a="http://schemas.openxmlformats.org/drawingml/2006/main">
               <a:ext uri="{FF2B5EF4-FFF2-40B4-BE49-F238E27FC236}">
-                <a16:creationId xmlns:a16="http://schemas.microsoft.com/office/drawing/2014/main" id="{7331539A-D099-4C4A-8A50-4B6DE4E30424}"/>
+                <a16:creationId xmlns:a16="http://schemas.microsoft.com/office/drawing/2014/main" id="{1D9280BA-48C8-4E4A-BCC3-86C2979F14C7}"/>
               </a:ext>
             </a:extLst>
           </p:cNvPr>
@@ -11981,7 +12101,7 @@
                 <a:ea typeface="Georgia"/>
                 <a:cs typeface="Georgia"/>
               </a:rPr>
-              <a:t>Transition to the final version</a:t>
+              <a:t>Energy-aware transition</a:t>
             </a:r>
           </a:p>
         </p:txBody>
@@ -11991,7 +12111,7 @@
           <p:cNvPr id="26" name="">
             <a:extLst xmlns:a="http://schemas.openxmlformats.org/drawingml/2006/main">
               <a:ext uri="{FF2B5EF4-FFF2-40B4-BE49-F238E27FC236}">
-                <a16:creationId xmlns:a16="http://schemas.microsoft.com/office/drawing/2014/main" id="{FDD87EAC-3A58-4580-99DE-718A3A794347}"/>
+                <a16:creationId xmlns:a16="http://schemas.microsoft.com/office/drawing/2014/main" id="{C73CED25-975A-4C21-89EE-CD6F1A648A4C}"/>
               </a:ext>
             </a:extLst>
           </p:cNvPr>
@@ -12027,25 +12147,25 @@
           <a:lstStyle xmlns:a="http://schemas.openxmlformats.org/drawingml/2006/main"/>
           <a:p xmlns:a="http://schemas.openxmlformats.org/drawingml/2006/main">
             <a:pPr algn="l">
-              <a:defRPr sz="975" b="0">
-                <a:solidFill>
-                  <a:srgbClr val="172033"/>
-                </a:solidFill>
-                <a:latin typeface="Aptos"/>
-                <a:ea typeface="Aptos"/>
-                <a:cs typeface="Aptos"/>
-              </a:defRPr>
-            </a:pPr>
-            <a:r>
-              <a:rPr sz="975" b="0">
-                <a:solidFill>
-                  <a:srgbClr val="172033"/>
-                </a:solidFill>
-                <a:latin typeface="Aptos"/>
-                <a:ea typeface="Aptos"/>
-                <a:cs typeface="Aptos"/>
-              </a:rPr>
-              <a:t>The next version adds distances, emergency state, stale detection, backup behavior, and a clean live log. That turns LoRa from a demo packet into useful IoT telemetry.</a:t>
+              <a:defRPr sz="915" b="0">
+                <a:solidFill>
+                  <a:srgbClr val="172033"/>
+                </a:solidFill>
+                <a:latin typeface="Aptos"/>
+                <a:ea typeface="Aptos"/>
+                <a:cs typeface="Aptos"/>
+              </a:defRPr>
+            </a:pPr>
+            <a:r>
+              <a:rPr sz="915" b="0">
+                <a:solidFill>
+                  <a:srgbClr val="172033"/>
+                </a:solidFill>
+                <a:latin typeface="Aptos"/>
+                <a:ea typeface="Aptos"/>
+                <a:cs typeface="Aptos"/>
+              </a:rPr>
+              <a:t>Active mode sends full telemetry. Idle or peak-saturated mode sends heartbeat only every long period. Node B keeps controlling the LEDs locally, while heartbeat proves both nodes are alive.</a:t>
             </a:r>
           </a:p>
         </p:txBody>
@@ -12055,7 +12175,7 @@
           <p:cNvPr id="27" name="">
             <a:extLst xmlns:a="http://schemas.openxmlformats.org/drawingml/2006/main">
               <a:ext uri="{FF2B5EF4-FFF2-40B4-BE49-F238E27FC236}">
-                <a16:creationId xmlns:a16="http://schemas.microsoft.com/office/drawing/2014/main" id="{59D2534D-C961-4167-8018-17F967BA8D0C}"/>
+                <a16:creationId xmlns:a16="http://schemas.microsoft.com/office/drawing/2014/main" id="{064EAAA5-4B22-4878-B0C5-ED909D93C9A5}"/>
               </a:ext>
             </a:extLst>
           </p:cNvPr>
@@ -12109,7 +12229,7 @@
                 <a:ea typeface="Aptos"/>
                 <a:cs typeface="Aptos"/>
               </a:rPr>
-              <a:t>Speaker message: this is the process slide. We can honestly say the first version was not enough, then show exactly what we changed.</a:t>
+              <a:t>Speaker message: the improvement is not just fewer packets. It separates traffic telemetry from health heartbeat, so energy saving does not break failure detection.</a:t>
             </a:r>
           </a:p>
         </p:txBody>
@@ -12117,7 +12237,7 @@
     </p:spTree>
     <p:extLst>
       <p:ext uri="{BB962C8B-B14F-4D97-AF65-F5344CB8AC3E}">
-        <p14:creationId xmlns:p14="http://schemas.microsoft.com/office/powerpoint/2010/main" val="1937034247"/>
+        <p14:creationId xmlns:p14="http://schemas.microsoft.com/office/powerpoint/2010/main" val="859671967"/>
       </p:ext>
     </p:extLst>
   </p:cSld>
@@ -12141,7 +12261,7 @@
           <p:cNvPr id="1" name="">
             <a:extLst xmlns:a="http://schemas.openxmlformats.org/drawingml/2006/main">
               <a:ext uri="{FF2B5EF4-FFF2-40B4-BE49-F238E27FC236}">
-                <a16:creationId xmlns:a16="http://schemas.microsoft.com/office/drawing/2014/main" id="{CFBA86D0-37CC-47DC-9308-46B0436FA7B3}"/>
+                <a16:creationId xmlns:a16="http://schemas.microsoft.com/office/drawing/2014/main" id="{A7808FBE-A1BD-41E3-801B-D8B195E87FFF}"/>
               </a:ext>
             </a:extLst>
           </p:cNvPr>
@@ -12176,7 +12296,7 @@
           <p:cNvPr id="2" name="">
             <a:extLst xmlns:a="http://schemas.openxmlformats.org/drawingml/2006/main">
               <a:ext uri="{FF2B5EF4-FFF2-40B4-BE49-F238E27FC236}">
-                <a16:creationId xmlns:a16="http://schemas.microsoft.com/office/drawing/2014/main" id="{CEF8B4E7-D9EA-4B6D-AE1B-E40B64E6E793}"/>
+                <a16:creationId xmlns:a16="http://schemas.microsoft.com/office/drawing/2014/main" id="{BEA781C5-BE2A-4890-9A29-2A7383E027F1}"/>
               </a:ext>
             </a:extLst>
           </p:cNvPr>
@@ -12211,7 +12331,7 @@
           <p:cNvPr id="3" name="">
             <a:extLst xmlns:a="http://schemas.openxmlformats.org/drawingml/2006/main">
               <a:ext uri="{FF2B5EF4-FFF2-40B4-BE49-F238E27FC236}">
-                <a16:creationId xmlns:a16="http://schemas.microsoft.com/office/drawing/2014/main" id="{06EC531B-5E8F-48E7-A18E-D67D0C99BB25}"/>
+                <a16:creationId xmlns:a16="http://schemas.microsoft.com/office/drawing/2014/main" id="{8B1142AC-69A0-432F-BD8F-68D14FE87EF6}"/>
               </a:ext>
             </a:extLst>
           </p:cNvPr>
@@ -12246,7 +12366,7 @@
           <p:cNvPr id="4" name="">
             <a:extLst xmlns:a="http://schemas.openxmlformats.org/drawingml/2006/main">
               <a:ext uri="{FF2B5EF4-FFF2-40B4-BE49-F238E27FC236}">
-                <a16:creationId xmlns:a16="http://schemas.microsoft.com/office/drawing/2014/main" id="{8C5892E2-E33F-45AB-AD12-5A371A91A528}"/>
+                <a16:creationId xmlns:a16="http://schemas.microsoft.com/office/drawing/2014/main" id="{B300C081-8BAB-48AA-9520-3C5EB0F5E262}"/>
               </a:ext>
             </a:extLst>
           </p:cNvPr>
@@ -12310,7 +12430,7 @@
           <p:cNvPr id="5" name="">
             <a:extLst xmlns:a="http://schemas.openxmlformats.org/drawingml/2006/main">
               <a:ext uri="{FF2B5EF4-FFF2-40B4-BE49-F238E27FC236}">
-                <a16:creationId xmlns:a16="http://schemas.microsoft.com/office/drawing/2014/main" id="{C0A79FF0-EAEF-4D73-8019-D273AE09C852}"/>
+                <a16:creationId xmlns:a16="http://schemas.microsoft.com/office/drawing/2014/main" id="{ABEBB015-43C2-4C5E-B8B6-3F8BC9E1D085}"/>
               </a:ext>
             </a:extLst>
           </p:cNvPr>
@@ -12345,7 +12465,7 @@
           <p:cNvPr id="6" name="">
             <a:extLst xmlns:a="http://schemas.openxmlformats.org/drawingml/2006/main">
               <a:ext uri="{FF2B5EF4-FFF2-40B4-BE49-F238E27FC236}">
-                <a16:creationId xmlns:a16="http://schemas.microsoft.com/office/drawing/2014/main" id="{9F894B64-D302-4715-8498-A3C09642AEAC}"/>
+                <a16:creationId xmlns:a16="http://schemas.microsoft.com/office/drawing/2014/main" id="{2FCADE72-33D6-462A-80CE-48293DF6DEB8}"/>
               </a:ext>
             </a:extLst>
           </p:cNvPr>
@@ -12380,7 +12500,7 @@
           <p:cNvPr id="7" name="">
             <a:extLst xmlns:a="http://schemas.openxmlformats.org/drawingml/2006/main">
               <a:ext uri="{FF2B5EF4-FFF2-40B4-BE49-F238E27FC236}">
-                <a16:creationId xmlns:a16="http://schemas.microsoft.com/office/drawing/2014/main" id="{8B204A2C-3050-4431-87D3-E82F250E2043}"/>
+                <a16:creationId xmlns:a16="http://schemas.microsoft.com/office/drawing/2014/main" id="{52AC471C-FA79-466C-AB72-A5F11B3B8FC2}"/>
               </a:ext>
             </a:extLst>
           </p:cNvPr>
@@ -12415,7 +12535,7 @@
           <p:cNvPr id="8" name="">
             <a:extLst xmlns:a="http://schemas.openxmlformats.org/drawingml/2006/main">
               <a:ext uri="{FF2B5EF4-FFF2-40B4-BE49-F238E27FC236}">
-                <a16:creationId xmlns:a16="http://schemas.microsoft.com/office/drawing/2014/main" id="{00AB6E7D-F693-4DBE-B6A0-27E46DD1A7BE}"/>
+                <a16:creationId xmlns:a16="http://schemas.microsoft.com/office/drawing/2014/main" id="{B4F90255-323B-4457-B41F-85E2BC8568CB}"/>
               </a:ext>
             </a:extLst>
           </p:cNvPr>
@@ -12479,7 +12599,7 @@
           <p:cNvPr id="9" name="">
             <a:extLst xmlns:a="http://schemas.openxmlformats.org/drawingml/2006/main">
               <a:ext uri="{FF2B5EF4-FFF2-40B4-BE49-F238E27FC236}">
-                <a16:creationId xmlns:a16="http://schemas.microsoft.com/office/drawing/2014/main" id="{300795C3-B57D-4ECE-9E17-094634A93908}"/>
+                <a16:creationId xmlns:a16="http://schemas.microsoft.com/office/drawing/2014/main" id="{ACCCB533-C59A-4FF3-995C-9C93B31E8534}"/>
               </a:ext>
             </a:extLst>
           </p:cNvPr>
@@ -12543,7 +12663,7 @@
           <p:cNvPr id="10" name="">
             <a:extLst xmlns:a="http://schemas.openxmlformats.org/drawingml/2006/main">
               <a:ext uri="{FF2B5EF4-FFF2-40B4-BE49-F238E27FC236}">
-                <a16:creationId xmlns:a16="http://schemas.microsoft.com/office/drawing/2014/main" id="{969EB997-7F45-44FB-BC1D-1836DEB628CE}"/>
+                <a16:creationId xmlns:a16="http://schemas.microsoft.com/office/drawing/2014/main" id="{DBDB8692-25FD-4543-9C95-649151204843}"/>
               </a:ext>
             </a:extLst>
           </p:cNvPr>
@@ -12607,7 +12727,7 @@
           <p:cNvPr id="11" name="">
             <a:extLst xmlns:a="http://schemas.openxmlformats.org/drawingml/2006/main">
               <a:ext uri="{FF2B5EF4-FFF2-40B4-BE49-F238E27FC236}">
-                <a16:creationId xmlns:a16="http://schemas.microsoft.com/office/drawing/2014/main" id="{F85714C6-2C4D-4FBF-99E8-4BB3F2A1B023}"/>
+                <a16:creationId xmlns:a16="http://schemas.microsoft.com/office/drawing/2014/main" id="{E5689D8A-5FDF-4618-B974-44AAB5F54DDA}"/>
               </a:ext>
             </a:extLst>
           </p:cNvPr>
@@ -12671,7 +12791,7 @@
           <p:cNvPr id="12" name="">
             <a:extLst xmlns:a="http://schemas.openxmlformats.org/drawingml/2006/main">
               <a:ext uri="{FF2B5EF4-FFF2-40B4-BE49-F238E27FC236}">
-                <a16:creationId xmlns:a16="http://schemas.microsoft.com/office/drawing/2014/main" id="{01C52D85-A8A1-4824-8E93-AC196A7244E0}"/>
+                <a16:creationId xmlns:a16="http://schemas.microsoft.com/office/drawing/2014/main" id="{985A39E3-B733-470A-A8C2-B4B2DF627AAA}"/>
               </a:ext>
             </a:extLst>
           </p:cNvPr>
@@ -12704,7 +12824,7 @@
           <p:cNvPr id="13" name="">
             <a:extLst xmlns:a="http://schemas.openxmlformats.org/drawingml/2006/main">
               <a:ext uri="{FF2B5EF4-FFF2-40B4-BE49-F238E27FC236}">
-                <a16:creationId xmlns:a16="http://schemas.microsoft.com/office/drawing/2014/main" id="{FA3B57C3-D4F0-4E84-AEE9-0D6BE8181423}"/>
+                <a16:creationId xmlns:a16="http://schemas.microsoft.com/office/drawing/2014/main" id="{07E7ECBD-35B7-4D33-905C-C72F009E59AA}"/>
               </a:ext>
             </a:extLst>
           </p:cNvPr>
@@ -12768,7 +12888,7 @@
           <p:cNvPr id="14" name="">
             <a:extLst xmlns:a="http://schemas.openxmlformats.org/drawingml/2006/main">
               <a:ext uri="{FF2B5EF4-FFF2-40B4-BE49-F238E27FC236}">
-                <a16:creationId xmlns:a16="http://schemas.microsoft.com/office/drawing/2014/main" id="{7DB6DC85-982A-4417-A002-778885D1B015}"/>
+                <a16:creationId xmlns:a16="http://schemas.microsoft.com/office/drawing/2014/main" id="{4F15F6CB-EE17-43DB-ACA1-0D7A4F32D025}"/>
               </a:ext>
             </a:extLst>
           </p:cNvPr>
@@ -12906,7 +13026,7 @@
           <p:cNvPr id="15" name="">
             <a:extLst xmlns:a="http://schemas.openxmlformats.org/drawingml/2006/main">
               <a:ext uri="{FF2B5EF4-FFF2-40B4-BE49-F238E27FC236}">
-                <a16:creationId xmlns:a16="http://schemas.microsoft.com/office/drawing/2014/main" id="{84E39DF4-FE3E-4AC9-9662-D1FD9991C3A0}"/>
+                <a16:creationId xmlns:a16="http://schemas.microsoft.com/office/drawing/2014/main" id="{064C4D97-E82D-4ED2-823F-11DF5EF74BB5}"/>
               </a:ext>
             </a:extLst>
           </p:cNvPr>
@@ -12939,7 +13059,7 @@
           <p:cNvPr id="16" name="">
             <a:extLst xmlns:a="http://schemas.openxmlformats.org/drawingml/2006/main">
               <a:ext uri="{FF2B5EF4-FFF2-40B4-BE49-F238E27FC236}">
-                <a16:creationId xmlns:a16="http://schemas.microsoft.com/office/drawing/2014/main" id="{2C0F8525-0EC0-4969-B28B-DB25F880E0D5}"/>
+                <a16:creationId xmlns:a16="http://schemas.microsoft.com/office/drawing/2014/main" id="{2D36E857-8B41-4B5C-96D9-E98375DF0709}"/>
               </a:ext>
             </a:extLst>
           </p:cNvPr>
@@ -13003,7 +13123,7 @@
           <p:cNvPr id="17" name="">
             <a:extLst xmlns:a="http://schemas.openxmlformats.org/drawingml/2006/main">
               <a:ext uri="{FF2B5EF4-FFF2-40B4-BE49-F238E27FC236}">
-                <a16:creationId xmlns:a16="http://schemas.microsoft.com/office/drawing/2014/main" id="{B751ECAB-A539-434B-897D-F24505F33001}"/>
+                <a16:creationId xmlns:a16="http://schemas.microsoft.com/office/drawing/2014/main" id="{C05B4928-F894-40E6-A394-34E2032D79BD}"/>
               </a:ext>
             </a:extLst>
           </p:cNvPr>
@@ -13274,7 +13394,7 @@
           <p:cNvPr id="18" name="">
             <a:extLst xmlns:a="http://schemas.openxmlformats.org/drawingml/2006/main">
               <a:ext uri="{FF2B5EF4-FFF2-40B4-BE49-F238E27FC236}">
-                <a16:creationId xmlns:a16="http://schemas.microsoft.com/office/drawing/2014/main" id="{A6EE6319-8AA3-405E-9F4B-C9C3026827F9}"/>
+                <a16:creationId xmlns:a16="http://schemas.microsoft.com/office/drawing/2014/main" id="{71E7652D-9ACA-4E81-9B0C-5F8CA2098E9A}"/>
               </a:ext>
             </a:extLst>
           </p:cNvPr>
@@ -13307,7 +13427,7 @@
           <p:cNvPr id="19" name="">
             <a:extLst xmlns:a="http://schemas.openxmlformats.org/drawingml/2006/main">
               <a:ext uri="{FF2B5EF4-FFF2-40B4-BE49-F238E27FC236}">
-                <a16:creationId xmlns:a16="http://schemas.microsoft.com/office/drawing/2014/main" id="{77CE8A7A-3014-427D-BA0C-4C4570639F25}"/>
+                <a16:creationId xmlns:a16="http://schemas.microsoft.com/office/drawing/2014/main" id="{5B0EDB03-EE65-417B-A0EA-E9351DECCAC8}"/>
               </a:ext>
             </a:extLst>
           </p:cNvPr>
@@ -13371,7 +13491,7 @@
           <p:cNvPr id="20" name="">
             <a:extLst xmlns:a="http://schemas.openxmlformats.org/drawingml/2006/main">
               <a:ext uri="{FF2B5EF4-FFF2-40B4-BE49-F238E27FC236}">
-                <a16:creationId xmlns:a16="http://schemas.microsoft.com/office/drawing/2014/main" id="{EEF6CADC-AA94-4888-9458-66B3BC5B447A}"/>
+                <a16:creationId xmlns:a16="http://schemas.microsoft.com/office/drawing/2014/main" id="{91101120-80F8-493B-BF6F-E833263C8EFE}"/>
               </a:ext>
             </a:extLst>
           </p:cNvPr>
@@ -13573,7 +13693,7 @@
           <p:cNvPr id="21" name="">
             <a:extLst xmlns:a="http://schemas.openxmlformats.org/drawingml/2006/main">
               <a:ext uri="{FF2B5EF4-FFF2-40B4-BE49-F238E27FC236}">
-                <a16:creationId xmlns:a16="http://schemas.microsoft.com/office/drawing/2014/main" id="{0CDA8D8B-98C6-4F80-9A1C-31B506DA034D}"/>
+                <a16:creationId xmlns:a16="http://schemas.microsoft.com/office/drawing/2014/main" id="{FF894439-395E-4986-B1EC-49CB1AE56136}"/>
               </a:ext>
             </a:extLst>
           </p:cNvPr>
@@ -13606,7 +13726,7 @@
           <p:cNvPr id="22" name="">
             <a:extLst xmlns:a="http://schemas.openxmlformats.org/drawingml/2006/main">
               <a:ext uri="{FF2B5EF4-FFF2-40B4-BE49-F238E27FC236}">
-                <a16:creationId xmlns:a16="http://schemas.microsoft.com/office/drawing/2014/main" id="{A2918555-CB9B-4256-A950-84207417CFA1}"/>
+                <a16:creationId xmlns:a16="http://schemas.microsoft.com/office/drawing/2014/main" id="{92203558-277F-4DA8-B642-6F8B7E2EB152}"/>
               </a:ext>
             </a:extLst>
           </p:cNvPr>
@@ -13660,7 +13780,7 @@
                 <a:ea typeface="Aptos"/>
                 <a:cs typeface="Aptos"/>
               </a:rPr>
-              <a:t>Future improvement: separate traffic telemetry from heartbeat</a:t>
+              <a:t>Future improvement: telemetry vs heartbeat modes</a:t>
             </a:r>
           </a:p>
         </p:txBody>
@@ -13670,7 +13790,7 @@
           <p:cNvPr id="23" name="">
             <a:extLst xmlns:a="http://schemas.openxmlformats.org/drawingml/2006/main">
               <a:ext uri="{FF2B5EF4-FFF2-40B4-BE49-F238E27FC236}">
-                <a16:creationId xmlns:a16="http://schemas.microsoft.com/office/drawing/2014/main" id="{D25975C9-2DA8-4736-B8D2-2F1431467E72}"/>
+                <a16:creationId xmlns:a16="http://schemas.microsoft.com/office/drawing/2014/main" id="{9005C5A1-DF2C-48C0-9E3D-501FB70109EC}"/>
               </a:ext>
             </a:extLst>
           </p:cNvPr>
@@ -13724,7 +13844,7 @@
                 <a:ea typeface="Consolas"/>
                 <a:cs typeface="Consolas"/>
               </a:rPr>
-              <a:t>if (queue == 0 &amp;&amp; farFree &amp;&amp; nearFree) {</a:t>
+              <a:t>if (stateChanged || emergency) {</a:t>
             </a:r>
           </a:p>
           <a:p xmlns:a="http://schemas.openxmlformats.org/drawingml/2006/main">
@@ -13747,7 +13867,7 @@
                 <a:ea typeface="Consolas"/>
                 <a:cs typeface="Consolas"/>
               </a:rPr>
-              <a:t>  sendHeartbeatEvery(10000);      // alive, no traffic</a:t>
+              <a:t>  sendTelemetryNow();             // full traffic state</a:t>
             </a:r>
           </a:p>
           <a:p xmlns:a="http://schemas.openxmlformats.org/drawingml/2006/main">
@@ -13770,7 +13890,7 @@
                 <a:ea typeface="Consolas"/>
                 <a:cs typeface="Consolas"/>
               </a:rPr>
-              <a:t>  sendTelemetryOnlyOnChange();    // full packet if state changes</a:t>
+              <a:t>} else if (bothQueuesEmpty() || peakSaturated()) {</a:t>
             </a:r>
           </a:p>
           <a:p xmlns:a="http://schemas.openxmlformats.org/drawingml/2006/main">
@@ -13793,6 +13913,52 @@
                 <a:ea typeface="Consolas"/>
                 <a:cs typeface="Consolas"/>
               </a:rPr>
+              <a:t>  sendHeartbeatEvery(15000);      // alive, reduced LoRa</a:t>
+            </a:r>
+          </a:p>
+          <a:p xmlns:a="http://schemas.openxmlformats.org/drawingml/2006/main">
+            <a:pPr algn="l">
+              <a:defRPr sz="698" b="0">
+                <a:solidFill>
+                  <a:srgbClr val="172033"/>
+                </a:solidFill>
+                <a:latin typeface="Consolas"/>
+                <a:ea typeface="Consolas"/>
+                <a:cs typeface="Consolas"/>
+              </a:defRPr>
+            </a:pPr>
+            <a:r>
+              <a:rPr sz="698" b="0">
+                <a:solidFill>
+                  <a:srgbClr val="172033"/>
+                </a:solidFill>
+                <a:latin typeface="Consolas"/>
+                <a:ea typeface="Consolas"/>
+                <a:cs typeface="Consolas"/>
+              </a:rPr>
+              <a:t>  nodeBControlsLightsLocally();   // normal light logic continues</a:t>
+            </a:r>
+          </a:p>
+          <a:p xmlns:a="http://schemas.openxmlformats.org/drawingml/2006/main">
+            <a:pPr algn="l">
+              <a:defRPr sz="698" b="0">
+                <a:solidFill>
+                  <a:srgbClr val="172033"/>
+                </a:solidFill>
+                <a:latin typeface="Consolas"/>
+                <a:ea typeface="Consolas"/>
+                <a:cs typeface="Consolas"/>
+              </a:defRPr>
+            </a:pPr>
+            <a:r>
+              <a:rPr sz="698" b="0">
+                <a:solidFill>
+                  <a:srgbClr val="172033"/>
+                </a:solidFill>
+                <a:latin typeface="Consolas"/>
+                <a:ea typeface="Consolas"/>
+                <a:cs typeface="Consolas"/>
+              </a:rPr>
               <a:t>} else {</a:t>
             </a:r>
           </a:p>
@@ -13816,7 +13982,7 @@
                 <a:ea typeface="Consolas"/>
                 <a:cs typeface="Consolas"/>
               </a:rPr>
-              <a:t>  sendTelemetryEvery(1000);       // active traffic mode</a:t>
+              <a:t>  sendTelemetryEvery(1000);       // active adaptive mode</a:t>
             </a:r>
           </a:p>
           <a:p xmlns:a="http://schemas.openxmlformats.org/drawingml/2006/main">
@@ -13923,7 +14089,7 @@
           <p:cNvPr id="24" name="">
             <a:extLst xmlns:a="http://schemas.openxmlformats.org/drawingml/2006/main">
               <a:ext uri="{FF2B5EF4-FFF2-40B4-BE49-F238E27FC236}">
-                <a16:creationId xmlns:a16="http://schemas.microsoft.com/office/drawing/2014/main" id="{478992BA-15EE-44A5-B7FE-64B095DC399E}"/>
+                <a16:creationId xmlns:a16="http://schemas.microsoft.com/office/drawing/2014/main" id="{8C63CFE7-40C1-481F-8FB4-84EC2918908B}"/>
               </a:ext>
             </a:extLst>
           </p:cNvPr>
@@ -13956,7 +14122,7 @@
           <p:cNvPr id="25" name="">
             <a:extLst xmlns:a="http://schemas.openxmlformats.org/drawingml/2006/main">
               <a:ext uri="{FF2B5EF4-FFF2-40B4-BE49-F238E27FC236}">
-                <a16:creationId xmlns:a16="http://schemas.microsoft.com/office/drawing/2014/main" id="{B762E059-0D1C-45B4-AF15-AD7AEA49E934}"/>
+                <a16:creationId xmlns:a16="http://schemas.microsoft.com/office/drawing/2014/main" id="{B7BBC23C-05A4-452E-88D6-152FA9D7F894}"/>
               </a:ext>
             </a:extLst>
           </p:cNvPr>
@@ -14020,7 +14186,7 @@
           <p:cNvPr id="26" name="">
             <a:extLst xmlns:a="http://schemas.openxmlformats.org/drawingml/2006/main">
               <a:ext uri="{FF2B5EF4-FFF2-40B4-BE49-F238E27FC236}">
-                <a16:creationId xmlns:a16="http://schemas.microsoft.com/office/drawing/2014/main" id="{7DC2540C-A157-44FA-A708-EDD4F31E909B}"/>
+                <a16:creationId xmlns:a16="http://schemas.microsoft.com/office/drawing/2014/main" id="{D5FF450F-A0D1-41E4-A4AD-8DFDEF7F6695}"/>
               </a:ext>
             </a:extLst>
           </p:cNvPr>
@@ -14107,7 +14273,7 @@
           <p:cNvPr id="27" name="">
             <a:extLst xmlns:a="http://schemas.openxmlformats.org/drawingml/2006/main">
               <a:ext uri="{FF2B5EF4-FFF2-40B4-BE49-F238E27FC236}">
-                <a16:creationId xmlns:a16="http://schemas.microsoft.com/office/drawing/2014/main" id="{134AB748-B919-4356-8C0B-A7403DDE0DE9}"/>
+                <a16:creationId xmlns:a16="http://schemas.microsoft.com/office/drawing/2014/main" id="{21FE2956-FAC0-4B72-8C04-6241DDDA30BE}"/>
               </a:ext>
             </a:extLst>
           </p:cNvPr>
@@ -14140,7 +14306,7 @@
           <p:cNvPr id="28" name="">
             <a:extLst xmlns:a="http://schemas.openxmlformats.org/drawingml/2006/main">
               <a:ext uri="{FF2B5EF4-FFF2-40B4-BE49-F238E27FC236}">
-                <a16:creationId xmlns:a16="http://schemas.microsoft.com/office/drawing/2014/main" id="{89683BD8-0A0C-437E-A458-A79E76F9D67D}"/>
+                <a16:creationId xmlns:a16="http://schemas.microsoft.com/office/drawing/2014/main" id="{FBA5DA93-71C0-4F8A-9A50-04F1BEE0B251}"/>
               </a:ext>
             </a:extLst>
           </p:cNvPr>
@@ -14204,7 +14370,7 @@
           <p:cNvPr id="29" name="">
             <a:extLst xmlns:a="http://schemas.openxmlformats.org/drawingml/2006/main">
               <a:ext uri="{FF2B5EF4-FFF2-40B4-BE49-F238E27FC236}">
-                <a16:creationId xmlns:a16="http://schemas.microsoft.com/office/drawing/2014/main" id="{6493EFE4-43D1-4597-9B79-60CF9B26A6DE}"/>
+                <a16:creationId xmlns:a16="http://schemas.microsoft.com/office/drawing/2014/main" id="{F258E0AE-465E-4DCC-AA08-A52A0EE3FB55}"/>
               </a:ext>
             </a:extLst>
           </p:cNvPr>
@@ -14266,7 +14432,7 @@
     </p:spTree>
     <p:extLst>
       <p:ext uri="{BB962C8B-B14F-4D97-AF65-F5344CB8AC3E}">
-        <p14:creationId xmlns:p14="http://schemas.microsoft.com/office/powerpoint/2010/main" val="1824653835"/>
+        <p14:creationId xmlns:p14="http://schemas.microsoft.com/office/powerpoint/2010/main" val="271711890"/>
       </p:ext>
     </p:extLst>
   </p:cSld>
@@ -14290,7 +14456,7 @@
           <p:cNvPr id="1" name="">
             <a:extLst xmlns:a="http://schemas.openxmlformats.org/drawingml/2006/main">
               <a:ext uri="{FF2B5EF4-FFF2-40B4-BE49-F238E27FC236}">
-                <a16:creationId xmlns:a16="http://schemas.microsoft.com/office/drawing/2014/main" id="{1F076C58-629B-421F-84F8-B79975C3BBA4}"/>
+                <a16:creationId xmlns:a16="http://schemas.microsoft.com/office/drawing/2014/main" id="{2BEC4FA3-DF2D-4D42-9A8F-E02B901D7389}"/>
               </a:ext>
             </a:extLst>
           </p:cNvPr>
@@ -14325,7 +14491,7 @@
           <p:cNvPr id="2" name="">
             <a:extLst xmlns:a="http://schemas.openxmlformats.org/drawingml/2006/main">
               <a:ext uri="{FF2B5EF4-FFF2-40B4-BE49-F238E27FC236}">
-                <a16:creationId xmlns:a16="http://schemas.microsoft.com/office/drawing/2014/main" id="{E13EE1AF-B88F-42DB-A413-A32A136C83DB}"/>
+                <a16:creationId xmlns:a16="http://schemas.microsoft.com/office/drawing/2014/main" id="{EC83C0DA-0B9E-4028-A1C1-E78B98ECAF98}"/>
               </a:ext>
             </a:extLst>
           </p:cNvPr>
@@ -14360,7 +14526,7 @@
           <p:cNvPr id="3" name="">
             <a:extLst xmlns:a="http://schemas.openxmlformats.org/drawingml/2006/main">
               <a:ext uri="{FF2B5EF4-FFF2-40B4-BE49-F238E27FC236}">
-                <a16:creationId xmlns:a16="http://schemas.microsoft.com/office/drawing/2014/main" id="{77EFCBB1-9620-4307-848C-C86F0A176753}"/>
+                <a16:creationId xmlns:a16="http://schemas.microsoft.com/office/drawing/2014/main" id="{D271ED6D-293C-4B6E-AE80-B1C959978D26}"/>
               </a:ext>
             </a:extLst>
           </p:cNvPr>
@@ -14395,7 +14561,7 @@
           <p:cNvPr id="4" name="">
             <a:extLst xmlns:a="http://schemas.openxmlformats.org/drawingml/2006/main">
               <a:ext uri="{FF2B5EF4-FFF2-40B4-BE49-F238E27FC236}">
-                <a16:creationId xmlns:a16="http://schemas.microsoft.com/office/drawing/2014/main" id="{9A86A7FF-4B24-4412-89E8-A8DD93464A63}"/>
+                <a16:creationId xmlns:a16="http://schemas.microsoft.com/office/drawing/2014/main" id="{4A5852E0-610F-4050-8E07-A4FA60A771E9}"/>
               </a:ext>
             </a:extLst>
           </p:cNvPr>
@@ -14459,7 +14625,7 @@
           <p:cNvPr id="5" name="">
             <a:extLst xmlns:a="http://schemas.openxmlformats.org/drawingml/2006/main">
               <a:ext uri="{FF2B5EF4-FFF2-40B4-BE49-F238E27FC236}">
-                <a16:creationId xmlns:a16="http://schemas.microsoft.com/office/drawing/2014/main" id="{C6A62125-E7CA-49DF-BB07-AD4B8C5F7136}"/>
+                <a16:creationId xmlns:a16="http://schemas.microsoft.com/office/drawing/2014/main" id="{40A8BF07-55BA-4ACA-80F4-60F8194DEF96}"/>
               </a:ext>
             </a:extLst>
           </p:cNvPr>
@@ -14494,7 +14660,7 @@
           <p:cNvPr id="6" name="">
             <a:extLst xmlns:a="http://schemas.openxmlformats.org/drawingml/2006/main">
               <a:ext uri="{FF2B5EF4-FFF2-40B4-BE49-F238E27FC236}">
-                <a16:creationId xmlns:a16="http://schemas.microsoft.com/office/drawing/2014/main" id="{DD821D3B-42D7-4E40-B685-8BE0B8FA1014}"/>
+                <a16:creationId xmlns:a16="http://schemas.microsoft.com/office/drawing/2014/main" id="{198DE8E8-313C-4FEF-853C-8493CD3A7198}"/>
               </a:ext>
             </a:extLst>
           </p:cNvPr>
@@ -14529,7 +14695,7 @@
           <p:cNvPr id="7" name="">
             <a:extLst xmlns:a="http://schemas.openxmlformats.org/drawingml/2006/main">
               <a:ext uri="{FF2B5EF4-FFF2-40B4-BE49-F238E27FC236}">
-                <a16:creationId xmlns:a16="http://schemas.microsoft.com/office/drawing/2014/main" id="{1EFEA222-CA7E-4175-83AF-A183D0A088D3}"/>
+                <a16:creationId xmlns:a16="http://schemas.microsoft.com/office/drawing/2014/main" id="{06F4B749-783E-444A-BCAF-B94BB8258471}"/>
               </a:ext>
             </a:extLst>
           </p:cNvPr>
@@ -14564,7 +14730,7 @@
           <p:cNvPr id="8" name="">
             <a:extLst xmlns:a="http://schemas.openxmlformats.org/drawingml/2006/main">
               <a:ext uri="{FF2B5EF4-FFF2-40B4-BE49-F238E27FC236}">
-                <a16:creationId xmlns:a16="http://schemas.microsoft.com/office/drawing/2014/main" id="{574B380A-6E2F-4313-9031-2405B72D6CEF}"/>
+                <a16:creationId xmlns:a16="http://schemas.microsoft.com/office/drawing/2014/main" id="{9D2FF6A1-2BBC-4DF3-A921-C413D32CB8F6}"/>
               </a:ext>
             </a:extLst>
           </p:cNvPr>
@@ -14628,7 +14794,7 @@
           <p:cNvPr id="9" name="">
             <a:extLst xmlns:a="http://schemas.openxmlformats.org/drawingml/2006/main">
               <a:ext uri="{FF2B5EF4-FFF2-40B4-BE49-F238E27FC236}">
-                <a16:creationId xmlns:a16="http://schemas.microsoft.com/office/drawing/2014/main" id="{CAE25DD9-7C2C-4D47-9C89-4ED806B12F0B}"/>
+                <a16:creationId xmlns:a16="http://schemas.microsoft.com/office/drawing/2014/main" id="{9FFF6A4B-C0D5-436C-822E-151CFE7EB5A8}"/>
               </a:ext>
             </a:extLst>
           </p:cNvPr>
@@ -14692,7 +14858,7 @@
           <p:cNvPr id="10" name="">
             <a:extLst xmlns:a="http://schemas.openxmlformats.org/drawingml/2006/main">
               <a:ext uri="{FF2B5EF4-FFF2-40B4-BE49-F238E27FC236}">
-                <a16:creationId xmlns:a16="http://schemas.microsoft.com/office/drawing/2014/main" id="{B0ECAB70-35AA-4D13-BD1B-22225BC5B2A2}"/>
+                <a16:creationId xmlns:a16="http://schemas.microsoft.com/office/drawing/2014/main" id="{92DEE053-D1BF-4688-8F6F-F93038265905}"/>
               </a:ext>
             </a:extLst>
           </p:cNvPr>
@@ -14756,7 +14922,7 @@
           <p:cNvPr id="11" name="">
             <a:extLst xmlns:a="http://schemas.openxmlformats.org/drawingml/2006/main">
               <a:ext uri="{FF2B5EF4-FFF2-40B4-BE49-F238E27FC236}">
-                <a16:creationId xmlns:a16="http://schemas.microsoft.com/office/drawing/2014/main" id="{58218824-6DAB-456B-9350-16B52195D7D1}"/>
+                <a16:creationId xmlns:a16="http://schemas.microsoft.com/office/drawing/2014/main" id="{E05FB12C-A111-4E5C-9A84-823EA228AF99}"/>
               </a:ext>
             </a:extLst>
           </p:cNvPr>
@@ -14820,7 +14986,7 @@
           <p:cNvPr id="12" name="">
             <a:extLst xmlns:a="http://schemas.openxmlformats.org/drawingml/2006/main">
               <a:ext uri="{FF2B5EF4-FFF2-40B4-BE49-F238E27FC236}">
-                <a16:creationId xmlns:a16="http://schemas.microsoft.com/office/drawing/2014/main" id="{16B4B078-D9CF-421F-8401-69F199C37B0F}"/>
+                <a16:creationId xmlns:a16="http://schemas.microsoft.com/office/drawing/2014/main" id="{FFBE80E5-D9E1-4067-B6CD-29121666668F}"/>
               </a:ext>
             </a:extLst>
           </p:cNvPr>
@@ -14853,7 +15019,7 @@
           <p:cNvPr id="13" name="">
             <a:extLst xmlns:a="http://schemas.openxmlformats.org/drawingml/2006/main">
               <a:ext uri="{FF2B5EF4-FFF2-40B4-BE49-F238E27FC236}">
-                <a16:creationId xmlns:a16="http://schemas.microsoft.com/office/drawing/2014/main" id="{BAE52E0B-3409-43E3-A31C-EC24B1B48247}"/>
+                <a16:creationId xmlns:a16="http://schemas.microsoft.com/office/drawing/2014/main" id="{39051E94-0F20-49B0-A8AA-87644E4464D3}"/>
               </a:ext>
             </a:extLst>
           </p:cNvPr>
@@ -14917,7 +15083,7 @@
           <p:cNvPr id="14" name="">
             <a:extLst xmlns:a="http://schemas.openxmlformats.org/drawingml/2006/main">
               <a:ext uri="{FF2B5EF4-FFF2-40B4-BE49-F238E27FC236}">
-                <a16:creationId xmlns:a16="http://schemas.microsoft.com/office/drawing/2014/main" id="{CC296A6A-C22A-445F-BCF9-FD8F2E8B38AE}"/>
+                <a16:creationId xmlns:a16="http://schemas.microsoft.com/office/drawing/2014/main" id="{421CE100-C809-487E-B4F9-B08D5DCB8332}"/>
               </a:ext>
             </a:extLst>
           </p:cNvPr>
@@ -14981,7 +15147,7 @@
           <p:cNvPr id="15" name="">
             <a:extLst xmlns:a="http://schemas.openxmlformats.org/drawingml/2006/main">
               <a:ext uri="{FF2B5EF4-FFF2-40B4-BE49-F238E27FC236}">
-                <a16:creationId xmlns:a16="http://schemas.microsoft.com/office/drawing/2014/main" id="{C19C92F4-B557-4613-AB1C-7647C3B5EAEE}"/>
+                <a16:creationId xmlns:a16="http://schemas.microsoft.com/office/drawing/2014/main" id="{D6D4A07E-C824-4FF8-BEF6-EFE3B4913A6A}"/>
               </a:ext>
             </a:extLst>
           </p:cNvPr>
@@ -15014,7 +15180,7 @@
           <p:cNvPr id="16" name="">
             <a:extLst xmlns:a="http://schemas.openxmlformats.org/drawingml/2006/main">
               <a:ext uri="{FF2B5EF4-FFF2-40B4-BE49-F238E27FC236}">
-                <a16:creationId xmlns:a16="http://schemas.microsoft.com/office/drawing/2014/main" id="{75D98CBD-4436-4820-BC20-9CE72B69051D}"/>
+                <a16:creationId xmlns:a16="http://schemas.microsoft.com/office/drawing/2014/main" id="{99FCF23A-0B6D-4FD1-8802-A0B11FC164AD}"/>
               </a:ext>
             </a:extLst>
           </p:cNvPr>
@@ -15078,7 +15244,7 @@
           <p:cNvPr id="17" name="">
             <a:extLst xmlns:a="http://schemas.openxmlformats.org/drawingml/2006/main">
               <a:ext uri="{FF2B5EF4-FFF2-40B4-BE49-F238E27FC236}">
-                <a16:creationId xmlns:a16="http://schemas.microsoft.com/office/drawing/2014/main" id="{A1F1FE6C-86E4-4849-91E1-BC72733A860C}"/>
+                <a16:creationId xmlns:a16="http://schemas.microsoft.com/office/drawing/2014/main" id="{CA7BAAAE-A768-4254-B35E-828176F50388}"/>
               </a:ext>
             </a:extLst>
           </p:cNvPr>
@@ -15142,7 +15308,7 @@
           <p:cNvPr id="18" name="">
             <a:extLst xmlns:a="http://schemas.openxmlformats.org/drawingml/2006/main">
               <a:ext uri="{FF2B5EF4-FFF2-40B4-BE49-F238E27FC236}">
-                <a16:creationId xmlns:a16="http://schemas.microsoft.com/office/drawing/2014/main" id="{24A27067-2142-4C3F-B6CB-8A355C796200}"/>
+                <a16:creationId xmlns:a16="http://schemas.microsoft.com/office/drawing/2014/main" id="{E399A809-62CC-4C3F-972E-A6A5BD546185}"/>
               </a:ext>
             </a:extLst>
           </p:cNvPr>
@@ -15175,7 +15341,7 @@
           <p:cNvPr id="19" name="">
             <a:extLst xmlns:a="http://schemas.openxmlformats.org/drawingml/2006/main">
               <a:ext uri="{FF2B5EF4-FFF2-40B4-BE49-F238E27FC236}">
-                <a16:creationId xmlns:a16="http://schemas.microsoft.com/office/drawing/2014/main" id="{4BEDCC28-4EFD-47AB-9BFA-A2BD56CF6718}"/>
+                <a16:creationId xmlns:a16="http://schemas.microsoft.com/office/drawing/2014/main" id="{7A78B89F-8958-4DCA-96CE-973D435CEA1E}"/>
               </a:ext>
             </a:extLst>
           </p:cNvPr>
@@ -15239,7 +15405,7 @@
           <p:cNvPr id="20" name="">
             <a:extLst xmlns:a="http://schemas.openxmlformats.org/drawingml/2006/main">
               <a:ext uri="{FF2B5EF4-FFF2-40B4-BE49-F238E27FC236}">
-                <a16:creationId xmlns:a16="http://schemas.microsoft.com/office/drawing/2014/main" id="{57542429-360C-4214-945A-1C39C9A5DF97}"/>
+                <a16:creationId xmlns:a16="http://schemas.microsoft.com/office/drawing/2014/main" id="{9D76B230-BD1C-48C7-B104-20C3AA45DFDB}"/>
               </a:ext>
             </a:extLst>
           </p:cNvPr>
@@ -15303,7 +15469,7 @@
           <p:cNvPr id="21" name="">
             <a:extLst xmlns:a="http://schemas.openxmlformats.org/drawingml/2006/main">
               <a:ext uri="{FF2B5EF4-FFF2-40B4-BE49-F238E27FC236}">
-                <a16:creationId xmlns:a16="http://schemas.microsoft.com/office/drawing/2014/main" id="{D670CC83-595F-4D32-8537-3475B4A0C4F2}"/>
+                <a16:creationId xmlns:a16="http://schemas.microsoft.com/office/drawing/2014/main" id="{92EB0EA3-69A1-4D06-8DBE-59B19B313E0A}"/>
               </a:ext>
             </a:extLst>
           </p:cNvPr>
@@ -15336,7 +15502,7 @@
           <p:cNvPr id="22" name="">
             <a:extLst xmlns:a="http://schemas.openxmlformats.org/drawingml/2006/main">
               <a:ext uri="{FF2B5EF4-FFF2-40B4-BE49-F238E27FC236}">
-                <a16:creationId xmlns:a16="http://schemas.microsoft.com/office/drawing/2014/main" id="{89718D6B-E540-400A-8714-40AF935E7E80}"/>
+                <a16:creationId xmlns:a16="http://schemas.microsoft.com/office/drawing/2014/main" id="{2A73AC0D-2EF2-4242-8BF5-4633412055F1}"/>
               </a:ext>
             </a:extLst>
           </p:cNvPr>
@@ -15400,7 +15566,7 @@
           <p:cNvPr id="23" name="">
             <a:extLst xmlns:a="http://schemas.openxmlformats.org/drawingml/2006/main">
               <a:ext uri="{FF2B5EF4-FFF2-40B4-BE49-F238E27FC236}">
-                <a16:creationId xmlns:a16="http://schemas.microsoft.com/office/drawing/2014/main" id="{BBC7A2E2-CA47-4C33-AF4C-AE61C9396241}"/>
+                <a16:creationId xmlns:a16="http://schemas.microsoft.com/office/drawing/2014/main" id="{F8B29115-F6EB-4192-9689-108E965CE763}"/>
               </a:ext>
             </a:extLst>
           </p:cNvPr>
@@ -15464,7 +15630,7 @@
           <p:cNvPr id="24" name="">
             <a:extLst xmlns:a="http://schemas.openxmlformats.org/drawingml/2006/main">
               <a:ext uri="{FF2B5EF4-FFF2-40B4-BE49-F238E27FC236}">
-                <a16:creationId xmlns:a16="http://schemas.microsoft.com/office/drawing/2014/main" id="{BAA73EF6-D583-4927-B400-AF94D7BFD73C}"/>
+                <a16:creationId xmlns:a16="http://schemas.microsoft.com/office/drawing/2014/main" id="{7042582D-13A4-42EA-B984-5A5F23DA64AC}"/>
               </a:ext>
             </a:extLst>
           </p:cNvPr>
@@ -15497,7 +15663,7 @@
           <p:cNvPr id="25" name="">
             <a:extLst xmlns:a="http://schemas.openxmlformats.org/drawingml/2006/main">
               <a:ext uri="{FF2B5EF4-FFF2-40B4-BE49-F238E27FC236}">
-                <a16:creationId xmlns:a16="http://schemas.microsoft.com/office/drawing/2014/main" id="{808492A6-DA8C-46EA-AC42-02A6754E59E1}"/>
+                <a16:creationId xmlns:a16="http://schemas.microsoft.com/office/drawing/2014/main" id="{B483879C-E358-4D93-9E84-6E0E0F1205D1}"/>
               </a:ext>
             </a:extLst>
           </p:cNvPr>
@@ -15561,7 +15727,7 @@
           <p:cNvPr id="26" name="">
             <a:extLst xmlns:a="http://schemas.openxmlformats.org/drawingml/2006/main">
               <a:ext uri="{FF2B5EF4-FFF2-40B4-BE49-F238E27FC236}">
-                <a16:creationId xmlns:a16="http://schemas.microsoft.com/office/drawing/2014/main" id="{E7A3F388-5D16-4646-8C68-1E5A8D77431A}"/>
+                <a16:creationId xmlns:a16="http://schemas.microsoft.com/office/drawing/2014/main" id="{714C11AB-45B6-432D-82BF-8219CDC6BB35}"/>
               </a:ext>
             </a:extLst>
           </p:cNvPr>
@@ -15837,7 +16003,7 @@
           <p:cNvPr id="27" name="">
             <a:extLst xmlns:a="http://schemas.openxmlformats.org/drawingml/2006/main">
               <a:ext uri="{FF2B5EF4-FFF2-40B4-BE49-F238E27FC236}">
-                <a16:creationId xmlns:a16="http://schemas.microsoft.com/office/drawing/2014/main" id="{1D5264B8-0B8E-48B7-9919-25C90702735F}"/>
+                <a16:creationId xmlns:a16="http://schemas.microsoft.com/office/drawing/2014/main" id="{358D3ADD-9B4F-4553-9121-00605CDF9443}"/>
               </a:ext>
             </a:extLst>
           </p:cNvPr>
@@ -15870,7 +16036,7 @@
           <p:cNvPr id="28" name="">
             <a:extLst xmlns:a="http://schemas.openxmlformats.org/drawingml/2006/main">
               <a:ext uri="{FF2B5EF4-FFF2-40B4-BE49-F238E27FC236}">
-                <a16:creationId xmlns:a16="http://schemas.microsoft.com/office/drawing/2014/main" id="{FA26B99E-397D-40BD-BFC8-E43C04C39D51}"/>
+                <a16:creationId xmlns:a16="http://schemas.microsoft.com/office/drawing/2014/main" id="{5EE62219-46D1-439E-9DE4-ACDEBCAF6222}"/>
               </a:ext>
             </a:extLst>
           </p:cNvPr>
@@ -15934,7 +16100,7 @@
           <p:cNvPr id="29" name="">
             <a:extLst xmlns:a="http://schemas.openxmlformats.org/drawingml/2006/main">
               <a:ext uri="{FF2B5EF4-FFF2-40B4-BE49-F238E27FC236}">
-                <a16:creationId xmlns:a16="http://schemas.microsoft.com/office/drawing/2014/main" id="{969C3DF3-EA21-4242-BC67-22F7F9F2A4A8}"/>
+                <a16:creationId xmlns:a16="http://schemas.microsoft.com/office/drawing/2014/main" id="{F7EA8D83-FDDB-4815-A841-CFDEDE0CBF33}"/>
               </a:ext>
             </a:extLst>
           </p:cNvPr>
@@ -16136,7 +16302,7 @@
           <p:cNvPr id="30" name="">
             <a:extLst xmlns:a="http://schemas.openxmlformats.org/drawingml/2006/main">
               <a:ext uri="{FF2B5EF4-FFF2-40B4-BE49-F238E27FC236}">
-                <a16:creationId xmlns:a16="http://schemas.microsoft.com/office/drawing/2014/main" id="{B0861315-9EF7-42E1-9A16-7290AB37BED0}"/>
+                <a16:creationId xmlns:a16="http://schemas.microsoft.com/office/drawing/2014/main" id="{1D27F64F-F445-444E-B118-4071FDE07CA7}"/>
               </a:ext>
             </a:extLst>
           </p:cNvPr>
@@ -16169,7 +16335,7 @@
           <p:cNvPr id="31" name="">
             <a:extLst xmlns:a="http://schemas.openxmlformats.org/drawingml/2006/main">
               <a:ext uri="{FF2B5EF4-FFF2-40B4-BE49-F238E27FC236}">
-                <a16:creationId xmlns:a16="http://schemas.microsoft.com/office/drawing/2014/main" id="{36CF18A1-D700-4979-B4C6-C12C3AAC2C99}"/>
+                <a16:creationId xmlns:a16="http://schemas.microsoft.com/office/drawing/2014/main" id="{7E6D26F3-5BDF-4ECF-94E7-D961B816ABE6}"/>
               </a:ext>
             </a:extLst>
           </p:cNvPr>
@@ -16233,7 +16399,7 @@
           <p:cNvPr id="32" name="">
             <a:extLst xmlns:a="http://schemas.openxmlformats.org/drawingml/2006/main">
               <a:ext uri="{FF2B5EF4-FFF2-40B4-BE49-F238E27FC236}">
-                <a16:creationId xmlns:a16="http://schemas.microsoft.com/office/drawing/2014/main" id="{923C39F7-524A-49B5-8FDB-E59D7F9DD0B3}"/>
+                <a16:creationId xmlns:a16="http://schemas.microsoft.com/office/drawing/2014/main" id="{A2416623-71B3-4650-A154-E61616D2F6A6}"/>
               </a:ext>
             </a:extLst>
           </p:cNvPr>
@@ -16366,7 +16532,7 @@
           <p:cNvPr id="33" name="">
             <a:extLst xmlns:a="http://schemas.openxmlformats.org/drawingml/2006/main">
               <a:ext uri="{FF2B5EF4-FFF2-40B4-BE49-F238E27FC236}">
-                <a16:creationId xmlns:a16="http://schemas.microsoft.com/office/drawing/2014/main" id="{F1982FD2-0DC9-4D9C-A525-DEDB447FFF3C}"/>
+                <a16:creationId xmlns:a16="http://schemas.microsoft.com/office/drawing/2014/main" id="{580A7908-9D2F-46D0-97A0-F3A7D4467C2A}"/>
               </a:ext>
             </a:extLst>
           </p:cNvPr>
@@ -16399,7 +16565,7 @@
           <p:cNvPr id="34" name="">
             <a:extLst xmlns:a="http://schemas.openxmlformats.org/drawingml/2006/main">
               <a:ext uri="{FF2B5EF4-FFF2-40B4-BE49-F238E27FC236}">
-                <a16:creationId xmlns:a16="http://schemas.microsoft.com/office/drawing/2014/main" id="{82280ED2-7AFB-400B-8498-EA19DCEC148F}"/>
+                <a16:creationId xmlns:a16="http://schemas.microsoft.com/office/drawing/2014/main" id="{39957FCA-42C5-49B2-A455-A7A5E3F7B1AB}"/>
               </a:ext>
             </a:extLst>
           </p:cNvPr>
@@ -16463,7 +16629,7 @@
           <p:cNvPr id="35" name="">
             <a:extLst xmlns:a="http://schemas.openxmlformats.org/drawingml/2006/main">
               <a:ext uri="{FF2B5EF4-FFF2-40B4-BE49-F238E27FC236}">
-                <a16:creationId xmlns:a16="http://schemas.microsoft.com/office/drawing/2014/main" id="{9307B883-AB48-402C-8709-56100FC3588C}"/>
+                <a16:creationId xmlns:a16="http://schemas.microsoft.com/office/drawing/2014/main" id="{23D2C4E3-137F-42ED-8474-8E858CE99AE4}"/>
               </a:ext>
             </a:extLst>
           </p:cNvPr>
@@ -16596,7 +16762,7 @@
           <p:cNvPr id="36" name="">
             <a:extLst xmlns:a="http://schemas.openxmlformats.org/drawingml/2006/main">
               <a:ext uri="{FF2B5EF4-FFF2-40B4-BE49-F238E27FC236}">
-                <a16:creationId xmlns:a16="http://schemas.microsoft.com/office/drawing/2014/main" id="{52F5C0A2-55DE-411E-AD58-06D6B92F40EF}"/>
+                <a16:creationId xmlns:a16="http://schemas.microsoft.com/office/drawing/2014/main" id="{ED442414-4C25-4CB4-A66F-E9E5E36B4E79}"/>
               </a:ext>
             </a:extLst>
           </p:cNvPr>
@@ -16629,7 +16795,7 @@
           <p:cNvPr id="37" name="">
             <a:extLst xmlns:a="http://schemas.openxmlformats.org/drawingml/2006/main">
               <a:ext uri="{FF2B5EF4-FFF2-40B4-BE49-F238E27FC236}">
-                <a16:creationId xmlns:a16="http://schemas.microsoft.com/office/drawing/2014/main" id="{435F5B1D-51DA-483D-ABA2-8185B80C2C06}"/>
+                <a16:creationId xmlns:a16="http://schemas.microsoft.com/office/drawing/2014/main" id="{7CDA6C80-8E65-4C82-97F8-FAD536B18E15}"/>
               </a:ext>
             </a:extLst>
           </p:cNvPr>
@@ -16693,7 +16859,7 @@
           <p:cNvPr id="38" name="">
             <a:extLst xmlns:a="http://schemas.openxmlformats.org/drawingml/2006/main">
               <a:ext uri="{FF2B5EF4-FFF2-40B4-BE49-F238E27FC236}">
-                <a16:creationId xmlns:a16="http://schemas.microsoft.com/office/drawing/2014/main" id="{3CAD60F6-589B-4E9B-B895-1C780E64BAC2}"/>
+                <a16:creationId xmlns:a16="http://schemas.microsoft.com/office/drawing/2014/main" id="{703E644D-F169-49DA-B924-D878F7C916E2}"/>
               </a:ext>
             </a:extLst>
           </p:cNvPr>
@@ -16757,7 +16923,7 @@
           <p:cNvPr id="39" name="">
             <a:extLst xmlns:a="http://schemas.openxmlformats.org/drawingml/2006/main">
               <a:ext uri="{FF2B5EF4-FFF2-40B4-BE49-F238E27FC236}">
-                <a16:creationId xmlns:a16="http://schemas.microsoft.com/office/drawing/2014/main" id="{F1F84C6F-DCE3-4B67-8385-645B12027868}"/>
+                <a16:creationId xmlns:a16="http://schemas.microsoft.com/office/drawing/2014/main" id="{56D7C270-4AD2-4465-8F4F-F7E39FD4B297}"/>
               </a:ext>
             </a:extLst>
           </p:cNvPr>
@@ -16819,7 +16985,7 @@
     </p:spTree>
     <p:extLst>
       <p:ext uri="{BB962C8B-B14F-4D97-AF65-F5344CB8AC3E}">
-        <p14:creationId xmlns:p14="http://schemas.microsoft.com/office/powerpoint/2010/main" val="2097687492"/>
+        <p14:creationId xmlns:p14="http://schemas.microsoft.com/office/powerpoint/2010/main" val="828230948"/>
       </p:ext>
     </p:extLst>
   </p:cSld>
@@ -16843,7 +17009,7 @@
           <p:cNvPr id="1" name="">
             <a:extLst xmlns:a="http://schemas.openxmlformats.org/drawingml/2006/main">
               <a:ext uri="{FF2B5EF4-FFF2-40B4-BE49-F238E27FC236}">
-                <a16:creationId xmlns:a16="http://schemas.microsoft.com/office/drawing/2014/main" id="{AA88C33B-EE9E-4734-8668-50C2766EDA71}"/>
+                <a16:creationId xmlns:a16="http://schemas.microsoft.com/office/drawing/2014/main" id="{10DE6438-FAB4-40F0-9008-E40BCCE35744}"/>
               </a:ext>
             </a:extLst>
           </p:cNvPr>
@@ -16878,7 +17044,7 @@
           <p:cNvPr id="2" name="">
             <a:extLst xmlns:a="http://schemas.openxmlformats.org/drawingml/2006/main">
               <a:ext uri="{FF2B5EF4-FFF2-40B4-BE49-F238E27FC236}">
-                <a16:creationId xmlns:a16="http://schemas.microsoft.com/office/drawing/2014/main" id="{6D8A3001-364A-4D1C-A993-ABEE67B34752}"/>
+                <a16:creationId xmlns:a16="http://schemas.microsoft.com/office/drawing/2014/main" id="{A7F8E858-17AB-419A-98E2-F39ABF9ED564}"/>
               </a:ext>
             </a:extLst>
           </p:cNvPr>
@@ -16913,7 +17079,7 @@
           <p:cNvPr id="3" name="">
             <a:extLst xmlns:a="http://schemas.openxmlformats.org/drawingml/2006/main">
               <a:ext uri="{FF2B5EF4-FFF2-40B4-BE49-F238E27FC236}">
-                <a16:creationId xmlns:a16="http://schemas.microsoft.com/office/drawing/2014/main" id="{AAD0D905-DC64-456A-A8C0-EF87AAAB727D}"/>
+                <a16:creationId xmlns:a16="http://schemas.microsoft.com/office/drawing/2014/main" id="{6EFA3173-0ABA-429D-8BDD-1D5A67707446}"/>
               </a:ext>
             </a:extLst>
           </p:cNvPr>
@@ -16948,7 +17114,7 @@
           <p:cNvPr id="4" name="">
             <a:extLst xmlns:a="http://schemas.openxmlformats.org/drawingml/2006/main">
               <a:ext uri="{FF2B5EF4-FFF2-40B4-BE49-F238E27FC236}">
-                <a16:creationId xmlns:a16="http://schemas.microsoft.com/office/drawing/2014/main" id="{324F39A2-657D-4AC9-A126-BF62B4DAFDA6}"/>
+                <a16:creationId xmlns:a16="http://schemas.microsoft.com/office/drawing/2014/main" id="{26A81539-9052-45E8-BAB5-399EC60D1A2E}"/>
               </a:ext>
             </a:extLst>
           </p:cNvPr>
@@ -17012,7 +17178,7 @@
           <p:cNvPr id="5" name="">
             <a:extLst xmlns:a="http://schemas.openxmlformats.org/drawingml/2006/main">
               <a:ext uri="{FF2B5EF4-FFF2-40B4-BE49-F238E27FC236}">
-                <a16:creationId xmlns:a16="http://schemas.microsoft.com/office/drawing/2014/main" id="{03CD2D7A-4FF8-4C0A-93EE-8996C78D0D27}"/>
+                <a16:creationId xmlns:a16="http://schemas.microsoft.com/office/drawing/2014/main" id="{9A8E743F-FB55-4217-9601-15720A9711CE}"/>
               </a:ext>
             </a:extLst>
           </p:cNvPr>
@@ -17047,7 +17213,7 @@
           <p:cNvPr id="6" name="">
             <a:extLst xmlns:a="http://schemas.openxmlformats.org/drawingml/2006/main">
               <a:ext uri="{FF2B5EF4-FFF2-40B4-BE49-F238E27FC236}">
-                <a16:creationId xmlns:a16="http://schemas.microsoft.com/office/drawing/2014/main" id="{D3EC731B-A8B3-4DC3-A60B-B4A91AF7B58E}"/>
+                <a16:creationId xmlns:a16="http://schemas.microsoft.com/office/drawing/2014/main" id="{73371DFF-C027-4749-B2A5-D60CA7EFBD68}"/>
               </a:ext>
             </a:extLst>
           </p:cNvPr>
@@ -17082,7 +17248,7 @@
           <p:cNvPr id="7" name="">
             <a:extLst xmlns:a="http://schemas.openxmlformats.org/drawingml/2006/main">
               <a:ext uri="{FF2B5EF4-FFF2-40B4-BE49-F238E27FC236}">
-                <a16:creationId xmlns:a16="http://schemas.microsoft.com/office/drawing/2014/main" id="{C5093FF9-2CB3-4A4D-86ED-C61EBA74F1E2}"/>
+                <a16:creationId xmlns:a16="http://schemas.microsoft.com/office/drawing/2014/main" id="{2B4FB51A-9134-4C5F-ADE6-E381BB675D0C}"/>
               </a:ext>
             </a:extLst>
           </p:cNvPr>
@@ -17117,7 +17283,7 @@
           <p:cNvPr id="8" name="">
             <a:extLst xmlns:a="http://schemas.openxmlformats.org/drawingml/2006/main">
               <a:ext uri="{FF2B5EF4-FFF2-40B4-BE49-F238E27FC236}">
-                <a16:creationId xmlns:a16="http://schemas.microsoft.com/office/drawing/2014/main" id="{5B47EF3A-6920-4142-B441-85BD4B3416ED}"/>
+                <a16:creationId xmlns:a16="http://schemas.microsoft.com/office/drawing/2014/main" id="{B8818D58-7A09-412E-BC5C-85891C272C01}"/>
               </a:ext>
             </a:extLst>
           </p:cNvPr>
@@ -17181,7 +17347,7 @@
           <p:cNvPr id="9" name="">
             <a:extLst xmlns:a="http://schemas.openxmlformats.org/drawingml/2006/main">
               <a:ext uri="{FF2B5EF4-FFF2-40B4-BE49-F238E27FC236}">
-                <a16:creationId xmlns:a16="http://schemas.microsoft.com/office/drawing/2014/main" id="{CD4B04D5-1825-43F0-B8AB-8C743CA2542C}"/>
+                <a16:creationId xmlns:a16="http://schemas.microsoft.com/office/drawing/2014/main" id="{8F0B1996-BF68-4237-8885-D219DE70AEC5}"/>
               </a:ext>
             </a:extLst>
           </p:cNvPr>
@@ -17245,7 +17411,7 @@
           <p:cNvPr id="10" name="">
             <a:extLst xmlns:a="http://schemas.openxmlformats.org/drawingml/2006/main">
               <a:ext uri="{FF2B5EF4-FFF2-40B4-BE49-F238E27FC236}">
-                <a16:creationId xmlns:a16="http://schemas.microsoft.com/office/drawing/2014/main" id="{6B243C7E-DF6C-4911-B446-BA86FBEB2440}"/>
+                <a16:creationId xmlns:a16="http://schemas.microsoft.com/office/drawing/2014/main" id="{649584B0-ED83-4A23-AAA1-DAC9D719BC9C}"/>
               </a:ext>
             </a:extLst>
           </p:cNvPr>
@@ -17309,7 +17475,7 @@
           <p:cNvPr id="11" name="">
             <a:extLst xmlns:a="http://schemas.openxmlformats.org/drawingml/2006/main">
               <a:ext uri="{FF2B5EF4-FFF2-40B4-BE49-F238E27FC236}">
-                <a16:creationId xmlns:a16="http://schemas.microsoft.com/office/drawing/2014/main" id="{2A6F2A2E-19B3-4023-872D-804620E614C5}"/>
+                <a16:creationId xmlns:a16="http://schemas.microsoft.com/office/drawing/2014/main" id="{5E9E5CEC-B5CB-4990-9672-2B1F7D1AF2B5}"/>
               </a:ext>
             </a:extLst>
           </p:cNvPr>
@@ -17373,7 +17539,7 @@
           <p:cNvPr id="12" name="">
             <a:extLst xmlns:a="http://schemas.openxmlformats.org/drawingml/2006/main">
               <a:ext uri="{FF2B5EF4-FFF2-40B4-BE49-F238E27FC236}">
-                <a16:creationId xmlns:a16="http://schemas.microsoft.com/office/drawing/2014/main" id="{21F33777-2D51-48BB-836F-BBD305949B82}"/>
+                <a16:creationId xmlns:a16="http://schemas.microsoft.com/office/drawing/2014/main" id="{DF84CA6A-9A04-4CC1-BE87-D598526B0467}"/>
               </a:ext>
             </a:extLst>
           </p:cNvPr>
@@ -17410,7 +17576,7 @@
           <p:nvPr/>
         </p:nvPicPr>
         <p:blipFill>
-          <a:blip xmlns:r="http://schemas.openxmlformats.org/officeDocument/2006/relationships" xmlns:a="http://schemas.openxmlformats.org/drawingml/2006/main" r:embed="Rb00e914a3e8e44c3"/>
+          <a:blip xmlns:r="http://schemas.openxmlformats.org/officeDocument/2006/relationships" xmlns:a="http://schemas.openxmlformats.org/drawingml/2006/main" r:embed="R679badd0e42a4f05"/>
           <a:stretch xmlns:a="http://schemas.openxmlformats.org/drawingml/2006/main"/>
         </p:blipFill>
         <p:spPr>
@@ -17428,7 +17594,7 @@
           <p:cNvPr id="14" name="">
             <a:extLst xmlns:a="http://schemas.openxmlformats.org/drawingml/2006/main">
               <a:ext uri="{FF2B5EF4-FFF2-40B4-BE49-F238E27FC236}">
-                <a16:creationId xmlns:a16="http://schemas.microsoft.com/office/drawing/2014/main" id="{817AC87A-C23A-4AA0-9DA9-9D8EBFA128C1}"/>
+                <a16:creationId xmlns:a16="http://schemas.microsoft.com/office/drawing/2014/main" id="{21CE309E-9552-4423-9CD3-B245A3595D56}"/>
               </a:ext>
             </a:extLst>
           </p:cNvPr>
@@ -17461,7 +17627,7 @@
           <p:cNvPr id="15" name="">
             <a:extLst xmlns:a="http://schemas.openxmlformats.org/drawingml/2006/main">
               <a:ext uri="{FF2B5EF4-FFF2-40B4-BE49-F238E27FC236}">
-                <a16:creationId xmlns:a16="http://schemas.microsoft.com/office/drawing/2014/main" id="{CF9EF1C5-0C48-47DF-B430-89AFAFAC288A}"/>
+                <a16:creationId xmlns:a16="http://schemas.microsoft.com/office/drawing/2014/main" id="{2B356754-2FDF-47F2-AD93-AE1C297BBA20}"/>
               </a:ext>
             </a:extLst>
           </p:cNvPr>
@@ -17525,7 +17691,7 @@
           <p:cNvPr id="16" name="">
             <a:extLst xmlns:a="http://schemas.openxmlformats.org/drawingml/2006/main">
               <a:ext uri="{FF2B5EF4-FFF2-40B4-BE49-F238E27FC236}">
-                <a16:creationId xmlns:a16="http://schemas.microsoft.com/office/drawing/2014/main" id="{5D0D196F-8C03-414C-A6AE-9B9246D787DD}"/>
+                <a16:creationId xmlns:a16="http://schemas.microsoft.com/office/drawing/2014/main" id="{46B0F7B5-18ED-4D01-B9A9-7A7011F60BC9}"/>
               </a:ext>
             </a:extLst>
           </p:cNvPr>
@@ -17681,7 +17847,7 @@
           <p:cNvPr id="17" name="">
             <a:extLst xmlns:a="http://schemas.openxmlformats.org/drawingml/2006/main">
               <a:ext uri="{FF2B5EF4-FFF2-40B4-BE49-F238E27FC236}">
-                <a16:creationId xmlns:a16="http://schemas.microsoft.com/office/drawing/2014/main" id="{6EE1EA9A-880C-46EA-B180-66032087208D}"/>
+                <a16:creationId xmlns:a16="http://schemas.microsoft.com/office/drawing/2014/main" id="{D54C066C-7C42-42B6-8A64-E76D0531F4D6}"/>
               </a:ext>
             </a:extLst>
           </p:cNvPr>
@@ -17714,7 +17880,7 @@
           <p:cNvPr id="18" name="">
             <a:extLst xmlns:a="http://schemas.openxmlformats.org/drawingml/2006/main">
               <a:ext uri="{FF2B5EF4-FFF2-40B4-BE49-F238E27FC236}">
-                <a16:creationId xmlns:a16="http://schemas.microsoft.com/office/drawing/2014/main" id="{A255800F-152C-45C0-B149-6A1A22A398A5}"/>
+                <a16:creationId xmlns:a16="http://schemas.microsoft.com/office/drawing/2014/main" id="{CE10C790-80F0-49EB-BD96-54D60015F57C}"/>
               </a:ext>
             </a:extLst>
           </p:cNvPr>
@@ -17778,7 +17944,7 @@
           <p:cNvPr id="19" name="">
             <a:extLst xmlns:a="http://schemas.openxmlformats.org/drawingml/2006/main">
               <a:ext uri="{FF2B5EF4-FFF2-40B4-BE49-F238E27FC236}">
-                <a16:creationId xmlns:a16="http://schemas.microsoft.com/office/drawing/2014/main" id="{F29BE8FC-761D-4D65-910E-9E65BCFF6682}"/>
+                <a16:creationId xmlns:a16="http://schemas.microsoft.com/office/drawing/2014/main" id="{095C9315-5077-4E92-81F6-D4DF63F5B3E1}"/>
               </a:ext>
             </a:extLst>
           </p:cNvPr>
@@ -17911,7 +18077,7 @@
           <p:cNvPr id="20" name="">
             <a:extLst xmlns:a="http://schemas.openxmlformats.org/drawingml/2006/main">
               <a:ext uri="{FF2B5EF4-FFF2-40B4-BE49-F238E27FC236}">
-                <a16:creationId xmlns:a16="http://schemas.microsoft.com/office/drawing/2014/main" id="{1E3192C2-2AC8-4426-A9A4-A6E243EEFDDC}"/>
+                <a16:creationId xmlns:a16="http://schemas.microsoft.com/office/drawing/2014/main" id="{371148BD-3E1C-48A0-94CE-DDAF3DA86848}"/>
               </a:ext>
             </a:extLst>
           </p:cNvPr>
@@ -17944,7 +18110,7 @@
           <p:cNvPr id="21" name="">
             <a:extLst xmlns:a="http://schemas.openxmlformats.org/drawingml/2006/main">
               <a:ext uri="{FF2B5EF4-FFF2-40B4-BE49-F238E27FC236}">
-                <a16:creationId xmlns:a16="http://schemas.microsoft.com/office/drawing/2014/main" id="{EEA99073-2F72-4E3C-BCE7-63AB0BE77B84}"/>
+                <a16:creationId xmlns:a16="http://schemas.microsoft.com/office/drawing/2014/main" id="{34276067-72B6-4CF3-8EC2-A4F93689C20A}"/>
               </a:ext>
             </a:extLst>
           </p:cNvPr>
@@ -18008,7 +18174,7 @@
           <p:cNvPr id="22" name="">
             <a:extLst xmlns:a="http://schemas.openxmlformats.org/drawingml/2006/main">
               <a:ext uri="{FF2B5EF4-FFF2-40B4-BE49-F238E27FC236}">
-                <a16:creationId xmlns:a16="http://schemas.microsoft.com/office/drawing/2014/main" id="{BF6DC528-60CD-4189-8858-BC7AF56CDD3E}"/>
+                <a16:creationId xmlns:a16="http://schemas.microsoft.com/office/drawing/2014/main" id="{290CD189-951F-401F-A041-349933D3551A}"/>
               </a:ext>
             </a:extLst>
           </p:cNvPr>
@@ -18192,7 +18358,7 @@
           <p:cNvPr id="23" name="">
             <a:extLst xmlns:a="http://schemas.openxmlformats.org/drawingml/2006/main">
               <a:ext uri="{FF2B5EF4-FFF2-40B4-BE49-F238E27FC236}">
-                <a16:creationId xmlns:a16="http://schemas.microsoft.com/office/drawing/2014/main" id="{6FD02A5F-F4F5-4210-983B-157B6603BC47}"/>
+                <a16:creationId xmlns:a16="http://schemas.microsoft.com/office/drawing/2014/main" id="{242CC186-0924-4861-AD2C-8D767BBB6681}"/>
               </a:ext>
             </a:extLst>
           </p:cNvPr>
@@ -18225,7 +18391,7 @@
           <p:cNvPr id="24" name="">
             <a:extLst xmlns:a="http://schemas.openxmlformats.org/drawingml/2006/main">
               <a:ext uri="{FF2B5EF4-FFF2-40B4-BE49-F238E27FC236}">
-                <a16:creationId xmlns:a16="http://schemas.microsoft.com/office/drawing/2014/main" id="{A4A4140F-63D4-45D9-A23B-D9CE34D0D570}"/>
+                <a16:creationId xmlns:a16="http://schemas.microsoft.com/office/drawing/2014/main" id="{43FCAB77-E0AA-474F-B4D5-A84D7E83E84A}"/>
               </a:ext>
             </a:extLst>
           </p:cNvPr>
@@ -18289,7 +18455,7 @@
           <p:cNvPr id="25" name="">
             <a:extLst xmlns:a="http://schemas.openxmlformats.org/drawingml/2006/main">
               <a:ext uri="{FF2B5EF4-FFF2-40B4-BE49-F238E27FC236}">
-                <a16:creationId xmlns:a16="http://schemas.microsoft.com/office/drawing/2014/main" id="{5AD1DC5B-4B5A-400C-A6AC-FFD8046D41A0}"/>
+                <a16:creationId xmlns:a16="http://schemas.microsoft.com/office/drawing/2014/main" id="{51410F23-0F33-4AD4-B37A-7114A6E2A64B}"/>
               </a:ext>
             </a:extLst>
           </p:cNvPr>
@@ -18353,7 +18519,7 @@
           <p:cNvPr id="26" name="">
             <a:extLst xmlns:a="http://schemas.openxmlformats.org/drawingml/2006/main">
               <a:ext uri="{FF2B5EF4-FFF2-40B4-BE49-F238E27FC236}">
-                <a16:creationId xmlns:a16="http://schemas.microsoft.com/office/drawing/2014/main" id="{9D5310AF-1824-4792-A684-50C3F94C29CA}"/>
+                <a16:creationId xmlns:a16="http://schemas.microsoft.com/office/drawing/2014/main" id="{A306CD8E-76EE-44BE-8718-5A82946D7539}"/>
               </a:ext>
             </a:extLst>
           </p:cNvPr>
@@ -18415,7 +18581,7 @@
     </p:spTree>
     <p:extLst>
       <p:ext uri="{BB962C8B-B14F-4D97-AF65-F5344CB8AC3E}">
-        <p14:creationId xmlns:p14="http://schemas.microsoft.com/office/powerpoint/2010/main" val="296031744"/>
+        <p14:creationId xmlns:p14="http://schemas.microsoft.com/office/powerpoint/2010/main" val="1128734403"/>
       </p:ext>
     </p:extLst>
   </p:cSld>

</xml_diff>